<commit_message>
Refresh docs and status deck for Goal 15
</commit_message>
<xml_diff>
--- a/rtdl_status_summary.pptx
+++ b/rtdl_status_summary.pptx
@@ -3023,7 +3023,7 @@
                 <a:ea typeface="Aptos" pitchFamily="34" charset="-122"/>
                 <a:cs typeface="Aptos" pitchFamily="34" charset="-120"/>
               </a:rPr>
-              <a:t>RTDL is a real language surface for four workloads.</a:t>
+              <a:t>RTDL is a real language surface for six workloads.</a:t>
             </a:r>
             <a:endParaRPr lang="en-US" sz="1080" dirty="0"/>
           </a:p>
@@ -3069,7 +3069,7 @@
                 <a:ea typeface="Aptos" pitchFamily="34" charset="-122"/>
                 <a:cs typeface="Aptos" pitchFamily="34" charset="-120"/>
               </a:rPr>
-              <a:t>Authored examples from humans, Codex, and Gemini can be validated through the same pipeline.</a:t>
+              <a:t>A separate audited native C++ + Embree comparison slice now cross-checks deterministic lsi and pip fixtures.</a:t>
             </a:r>
             <a:endParaRPr lang="en-US" sz="1080" dirty="0"/>
           </a:p>
@@ -3719,7 +3719,7 @@
                 <a:ea typeface="Aptos" pitchFamily="34" charset="-122"/>
                 <a:cs typeface="Aptos" pitchFamily="34" charset="-120"/>
               </a:rPr>
-              <a:t>Add more geometry/query forms beyond the current RayJoin-aligned four workloads.</a:t>
+              <a:t>Add more geometry/query forms beyond the current RayJoin-aligned six-workload surface.</a:t>
             </a:r>
             <a:endParaRPr lang="en-US" sz="1080" dirty="0"/>
           </a:p>
@@ -4384,7 +4384,7 @@
                 <a:ea typeface="Aptos" pitchFamily="34" charset="-122"/>
                 <a:cs typeface="Aptos" pitchFamily="34" charset="-120"/>
               </a:rPr>
-              <a:t>GitHub and local repo should include the updated deck plus the Gemini-authored Embree example.</a:t>
+              <a:t>GitHub and local repo are in sync through Goal 15, including the native C++ + Embree comparison slice and refreshed history dashboard.</a:t>
             </a:r>
             <a:endParaRPr lang="en-US" sz="1080" dirty="0"/>
           </a:p>
@@ -4704,7 +4704,7 @@
                 <a:ea typeface="Courier New" pitchFamily="34" charset="-122"/>
                 <a:cs typeface="Courier New" pitchFamily="34" charset="-120"/>
               </a:rPr>
-              <a:t>- Four supported workloads</a:t>
+              <a:t>- Six supported workloads</a:t>
             </a:r>
             <a:endParaRPr lang="en-US" sz="980" dirty="0"/>
           </a:p>
@@ -4721,7 +4721,7 @@
                 <a:ea typeface="Courier New" pitchFamily="34" charset="-122"/>
                 <a:cs typeface="Courier New" pitchFamily="34" charset="-120"/>
               </a:rPr>
-              <a:t>- Three execution modes</a:t>
+              <a:t>- CPU + Embree runtimes plus native C++ comparison slice</a:t>
             </a:r>
             <a:endParaRPr lang="en-US" sz="980" dirty="0"/>
           </a:p>
@@ -4755,7 +4755,7 @@
                 <a:ea typeface="Courier New" pitchFamily="34" charset="-122"/>
                 <a:cs typeface="Courier New" pitchFamily="34" charset="-120"/>
               </a:rPr>
-              <a:t>- 32 passing tests</a:t>
+              <a:t>- 57 passing tests</a:t>
             </a:r>
             <a:endParaRPr lang="en-US" sz="980" dirty="0"/>
           </a:p>
@@ -4772,7 +4772,7 @@
                 <a:ea typeface="Courier New" pitchFamily="34" charset="-122"/>
                 <a:cs typeface="Courier New" pitchFamily="34" charset="-120"/>
               </a:rPr>
-              <a:t>- 8 archived review/revision rounds</a:t>
+              <a:t>- 16 archived review/revision rounds</a:t>
             </a:r>
             <a:endParaRPr lang="en-US" sz="980" dirty="0"/>
           </a:p>
@@ -8567,7 +8567,7 @@
                 <a:ea typeface="Aptos" pitchFamily="34" charset="-122"/>
                 <a:cs typeface="Aptos" pitchFamily="34" charset="-120"/>
               </a:rPr>
-              <a:t>RTDL now covers four workload shapes and includes RayJoin-aligned fixture support.</a:t>
+              <a:t>RTDL now covers six workload families and includes RayJoin-aligned fixture support.</a:t>
             </a:r>
             <a:endParaRPr lang="en-US" sz="1050" dirty="0"/>
           </a:p>
@@ -8582,7 +8582,7 @@
         <p:spPr>
           <a:xfrm>
             <a:off x="731520" y="1417320"/>
-            <a:ext cx="2606040" cy="3611880"/>
+            <a:ext cx="2606040" cy="2880360"/>
           </a:xfrm>
           <a:prstGeom prst="roundRect">
             <a:avLst>
@@ -8650,7 +8650,7 @@
         <p:spPr>
           <a:xfrm>
             <a:off x="877824" y="1801368"/>
-            <a:ext cx="2313432" cy="3118104"/>
+            <a:ext cx="2313432" cy="2386584"/>
           </a:xfrm>
           <a:prstGeom prst="rect">
             <a:avLst/>
@@ -8780,7 +8780,7 @@
         <p:spPr>
           <a:xfrm>
             <a:off x="3611880" y="1417320"/>
-            <a:ext cx="2606040" cy="3611880"/>
+            <a:ext cx="2606040" cy="2880360"/>
           </a:xfrm>
           <a:prstGeom prst="roundRect">
             <a:avLst>
@@ -8848,7 +8848,7 @@
         <p:spPr>
           <a:xfrm>
             <a:off x="3758184" y="1801368"/>
-            <a:ext cx="2313432" cy="3118104"/>
+            <a:ext cx="2313432" cy="2386584"/>
           </a:xfrm>
           <a:prstGeom prst="rect">
             <a:avLst/>
@@ -8961,7 +8961,7 @@
         <p:spPr>
           <a:xfrm>
             <a:off x="6492240" y="1417320"/>
-            <a:ext cx="2606040" cy="3611880"/>
+            <a:ext cx="2606040" cy="2880360"/>
           </a:xfrm>
           <a:prstGeom prst="roundRect">
             <a:avLst>
@@ -9029,7 +9029,7 @@
         <p:spPr>
           <a:xfrm>
             <a:off x="6638544" y="1801368"/>
-            <a:ext cx="2313432" cy="3118104"/>
+            <a:ext cx="2313432" cy="2386584"/>
           </a:xfrm>
           <a:prstGeom prst="rect">
             <a:avLst/>
@@ -9159,7 +9159,7 @@
         <p:spPr>
           <a:xfrm>
             <a:off x="9372600" y="1417320"/>
-            <a:ext cx="2103120" cy="3611880"/>
+            <a:ext cx="2103120" cy="2880360"/>
           </a:xfrm>
           <a:prstGeom prst="roundRect">
             <a:avLst>
@@ -9227,7 +9227,7 @@
         <p:spPr>
           <a:xfrm>
             <a:off x="9518904" y="1801368"/>
-            <a:ext cx="1810512" cy="3118104"/>
+            <a:ext cx="1810512" cy="2386584"/>
           </a:xfrm>
           <a:prstGeom prst="rect">
             <a:avLst/>
@@ -9322,12 +9322,12 @@
         </p:nvSpPr>
         <p:spPr>
           <a:xfrm>
-            <a:off x="731520" y="5257800"/>
-            <a:ext cx="5120640" cy="640080"/>
+            <a:off x="731520" y="4526280"/>
+            <a:ext cx="3474720" cy="1188720"/>
           </a:xfrm>
           <a:prstGeom prst="roundRect">
             <a:avLst>
-              <a:gd name="adj" fmla="val 7143"/>
+              <a:gd name="adj" fmla="val 3846"/>
             </a:avLst>
           </a:prstGeom>
           <a:solidFill>
@@ -9351,8 +9351,8 @@
         </p:nvSpPr>
         <p:spPr>
           <a:xfrm>
-            <a:off x="877824" y="5367528"/>
-            <a:ext cx="4828032" cy="219456"/>
+            <a:off x="877824" y="4636008"/>
+            <a:ext cx="3182112" cy="219456"/>
           </a:xfrm>
           <a:prstGeom prst="rect">
             <a:avLst/>
@@ -9376,7 +9376,7 @@
                 <a:ea typeface="Aptos Display" pitchFamily="34" charset="-122"/>
                 <a:cs typeface="Aptos Display" pitchFamily="34" charset="-120"/>
               </a:rPr>
-              <a:t>Dataset support</a:t>
+              <a:t>Goal 10 extensions</a:t>
             </a:r>
             <a:endParaRPr lang="en-US" sz="1400" dirty="0"/>
           </a:p>
@@ -9390,8 +9390,8 @@
         </p:nvSpPr>
         <p:spPr>
           <a:xfrm>
-            <a:off x="877824" y="5641848"/>
-            <a:ext cx="4828032" cy="146304"/>
+            <a:off x="877824" y="4910328"/>
+            <a:ext cx="3182112" cy="694944"/>
           </a:xfrm>
           <a:prstGeom prst="rect">
             <a:avLst/>
@@ -9415,7 +9415,47 @@
                 <a:ea typeface="Aptos" pitchFamily="34" charset="-122"/>
                 <a:cs typeface="Aptos" pitchFamily="34" charset="-120"/>
               </a:rPr>
-              <a:t>datasets.py parses RayJoin-style CDB chains and derives segment, polygon, and point-probe views for non-GPU validation.</a:t>
+              <a:t>segment_polygon_hitcount</a:t>
+            </a:r>
+            <a:endParaRPr lang="en-US" sz="1080" dirty="0"/>
+          </a:p>
+          <a:p>
+            <a:pPr indent="0" marL="0">
+              <a:buNone/>
+            </a:pPr>
+            <a:r>
+              <a:rPr lang="en-US" sz="1080" dirty="0">
+                <a:solidFill>
+                  <a:srgbClr val="102032"/>
+                </a:solidFill>
+                <a:latin typeface="Aptos" pitchFamily="34" charset="0"/>
+                <a:ea typeface="Aptos" pitchFamily="34" charset="-122"/>
+                <a:cs typeface="Aptos" pitchFamily="34" charset="-120"/>
+              </a:rPr>
+              <a:t>point_nearest_segment</a:t>
+            </a:r>
+            <a:endParaRPr lang="en-US" sz="1080" dirty="0"/>
+          </a:p>
+          <a:p>
+            <a:pPr indent="0" marL="0">
+              <a:buNone/>
+            </a:pPr>
+            <a:endParaRPr lang="en-US" sz="1080" dirty="0"/>
+          </a:p>
+          <a:p>
+            <a:pPr indent="0" marL="0">
+              <a:buNone/>
+            </a:pPr>
+            <a:r>
+              <a:rPr lang="en-US" sz="1080" dirty="0">
+                <a:solidFill>
+                  <a:srgbClr val="102032"/>
+                </a:solidFill>
+                <a:latin typeface="Aptos" pitchFamily="34" charset="0"/>
+                <a:ea typeface="Aptos" pitchFamily="34" charset="-122"/>
+                <a:cs typeface="Aptos" pitchFamily="34" charset="-120"/>
+              </a:rPr>
+              <a:t>These execute through audited native_loop local cases.</a:t>
             </a:r>
             <a:endParaRPr lang="en-US" sz="1080" dirty="0"/>
           </a:p>
@@ -9429,12 +9469,119 @@
         </p:nvSpPr>
         <p:spPr>
           <a:xfrm>
-            <a:off x="6080760" y="5257800"/>
-            <a:ext cx="5349240" cy="640080"/>
+            <a:off x="4434840" y="4526280"/>
+            <a:ext cx="3383280" cy="1188720"/>
           </a:xfrm>
           <a:prstGeom prst="roundRect">
             <a:avLst>
-              <a:gd name="adj" fmla="val 7143"/>
+              <a:gd name="adj" fmla="val 3846"/>
+            </a:avLst>
+          </a:prstGeom>
+          <a:solidFill>
+            <a:srgbClr val="FFFFFF"/>
+          </a:solidFill>
+          <a:ln w="12700">
+            <a:solidFill>
+              <a:srgbClr val="FFFFFF">
+                <a:alpha val="0"/>
+              </a:srgbClr>
+            </a:solidFill>
+            <a:prstDash val="solid"/>
+          </a:ln>
+        </p:spPr>
+      </p:sp>
+      <p:sp>
+        <p:nvSpPr>
+          <p:cNvPr id="22" name="Text 20"/>
+          <p:cNvSpPr/>
+          <p:nvPr/>
+        </p:nvSpPr>
+        <p:spPr>
+          <a:xfrm>
+            <a:off x="4581144" y="4636008"/>
+            <a:ext cx="3090672" cy="219456"/>
+          </a:xfrm>
+          <a:prstGeom prst="rect">
+            <a:avLst/>
+          </a:prstGeom>
+          <a:noFill/>
+          <a:ln/>
+        </p:spPr>
+        <p:txBody>
+          <a:bodyPr wrap="square" lIns="0" tIns="0" rIns="0" bIns="0" rtlCol="0" anchor="ctr"/>
+          <a:lstStyle/>
+          <a:p>
+            <a:pPr indent="0" marL="0">
+              <a:buNone/>
+            </a:pPr>
+            <a:r>
+              <a:rPr lang="en-US" sz="1400" b="1" dirty="0">
+                <a:solidFill>
+                  <a:srgbClr val="102032"/>
+                </a:solidFill>
+                <a:latin typeface="Aptos Display" pitchFamily="34" charset="0"/>
+                <a:ea typeface="Aptos Display" pitchFamily="34" charset="-122"/>
+                <a:cs typeface="Aptos Display" pitchFamily="34" charset="-120"/>
+              </a:rPr>
+              <a:t>Dataset support</a:t>
+            </a:r>
+            <a:endParaRPr lang="en-US" sz="1400" dirty="0"/>
+          </a:p>
+        </p:txBody>
+      </p:sp>
+      <p:sp>
+        <p:nvSpPr>
+          <p:cNvPr id="23" name="Text 21"/>
+          <p:cNvSpPr/>
+          <p:nvPr/>
+        </p:nvSpPr>
+        <p:spPr>
+          <a:xfrm>
+            <a:off x="4581144" y="4910328"/>
+            <a:ext cx="3090672" cy="694944"/>
+          </a:xfrm>
+          <a:prstGeom prst="rect">
+            <a:avLst/>
+          </a:prstGeom>
+          <a:noFill/>
+          <a:ln/>
+        </p:spPr>
+        <p:txBody>
+          <a:bodyPr wrap="square" lIns="0" tIns="0" rIns="0" bIns="0" rtlCol="0" anchor="t"/>
+          <a:lstStyle/>
+          <a:p>
+            <a:pPr indent="0" marL="0">
+              <a:buNone/>
+            </a:pPr>
+            <a:r>
+              <a:rPr lang="en-US" sz="1080" dirty="0">
+                <a:solidFill>
+                  <a:srgbClr val="102032"/>
+                </a:solidFill>
+                <a:latin typeface="Aptos" pitchFamily="34" charset="0"/>
+                <a:ea typeface="Aptos" pitchFamily="34" charset="-122"/>
+                <a:cs typeface="Aptos" pitchFamily="34" charset="-120"/>
+              </a:rPr>
+              <a:t>datasets.py parses RayJoin-style CDB chains and derives segment, polygon, and point-probe views for non-GPU validation.</a:t>
+            </a:r>
+            <a:endParaRPr lang="en-US" sz="1080" dirty="0"/>
+          </a:p>
+        </p:txBody>
+      </p:sp>
+      <p:sp>
+        <p:nvSpPr>
+          <p:cNvPr id="24" name="Shape 22"/>
+          <p:cNvSpPr/>
+          <p:nvPr/>
+        </p:nvSpPr>
+        <p:spPr>
+          <a:xfrm>
+            <a:off x="8046720" y="4526280"/>
+            <a:ext cx="3383280" cy="1188720"/>
+          </a:xfrm>
+          <a:prstGeom prst="roundRect">
+            <a:avLst>
+              <a:gd name="adj" fmla="val 3846"/>
             </a:avLst>
           </a:prstGeom>
           <a:solidFill>
@@ -9452,14 +9599,14 @@
       </p:sp>
       <p:sp>
         <p:nvSpPr>
-          <p:cNvPr id="22" name="Text 20"/>
-          <p:cNvSpPr/>
-          <p:nvPr/>
-        </p:nvSpPr>
-        <p:spPr>
-          <a:xfrm>
-            <a:off x="6227064" y="5367528"/>
-            <a:ext cx="5056632" cy="219456"/>
+          <p:cNvPr id="25" name="Text 23"/>
+          <p:cNvSpPr/>
+          <p:nvPr/>
+        </p:nvSpPr>
+        <p:spPr>
+          <a:xfrm>
+            <a:off x="8193024" y="4636008"/>
+            <a:ext cx="3090672" cy="219456"/>
           </a:xfrm>
           <a:prstGeom prst="rect">
             <a:avLst/>
@@ -9491,14 +9638,14 @@
       </p:sp>
       <p:sp>
         <p:nvSpPr>
-          <p:cNvPr id="23" name="Text 21"/>
-          <p:cNvSpPr/>
-          <p:nvPr/>
-        </p:nvSpPr>
-        <p:spPr>
-          <a:xfrm>
-            <a:off x="6227064" y="5641848"/>
-            <a:ext cx="5056632" cy="146304"/>
+          <p:cNvPr id="26" name="Text 24"/>
+          <p:cNvSpPr/>
+          <p:nvPr/>
+        </p:nvSpPr>
+        <p:spPr>
+          <a:xfrm>
+            <a:off x="8193024" y="4910328"/>
+            <a:ext cx="3090672" cy="694944"/>
           </a:xfrm>
           <a:prstGeom prst="rect">
             <a:avLst/>
@@ -9522,15 +9669,15 @@
                 <a:ea typeface="Aptos" pitchFamily="34" charset="-122"/>
                 <a:cs typeface="Aptos" pitchFamily="34" charset="-120"/>
               </a:rPr>
-              <a:t>tests/fixtures/rayjoin/ plus authored synthetic examples for ray queries and Embree demos.</a:t>
-            </a:r>
-            <a:endParaRPr lang="en-US" sz="1080" dirty="0"/>
-          </a:p>
-        </p:txBody>
-      </p:sp>
-      <p:sp>
-        <p:nvSpPr>
-          <p:cNvPr id="24" name="Text 22"/>
+              <a:t>tests/fixtures/rayjoin/ plus authored synthetic examples, Section 5.6 generators, and Embree demos.</a:t>
+            </a:r>
+            <a:endParaRPr lang="en-US" sz="1080" dirty="0"/>
+          </a:p>
+        </p:txBody>
+      </p:sp>
+      <p:sp>
+        <p:nvSpPr>
+          <p:cNvPr id="27" name="Text 25"/>
           <p:cNvSpPr/>
           <p:nvPr/>
         </p:nvSpPr>
@@ -11253,7 +11400,7 @@
                 <a:ea typeface="Aptos Display" pitchFamily="34" charset="-122"/>
                 <a:cs typeface="Aptos Display" pitchFamily="34" charset="-120"/>
               </a:rPr>
-              <a:t>Goals 6-7</a:t>
+              <a:t>Goals 6-15</a:t>
             </a:r>
             <a:endParaRPr lang="en-US" sz="1400" dirty="0"/>
           </a:p>
@@ -11292,30 +11439,7 @@
                 <a:ea typeface="Aptos" pitchFamily="34" charset="-122"/>
                 <a:cs typeface="Aptos" pitchFamily="34" charset="-120"/>
               </a:rPr>
-              <a:t>CPU simulator and Embree backend.</a:t>
-            </a:r>
-            <a:endParaRPr lang="en-US" sz="1080" dirty="0"/>
-          </a:p>
-          <a:p>
-            <a:pPr indent="0" marL="0">
-              <a:buNone/>
-            </a:pPr>
-            <a:endParaRPr lang="en-US" sz="1080" dirty="0"/>
-          </a:p>
-          <a:p>
-            <a:pPr indent="0" marL="0">
-              <a:buNone/>
-            </a:pPr>
-            <a:r>
-              <a:rPr lang="en-US" sz="1080" dirty="0">
-                <a:solidFill>
-                  <a:srgbClr val="102032"/>
-                </a:solidFill>
-                <a:latin typeface="Aptos" pitchFamily="34" charset="0"/>
-                <a:ea typeface="Aptos" pitchFamily="34" charset="-122"/>
-                <a:cs typeface="Aptos" pitchFamily="34" charset="-120"/>
-              </a:rPr>
-              <a:t>Outcome: RTDL programs now return real results locally.</a:t>
+              <a:t>CPU simulator, Embree backend, evaluation/reporting, trust audit, paper-analogue work, and native C++ comparison.</a:t>
             </a:r>
             <a:endParaRPr lang="en-US" sz="1080" dirty="0"/>
           </a:p>
@@ -11422,7 +11546,7 @@
                 <a:ea typeface="Aptos" pitchFamily="34" charset="-122"/>
                 <a:cs typeface="Aptos" pitchFamily="34" charset="-120"/>
               </a:rPr>
-              <a:t>8 rounds</a:t>
+              <a:t>16 rounds</a:t>
             </a:r>
             <a:endParaRPr lang="en-US" sz="1020" dirty="0"/>
           </a:p>
@@ -11439,7 +11563,7 @@
                 <a:ea typeface="Aptos" pitchFamily="34" charset="-122"/>
                 <a:cs typeface="Aptos" pitchFamily="34" charset="-120"/>
               </a:rPr>
-              <a:t>29 external reports</a:t>
+              <a:t>44 external reports</a:t>
             </a:r>
             <a:endParaRPr lang="en-US" sz="1020" dirty="0"/>
           </a:p>
@@ -11456,7 +11580,7 @@
                 <a:ea typeface="Aptos" pitchFamily="34" charset="-122"/>
                 <a:cs typeface="Aptos" pitchFamily="34" charset="-120"/>
               </a:rPr>
-              <a:t>156 archived project snapshots</a:t>
+              <a:t>251 archived project snapshots</a:t>
             </a:r>
             <a:endParaRPr lang="en-US" sz="1020" dirty="0"/>
           </a:p>

</xml_diff>

<commit_message>
Document AI collaboration workflow
</commit_message>
<xml_diff>
--- a/rtdl_status_summary.pptx
+++ b/rtdl_status_summary.pptx
@@ -17,9 +17,11 @@
     <p:sldId id="265" r:id="rId11"/>
     <p:sldId id="266" r:id="rId12"/>
     <p:sldId id="267" r:id="rId13"/>
+    <p:sldId id="268" r:id="rId14"/>
+    <p:sldId id="269" r:id="rId15"/>
   </p:sldIdLst>
   <p:notesMasterIdLst>
-    <p:notesMasterId r:id="rId14"/>
+    <p:notesMasterId r:id="rId16"/>
   </p:notesMasterIdLst>
   <p:sldSz cx="12192000" cy="6858000"/>
   <p:notesSz cx="6858000" cy="12192000"/>
@@ -801,6 +803,182 @@
             <a:fld id="{F7021451-1387-4CA6-816F-3879F97B5CBC}" type="slidenum">
               <a:rPr lang="en-US"/>
               <a:t>12</a:t>
+            </a:fld>
+            <a:endParaRPr lang="en-US"/>
+          </a:p>
+        </p:txBody>
+      </p:sp>
+    </p:spTree>
+    <p:extLst>
+      <p:ext uri="{BB962C8B-B14F-4D97-AF65-F5344CB8AC3E}">
+        <p14:creationId xmlns:p14="http://schemas.microsoft.com/office/powerpoint/2010/main" val="1024086991"/>
+      </p:ext>
+    </p:extLst>
+  </p:cSld>
+  <p:clrMapOvr>
+    <a:masterClrMapping/>
+  </p:clrMapOvr>
+</p:notes>
+</file>
+
+<file path=ppt/notesSlides/notesSlide13.xml><?xml version="1.0" encoding="utf-8"?>
+<p:notes xmlns:a="http://schemas.openxmlformats.org/drawingml/2006/main" xmlns:r="http://schemas.openxmlformats.org/officeDocument/2006/relationships" xmlns:p="http://schemas.openxmlformats.org/presentationml/2006/main">
+  <p:cSld>
+    <p:spTree>
+      <p:nvGrpSpPr>
+        <p:cNvPr id="1" name=""/>
+        <p:cNvGrpSpPr/>
+        <p:nvPr/>
+      </p:nvGrpSpPr>
+      <p:grpSpPr>
+        <a:xfrm>
+          <a:off x="0" y="0"/>
+          <a:ext cx="0" cy="0"/>
+          <a:chOff x="0" y="0"/>
+          <a:chExt cx="0" cy="0"/>
+        </a:xfrm>
+      </p:grpSpPr>
+      <p:sp>
+        <p:nvSpPr>
+          <p:cNvPr id="2" name="Slide Image Placeholder 1"/>
+          <p:cNvSpPr>
+            <a:spLocks noGrp="1" noRot="1" noChangeAspect="1"/>
+          </p:cNvSpPr>
+          <p:nvPr>
+            <p:ph type="sldImg"/>
+          </p:nvPr>
+        </p:nvSpPr>
+        <p:spPr/>
+      </p:sp>
+      <p:sp>
+        <p:nvSpPr>
+          <p:cNvPr id="3" name="Notes Placeholder 2"/>
+          <p:cNvSpPr>
+            <a:spLocks noGrp="1"/>
+          </p:cNvSpPr>
+          <p:nvPr>
+            <p:ph type="body" idx="1"/>
+          </p:nvPr>
+        </p:nvSpPr>
+        <p:spPr/>
+        <p:txBody>
+          <a:bodyPr/>
+          <a:lstStyle/>
+          <a:p>
+            <a:r>
+              <a:rPr lang="en-US" dirty="0"/>
+              <a:t/>
+            </a:r>
+            <a:endParaRPr lang="en-US" dirty="0"/>
+          </a:p>
+        </p:txBody>
+      </p:sp>
+      <p:sp>
+        <p:nvSpPr>
+          <p:cNvPr id="4" name="Slide Number Placeholder 3"/>
+          <p:cNvSpPr>
+            <a:spLocks noGrp="1"/>
+          </p:cNvSpPr>
+          <p:nvPr>
+            <p:ph type="sldNum" sz="quarter" idx="10"/>
+          </p:nvPr>
+        </p:nvSpPr>
+        <p:spPr/>
+        <p:txBody>
+          <a:bodyPr/>
+          <a:lstStyle/>
+          <a:p>
+            <a:fld id="{F7021451-1387-4CA6-816F-3879F97B5CBC}" type="slidenum">
+              <a:rPr lang="en-US"/>
+              <a:t>13</a:t>
+            </a:fld>
+            <a:endParaRPr lang="en-US"/>
+          </a:p>
+        </p:txBody>
+      </p:sp>
+    </p:spTree>
+    <p:extLst>
+      <p:ext uri="{BB962C8B-B14F-4D97-AF65-F5344CB8AC3E}">
+        <p14:creationId xmlns:p14="http://schemas.microsoft.com/office/powerpoint/2010/main" val="1024086991"/>
+      </p:ext>
+    </p:extLst>
+  </p:cSld>
+  <p:clrMapOvr>
+    <a:masterClrMapping/>
+  </p:clrMapOvr>
+</p:notes>
+</file>
+
+<file path=ppt/notesSlides/notesSlide14.xml><?xml version="1.0" encoding="utf-8"?>
+<p:notes xmlns:a="http://schemas.openxmlformats.org/drawingml/2006/main" xmlns:r="http://schemas.openxmlformats.org/officeDocument/2006/relationships" xmlns:p="http://schemas.openxmlformats.org/presentationml/2006/main">
+  <p:cSld>
+    <p:spTree>
+      <p:nvGrpSpPr>
+        <p:cNvPr id="1" name=""/>
+        <p:cNvGrpSpPr/>
+        <p:nvPr/>
+      </p:nvGrpSpPr>
+      <p:grpSpPr>
+        <a:xfrm>
+          <a:off x="0" y="0"/>
+          <a:ext cx="0" cy="0"/>
+          <a:chOff x="0" y="0"/>
+          <a:chExt cx="0" cy="0"/>
+        </a:xfrm>
+      </p:grpSpPr>
+      <p:sp>
+        <p:nvSpPr>
+          <p:cNvPr id="2" name="Slide Image Placeholder 1"/>
+          <p:cNvSpPr>
+            <a:spLocks noGrp="1" noRot="1" noChangeAspect="1"/>
+          </p:cNvSpPr>
+          <p:nvPr>
+            <p:ph type="sldImg"/>
+          </p:nvPr>
+        </p:nvSpPr>
+        <p:spPr/>
+      </p:sp>
+      <p:sp>
+        <p:nvSpPr>
+          <p:cNvPr id="3" name="Notes Placeholder 2"/>
+          <p:cNvSpPr>
+            <a:spLocks noGrp="1"/>
+          </p:cNvSpPr>
+          <p:nvPr>
+            <p:ph type="body" idx="1"/>
+          </p:nvPr>
+        </p:nvSpPr>
+        <p:spPr/>
+        <p:txBody>
+          <a:bodyPr/>
+          <a:lstStyle/>
+          <a:p>
+            <a:r>
+              <a:rPr lang="en-US" dirty="0"/>
+              <a:t/>
+            </a:r>
+            <a:endParaRPr lang="en-US" dirty="0"/>
+          </a:p>
+        </p:txBody>
+      </p:sp>
+      <p:sp>
+        <p:nvSpPr>
+          <p:cNvPr id="4" name="Slide Number Placeholder 3"/>
+          <p:cNvSpPr>
+            <a:spLocks noGrp="1"/>
+          </p:cNvSpPr>
+          <p:nvPr>
+            <p:ph type="sldNum" sz="quarter" idx="10"/>
+          </p:nvPr>
+        </p:nvSpPr>
+        <p:spPr/>
+        <p:txBody>
+          <a:bodyPr/>
+          <a:lstStyle/>
+          <a:p>
+            <a:fld id="{F7021451-1387-4CA6-816F-3879F97B5CBC}" type="slidenum">
+              <a:rPr lang="en-US"/>
+              <a:t>14</a:t>
             </a:fld>
             <a:endParaRPr lang="en-US"/>
           </a:p>
@@ -2752,7 +2930,7 @@
                 <a:ea typeface="Aptos" pitchFamily="34" charset="-122"/>
                 <a:cs typeface="Aptos" pitchFamily="34" charset="-120"/>
               </a:rPr>
-              <a:t>RTDL summary · 1/12</a:t>
+              <a:t>RTDL summary · 1/14</a:t>
             </a:r>
             <a:endParaRPr lang="en-US" sz="850" dirty="0"/>
           </a:p>
@@ -3307,7 +3485,7 @@
                 <a:ea typeface="Aptos" pitchFamily="34" charset="-122"/>
                 <a:cs typeface="Aptos" pitchFamily="34" charset="-120"/>
               </a:rPr>
-              <a:t>RTDL summary · 10/12</a:t>
+              <a:t>RTDL summary · 10/14</a:t>
             </a:r>
             <a:endParaRPr lang="en-US" sz="850" dirty="0"/>
           </a:p>
@@ -4113,7 +4291,7 @@
                 <a:ea typeface="Aptos" pitchFamily="34" charset="-122"/>
                 <a:cs typeface="Aptos" pitchFamily="34" charset="-120"/>
               </a:rPr>
-              <a:t>RTDL summary · 11/12</a:t>
+              <a:t>RTDL summary · 11/14</a:t>
             </a:r>
             <a:endParaRPr lang="en-US" sz="850" dirty="0"/>
           </a:p>
@@ -4828,7 +5006,1548 @@
                 <a:ea typeface="Aptos" pitchFamily="34" charset="-122"/>
                 <a:cs typeface="Aptos" pitchFamily="34" charset="-120"/>
               </a:rPr>
-              <a:t>RTDL summary · 12/12</a:t>
+              <a:t>RTDL summary · 12/14</a:t>
+            </a:r>
+            <a:endParaRPr lang="en-US" sz="850" dirty="0"/>
+          </a:p>
+        </p:txBody>
+      </p:sp>
+    </p:spTree>
+  </p:cSld>
+  <p:clrMapOvr>
+    <a:masterClrMapping/>
+  </p:clrMapOvr>
+</p:sld>
+</file>
+
+<file path=ppt/slides/slide13.xml><?xml version="1.0" encoding="utf-8"?>
+<p:sld xmlns:a="http://schemas.openxmlformats.org/drawingml/2006/main" xmlns:r="http://schemas.openxmlformats.org/officeDocument/2006/relationships" xmlns:p="http://schemas.openxmlformats.org/presentationml/2006/main">
+  <p:cSld name="Slide 13">
+    <p:bg>
+      <p:bgPr>
+        <a:solidFill>
+          <a:srgbClr val="F7F4EE"/>
+        </a:solidFill>
+      </p:bgPr>
+    </p:bg>
+    <p:spTree>
+      <p:nvGrpSpPr>
+        <p:cNvPr id="1" name=""/>
+        <p:cNvGrpSpPr/>
+        <p:nvPr/>
+      </p:nvGrpSpPr>
+      <p:grpSpPr>
+        <a:xfrm>
+          <a:off x="0" y="0"/>
+          <a:ext cx="0" cy="0"/>
+          <a:chOff x="0" y="0"/>
+          <a:chExt cx="0" cy="0"/>
+        </a:xfrm>
+      </p:grpSpPr>
+      <p:sp>
+        <p:nvSpPr>
+          <p:cNvPr id="2" name="Shape 0"/>
+          <p:cNvSpPr/>
+          <p:nvPr/>
+        </p:nvSpPr>
+        <p:spPr>
+          <a:xfrm>
+            <a:off x="0" y="0"/>
+            <a:ext cx="12191695" cy="310896"/>
+          </a:xfrm>
+          <a:prstGeom prst="rect">
+            <a:avLst/>
+          </a:prstGeom>
+          <a:solidFill>
+            <a:srgbClr val="1E7D77"/>
+          </a:solidFill>
+          <a:ln w="12700">
+            <a:solidFill>
+              <a:srgbClr val="1E7D77">
+                <a:alpha val="0"/>
+              </a:srgbClr>
+            </a:solidFill>
+            <a:prstDash val="solid"/>
+          </a:ln>
+        </p:spPr>
+      </p:sp>
+      <p:sp>
+        <p:nvSpPr>
+          <p:cNvPr id="3" name="Shape 1"/>
+          <p:cNvSpPr/>
+          <p:nvPr/>
+        </p:nvSpPr>
+        <p:spPr>
+          <a:xfrm>
+            <a:off x="0" y="6528816"/>
+            <a:ext cx="12191695" cy="329184"/>
+          </a:xfrm>
+          <a:prstGeom prst="rect">
+            <a:avLst/>
+          </a:prstGeom>
+          <a:solidFill>
+            <a:srgbClr val="0D1720"/>
+          </a:solidFill>
+          <a:ln w="12700">
+            <a:solidFill>
+              <a:srgbClr val="0D1720">
+                <a:alpha val="0"/>
+              </a:srgbClr>
+            </a:solidFill>
+            <a:prstDash val="solid"/>
+          </a:ln>
+        </p:spPr>
+      </p:sp>
+      <p:sp>
+        <p:nvSpPr>
+          <p:cNvPr id="4" name="Text 2"/>
+          <p:cNvSpPr/>
+          <p:nvPr/>
+        </p:nvSpPr>
+        <p:spPr>
+          <a:xfrm>
+            <a:off x="640080" y="457200"/>
+            <a:ext cx="8595360" cy="420624"/>
+          </a:xfrm>
+          <a:prstGeom prst="rect">
+            <a:avLst/>
+          </a:prstGeom>
+          <a:noFill/>
+          <a:ln/>
+        </p:spPr>
+        <p:txBody>
+          <a:bodyPr wrap="square" lIns="0" tIns="0" rIns="0" bIns="0" rtlCol="0" anchor="ctr"/>
+          <a:lstStyle/>
+          <a:p>
+            <a:pPr indent="0" marL="0">
+              <a:buNone/>
+            </a:pPr>
+            <a:r>
+              <a:rPr lang="en-US" sz="2400" b="1" dirty="0">
+                <a:solidFill>
+                  <a:srgbClr val="102032"/>
+                </a:solidFill>
+                <a:latin typeface="Aptos Display" pitchFamily="34" charset="0"/>
+                <a:ea typeface="Aptos Display" pitchFamily="34" charset="-122"/>
+                <a:cs typeface="Aptos Display" pitchFamily="34" charset="-120"/>
+              </a:rPr>
+              <a:t>How the AIs Work Together</a:t>
+            </a:r>
+            <a:endParaRPr lang="en-US" sz="2400" dirty="0"/>
+          </a:p>
+        </p:txBody>
+      </p:sp>
+      <p:sp>
+        <p:nvSpPr>
+          <p:cNvPr id="5" name="Text 3"/>
+          <p:cNvSpPr/>
+          <p:nvPr/>
+        </p:nvSpPr>
+        <p:spPr>
+          <a:xfrm>
+            <a:off x="658368" y="932688"/>
+            <a:ext cx="9875520" cy="274320"/>
+          </a:xfrm>
+          <a:prstGeom prst="rect">
+            <a:avLst/>
+          </a:prstGeom>
+          <a:noFill/>
+          <a:ln/>
+        </p:spPr>
+        <p:txBody>
+          <a:bodyPr wrap="square" lIns="0" tIns="0" rIns="0" bIns="0" rtlCol="0" anchor="ctr"/>
+          <a:lstStyle/>
+          <a:p>
+            <a:pPr indent="0" marL="0">
+              <a:buNone/>
+            </a:pPr>
+            <a:r>
+              <a:rPr lang="en-US" sz="1050" dirty="0">
+                <a:solidFill>
+                  <a:srgbClr val="5C6B77"/>
+                </a:solidFill>
+                <a:latin typeface="Aptos" pitchFamily="34" charset="0"/>
+                <a:ea typeface="Aptos" pitchFamily="34" charset="-122"/>
+                <a:cs typeface="Aptos" pitchFamily="34" charset="-120"/>
+              </a:rPr>
+              <a:t>RTDL uses a staged multi-agent loop instead of a one-pass coding workflow.</a:t>
+            </a:r>
+            <a:endParaRPr lang="en-US" sz="1050" dirty="0"/>
+          </a:p>
+        </p:txBody>
+      </p:sp>
+      <p:sp>
+        <p:nvSpPr>
+          <p:cNvPr id="6" name="Shape 4"/>
+          <p:cNvSpPr/>
+          <p:nvPr/>
+        </p:nvSpPr>
+        <p:spPr>
+          <a:xfrm>
+            <a:off x="731520" y="1417320"/>
+            <a:ext cx="2103120" cy="4251960"/>
+          </a:xfrm>
+          <a:prstGeom prst="roundRect">
+            <a:avLst>
+              <a:gd name="adj" fmla="val 2174"/>
+            </a:avLst>
+          </a:prstGeom>
+          <a:solidFill>
+            <a:srgbClr val="FFFFFF"/>
+          </a:solidFill>
+          <a:ln w="12700">
+            <a:solidFill>
+              <a:srgbClr val="FFFFFF">
+                <a:alpha val="0"/>
+              </a:srgbClr>
+            </a:solidFill>
+            <a:prstDash val="solid"/>
+          </a:ln>
+        </p:spPr>
+      </p:sp>
+      <p:sp>
+        <p:nvSpPr>
+          <p:cNvPr id="7" name="Text 5"/>
+          <p:cNvSpPr/>
+          <p:nvPr/>
+        </p:nvSpPr>
+        <p:spPr>
+          <a:xfrm>
+            <a:off x="877824" y="1527048"/>
+            <a:ext cx="1810512" cy="219456"/>
+          </a:xfrm>
+          <a:prstGeom prst="rect">
+            <a:avLst/>
+          </a:prstGeom>
+          <a:noFill/>
+          <a:ln/>
+        </p:spPr>
+        <p:txBody>
+          <a:bodyPr wrap="square" lIns="0" tIns="0" rIns="0" bIns="0" rtlCol="0" anchor="ctr"/>
+          <a:lstStyle/>
+          <a:p>
+            <a:pPr indent="0" marL="0">
+              <a:buNone/>
+            </a:pPr>
+            <a:r>
+              <a:rPr lang="en-US" sz="1400" b="1" dirty="0">
+                <a:solidFill>
+                  <a:srgbClr val="102032"/>
+                </a:solidFill>
+                <a:latin typeface="Aptos Display" pitchFamily="34" charset="0"/>
+                <a:ea typeface="Aptos Display" pitchFamily="34" charset="-122"/>
+                <a:cs typeface="Aptos Display" pitchFamily="34" charset="-120"/>
+              </a:rPr>
+              <a:t>1. Goal setup</a:t>
+            </a:r>
+            <a:endParaRPr lang="en-US" sz="1400" dirty="0"/>
+          </a:p>
+        </p:txBody>
+      </p:sp>
+      <p:sp>
+        <p:nvSpPr>
+          <p:cNvPr id="8" name="Text 6"/>
+          <p:cNvSpPr/>
+          <p:nvPr/>
+        </p:nvSpPr>
+        <p:spPr>
+          <a:xfrm>
+            <a:off x="877824" y="1801368"/>
+            <a:ext cx="1810512" cy="3758184"/>
+          </a:xfrm>
+          <a:prstGeom prst="rect">
+            <a:avLst/>
+          </a:prstGeom>
+          <a:noFill/>
+          <a:ln/>
+        </p:spPr>
+        <p:txBody>
+          <a:bodyPr wrap="square" lIns="0" tIns="0" rIns="0" bIns="0" rtlCol="0" anchor="t"/>
+          <a:lstStyle/>
+          <a:p>
+            <a:pPr indent="0" marL="0">
+              <a:buNone/>
+            </a:pPr>
+            <a:r>
+              <a:rPr lang="en-US" sz="1080" dirty="0">
+                <a:solidFill>
+                  <a:srgbClr val="102032"/>
+                </a:solidFill>
+                <a:latin typeface="Aptos" pitchFamily="34" charset="0"/>
+                <a:ea typeface="Aptos" pitchFamily="34" charset="-122"/>
+                <a:cs typeface="Aptos" pitchFamily="34" charset="-120"/>
+              </a:rPr>
+              <a:t>Codex writes the goal, scope, deliverables, and acceptance bar before code changes are treated as valid progress.</a:t>
+            </a:r>
+            <a:endParaRPr lang="en-US" sz="1080" dirty="0"/>
+          </a:p>
+        </p:txBody>
+      </p:sp>
+      <p:sp>
+        <p:nvSpPr>
+          <p:cNvPr id="9" name="Shape 7"/>
+          <p:cNvSpPr/>
+          <p:nvPr/>
+        </p:nvSpPr>
+        <p:spPr>
+          <a:xfrm>
+            <a:off x="3063240" y="1417320"/>
+            <a:ext cx="2103120" cy="4251960"/>
+          </a:xfrm>
+          <a:prstGeom prst="roundRect">
+            <a:avLst>
+              <a:gd name="adj" fmla="val 2174"/>
+            </a:avLst>
+          </a:prstGeom>
+          <a:solidFill>
+            <a:srgbClr val="E9F1F4"/>
+          </a:solidFill>
+          <a:ln w="12700">
+            <a:solidFill>
+              <a:srgbClr val="E9F1F4">
+                <a:alpha val="0"/>
+              </a:srgbClr>
+            </a:solidFill>
+            <a:prstDash val="solid"/>
+          </a:ln>
+        </p:spPr>
+      </p:sp>
+      <p:sp>
+        <p:nvSpPr>
+          <p:cNvPr id="10" name="Text 8"/>
+          <p:cNvSpPr/>
+          <p:nvPr/>
+        </p:nvSpPr>
+        <p:spPr>
+          <a:xfrm>
+            <a:off x="3209544" y="1527048"/>
+            <a:ext cx="1810512" cy="219456"/>
+          </a:xfrm>
+          <a:prstGeom prst="rect">
+            <a:avLst/>
+          </a:prstGeom>
+          <a:noFill/>
+          <a:ln/>
+        </p:spPr>
+        <p:txBody>
+          <a:bodyPr wrap="square" lIns="0" tIns="0" rIns="0" bIns="0" rtlCol="0" anchor="ctr"/>
+          <a:lstStyle/>
+          <a:p>
+            <a:pPr indent="0" marL="0">
+              <a:buNone/>
+            </a:pPr>
+            <a:r>
+              <a:rPr lang="en-US" sz="1400" b="1" dirty="0">
+                <a:solidFill>
+                  <a:srgbClr val="102032"/>
+                </a:solidFill>
+                <a:latin typeface="Aptos Display" pitchFamily="34" charset="0"/>
+                <a:ea typeface="Aptos Display" pitchFamily="34" charset="-122"/>
+                <a:cs typeface="Aptos Display" pitchFamily="34" charset="-120"/>
+              </a:rPr>
+              <a:t>2. Pre-review</a:t>
+            </a:r>
+            <a:endParaRPr lang="en-US" sz="1400" dirty="0"/>
+          </a:p>
+        </p:txBody>
+      </p:sp>
+      <p:sp>
+        <p:nvSpPr>
+          <p:cNvPr id="11" name="Text 9"/>
+          <p:cNvSpPr/>
+          <p:nvPr/>
+        </p:nvSpPr>
+        <p:spPr>
+          <a:xfrm>
+            <a:off x="3209544" y="1801368"/>
+            <a:ext cx="1810512" cy="3758184"/>
+          </a:xfrm>
+          <a:prstGeom prst="rect">
+            <a:avLst/>
+          </a:prstGeom>
+          <a:noFill/>
+          <a:ln/>
+        </p:spPr>
+        <p:txBody>
+          <a:bodyPr wrap="square" lIns="0" tIns="0" rIns="0" bIns="0" rtlCol="0" anchor="t"/>
+          <a:lstStyle/>
+          <a:p>
+            <a:pPr indent="0" marL="0">
+              <a:buNone/>
+            </a:pPr>
+            <a:r>
+              <a:rPr lang="en-US" sz="1080" dirty="0">
+                <a:solidFill>
+                  <a:srgbClr val="102032"/>
+                </a:solidFill>
+                <a:latin typeface="Aptos" pitchFamily="34" charset="0"/>
+                <a:ea typeface="Aptos" pitchFamily="34" charset="-122"/>
+                <a:cs typeface="Aptos" pitchFamily="34" charset="-120"/>
+              </a:rPr>
+              <a:t>Gemini or Claude reviews the goal first, checks whether the scope is sound, and states how completion should be verified.</a:t>
+            </a:r>
+            <a:endParaRPr lang="en-US" sz="1080" dirty="0"/>
+          </a:p>
+        </p:txBody>
+      </p:sp>
+      <p:sp>
+        <p:nvSpPr>
+          <p:cNvPr id="12" name="Shape 10"/>
+          <p:cNvSpPr/>
+          <p:nvPr/>
+        </p:nvSpPr>
+        <p:spPr>
+          <a:xfrm>
+            <a:off x="5394960" y="1417320"/>
+            <a:ext cx="2103120" cy="4251960"/>
+          </a:xfrm>
+          <a:prstGeom prst="roundRect">
+            <a:avLst>
+              <a:gd name="adj" fmla="val 2174"/>
+            </a:avLst>
+          </a:prstGeom>
+          <a:solidFill>
+            <a:srgbClr val="FFFFFF"/>
+          </a:solidFill>
+          <a:ln w="12700">
+            <a:solidFill>
+              <a:srgbClr val="FFFFFF">
+                <a:alpha val="0"/>
+              </a:srgbClr>
+            </a:solidFill>
+            <a:prstDash val="solid"/>
+          </a:ln>
+        </p:spPr>
+      </p:sp>
+      <p:sp>
+        <p:nvSpPr>
+          <p:cNvPr id="13" name="Text 11"/>
+          <p:cNvSpPr/>
+          <p:nvPr/>
+        </p:nvSpPr>
+        <p:spPr>
+          <a:xfrm>
+            <a:off x="5541264" y="1527048"/>
+            <a:ext cx="1810512" cy="219456"/>
+          </a:xfrm>
+          <a:prstGeom prst="rect">
+            <a:avLst/>
+          </a:prstGeom>
+          <a:noFill/>
+          <a:ln/>
+        </p:spPr>
+        <p:txBody>
+          <a:bodyPr wrap="square" lIns="0" tIns="0" rIns="0" bIns="0" rtlCol="0" anchor="ctr"/>
+          <a:lstStyle/>
+          <a:p>
+            <a:pPr indent="0" marL="0">
+              <a:buNone/>
+            </a:pPr>
+            <a:r>
+              <a:rPr lang="en-US" sz="1400" b="1" dirty="0">
+                <a:solidFill>
+                  <a:srgbClr val="102032"/>
+                </a:solidFill>
+                <a:latin typeface="Aptos Display" pitchFamily="34" charset="0"/>
+                <a:ea typeface="Aptos Display" pitchFamily="34" charset="-122"/>
+                <a:cs typeface="Aptos Display" pitchFamily="34" charset="-120"/>
+              </a:rPr>
+              <a:t>3. Implement + validate</a:t>
+            </a:r>
+            <a:endParaRPr lang="en-US" sz="1400" dirty="0"/>
+          </a:p>
+        </p:txBody>
+      </p:sp>
+      <p:sp>
+        <p:nvSpPr>
+          <p:cNvPr id="14" name="Text 12"/>
+          <p:cNvSpPr/>
+          <p:nvPr/>
+        </p:nvSpPr>
+        <p:spPr>
+          <a:xfrm>
+            <a:off x="5541264" y="1801368"/>
+            <a:ext cx="1810512" cy="3758184"/>
+          </a:xfrm>
+          <a:prstGeom prst="rect">
+            <a:avLst/>
+          </a:prstGeom>
+          <a:noFill/>
+          <a:ln/>
+        </p:spPr>
+        <p:txBody>
+          <a:bodyPr wrap="square" lIns="0" tIns="0" rIns="0" bIns="0" rtlCol="0" anchor="t"/>
+          <a:lstStyle/>
+          <a:p>
+            <a:pPr indent="0" marL="0">
+              <a:buNone/>
+            </a:pPr>
+            <a:r>
+              <a:rPr lang="en-US" sz="1080" dirty="0">
+                <a:solidFill>
+                  <a:srgbClr val="102032"/>
+                </a:solidFill>
+                <a:latin typeface="Aptos" pitchFamily="34" charset="0"/>
+                <a:ea typeface="Aptos" pitchFamily="34" charset="-122"/>
+                <a:cs typeface="Aptos" pitchFamily="34" charset="-120"/>
+              </a:rPr>
+              <a:t>Codex updates code, tests, docs, reports, and examples, then runs the actual evidence path.</a:t>
+            </a:r>
+            <a:endParaRPr lang="en-US" sz="1080" dirty="0"/>
+          </a:p>
+        </p:txBody>
+      </p:sp>
+      <p:sp>
+        <p:nvSpPr>
+          <p:cNvPr id="15" name="Shape 13"/>
+          <p:cNvSpPr/>
+          <p:nvPr/>
+        </p:nvSpPr>
+        <p:spPr>
+          <a:xfrm>
+            <a:off x="7726680" y="1417320"/>
+            <a:ext cx="2103120" cy="4251960"/>
+          </a:xfrm>
+          <a:prstGeom prst="roundRect">
+            <a:avLst>
+              <a:gd name="adj" fmla="val 2174"/>
+            </a:avLst>
+          </a:prstGeom>
+          <a:solidFill>
+            <a:srgbClr val="E9F1F4"/>
+          </a:solidFill>
+          <a:ln w="12700">
+            <a:solidFill>
+              <a:srgbClr val="E9F1F4">
+                <a:alpha val="0"/>
+              </a:srgbClr>
+            </a:solidFill>
+            <a:prstDash val="solid"/>
+          </a:ln>
+        </p:spPr>
+      </p:sp>
+      <p:sp>
+        <p:nvSpPr>
+          <p:cNvPr id="16" name="Text 14"/>
+          <p:cNvSpPr/>
+          <p:nvPr/>
+        </p:nvSpPr>
+        <p:spPr>
+          <a:xfrm>
+            <a:off x="7872984" y="1527048"/>
+            <a:ext cx="1810512" cy="219456"/>
+          </a:xfrm>
+          <a:prstGeom prst="rect">
+            <a:avLst/>
+          </a:prstGeom>
+          <a:noFill/>
+          <a:ln/>
+        </p:spPr>
+        <p:txBody>
+          <a:bodyPr wrap="square" lIns="0" tIns="0" rIns="0" bIns="0" rtlCol="0" anchor="ctr"/>
+          <a:lstStyle/>
+          <a:p>
+            <a:pPr indent="0" marL="0">
+              <a:buNone/>
+            </a:pPr>
+            <a:r>
+              <a:rPr lang="en-US" sz="1400" b="1" dirty="0">
+                <a:solidFill>
+                  <a:srgbClr val="102032"/>
+                </a:solidFill>
+                <a:latin typeface="Aptos Display" pitchFamily="34" charset="0"/>
+                <a:ea typeface="Aptos Display" pitchFamily="34" charset="-122"/>
+                <a:cs typeface="Aptos Display" pitchFamily="34" charset="-120"/>
+              </a:rPr>
+              <a:t>4. Review + revise</a:t>
+            </a:r>
+            <a:endParaRPr lang="en-US" sz="1400" dirty="0"/>
+          </a:p>
+        </p:txBody>
+      </p:sp>
+      <p:sp>
+        <p:nvSpPr>
+          <p:cNvPr id="17" name="Text 15"/>
+          <p:cNvSpPr/>
+          <p:nvPr/>
+        </p:nvSpPr>
+        <p:spPr>
+          <a:xfrm>
+            <a:off x="7872984" y="1801368"/>
+            <a:ext cx="1810512" cy="3758184"/>
+          </a:xfrm>
+          <a:prstGeom prst="rect">
+            <a:avLst/>
+          </a:prstGeom>
+          <a:noFill/>
+          <a:ln/>
+        </p:spPr>
+        <p:txBody>
+          <a:bodyPr wrap="square" lIns="0" tIns="0" rIns="0" bIns="0" rtlCol="0" anchor="t"/>
+          <a:lstStyle/>
+          <a:p>
+            <a:pPr indent="0" marL="0">
+              <a:buNone/>
+            </a:pPr>
+            <a:r>
+              <a:rPr lang="en-US" sz="1080" dirty="0">
+                <a:solidFill>
+                  <a:srgbClr val="102032"/>
+                </a:solidFill>
+                <a:latin typeface="Aptos" pitchFamily="34" charset="0"/>
+                <a:ea typeface="Aptos" pitchFamily="34" charset="-122"/>
+                <a:cs typeface="Aptos" pitchFamily="34" charset="-120"/>
+              </a:rPr>
+              <a:t>Another agent reviews the implemented state. Findings trigger a direct response and another revision pass if needed.</a:t>
+            </a:r>
+            <a:endParaRPr lang="en-US" sz="1080" dirty="0"/>
+          </a:p>
+        </p:txBody>
+      </p:sp>
+      <p:sp>
+        <p:nvSpPr>
+          <p:cNvPr id="18" name="Shape 16"/>
+          <p:cNvSpPr/>
+          <p:nvPr/>
+        </p:nvSpPr>
+        <p:spPr>
+          <a:xfrm>
+            <a:off x="10058400" y="1417320"/>
+            <a:ext cx="1417320" cy="4251960"/>
+          </a:xfrm>
+          <a:prstGeom prst="roundRect">
+            <a:avLst>
+              <a:gd name="adj" fmla="val 3226"/>
+            </a:avLst>
+          </a:prstGeom>
+          <a:solidFill>
+            <a:srgbClr val="FFFFFF"/>
+          </a:solidFill>
+          <a:ln w="12700">
+            <a:solidFill>
+              <a:srgbClr val="FFFFFF">
+                <a:alpha val="0"/>
+              </a:srgbClr>
+            </a:solidFill>
+            <a:prstDash val="solid"/>
+          </a:ln>
+        </p:spPr>
+      </p:sp>
+      <p:sp>
+        <p:nvSpPr>
+          <p:cNvPr id="19" name="Text 17"/>
+          <p:cNvSpPr/>
+          <p:nvPr/>
+        </p:nvSpPr>
+        <p:spPr>
+          <a:xfrm>
+            <a:off x="10204704" y="1527048"/>
+            <a:ext cx="1124712" cy="219456"/>
+          </a:xfrm>
+          <a:prstGeom prst="rect">
+            <a:avLst/>
+          </a:prstGeom>
+          <a:noFill/>
+          <a:ln/>
+        </p:spPr>
+        <p:txBody>
+          <a:bodyPr wrap="square" lIns="0" tIns="0" rIns="0" bIns="0" rtlCol="0" anchor="ctr"/>
+          <a:lstStyle/>
+          <a:p>
+            <a:pPr indent="0" marL="0">
+              <a:buNone/>
+            </a:pPr>
+            <a:r>
+              <a:rPr lang="en-US" sz="1400" b="1" dirty="0">
+                <a:solidFill>
+                  <a:srgbClr val="102032"/>
+                </a:solidFill>
+                <a:latin typeface="Aptos Display" pitchFamily="34" charset="0"/>
+                <a:ea typeface="Aptos Display" pitchFamily="34" charset="-122"/>
+                <a:cs typeface="Aptos Display" pitchFamily="34" charset="-120"/>
+              </a:rPr>
+              <a:t>5. Close + archive</a:t>
+            </a:r>
+            <a:endParaRPr lang="en-US" sz="1400" dirty="0"/>
+          </a:p>
+        </p:txBody>
+      </p:sp>
+      <p:sp>
+        <p:nvSpPr>
+          <p:cNvPr id="20" name="Text 18"/>
+          <p:cNvSpPr/>
+          <p:nvPr/>
+        </p:nvSpPr>
+        <p:spPr>
+          <a:xfrm>
+            <a:off x="10204704" y="1801368"/>
+            <a:ext cx="1124712" cy="3758184"/>
+          </a:xfrm>
+          <a:prstGeom prst="rect">
+            <a:avLst/>
+          </a:prstGeom>
+          <a:noFill/>
+          <a:ln/>
+        </p:spPr>
+        <p:txBody>
+          <a:bodyPr wrap="square" lIns="0" tIns="0" rIns="0" bIns="0" rtlCol="0" anchor="t"/>
+          <a:lstStyle/>
+          <a:p>
+            <a:pPr indent="0" marL="0">
+              <a:buNone/>
+            </a:pPr>
+            <a:r>
+              <a:rPr lang="en-US" sz="1020" dirty="0">
+                <a:solidFill>
+                  <a:srgbClr val="102032"/>
+                </a:solidFill>
+                <a:latin typeface="Aptos" pitchFamily="34" charset="0"/>
+                <a:ea typeface="Aptos" pitchFamily="34" charset="-122"/>
+                <a:cs typeface="Aptos" pitchFamily="34" charset="-120"/>
+              </a:rPr>
+              <a:t>Only after consensus does the round move into history, dashboards, and main.</a:t>
+            </a:r>
+            <a:endParaRPr lang="en-US" sz="1020" dirty="0"/>
+          </a:p>
+        </p:txBody>
+      </p:sp>
+      <p:sp>
+        <p:nvSpPr>
+          <p:cNvPr id="21" name="Shape 19"/>
+          <p:cNvSpPr/>
+          <p:nvPr/>
+        </p:nvSpPr>
+        <p:spPr>
+          <a:xfrm>
+            <a:off x="777240" y="5897880"/>
+            <a:ext cx="10698480" cy="530352"/>
+          </a:xfrm>
+          <a:prstGeom prst="roundRect">
+            <a:avLst>
+              <a:gd name="adj" fmla="val 8621"/>
+            </a:avLst>
+          </a:prstGeom>
+          <a:solidFill>
+            <a:srgbClr val="E6F2EC"/>
+          </a:solidFill>
+          <a:ln w="12700">
+            <a:solidFill>
+              <a:srgbClr val="E6F2EC">
+                <a:alpha val="0"/>
+              </a:srgbClr>
+            </a:solidFill>
+            <a:prstDash val="solid"/>
+          </a:ln>
+        </p:spPr>
+      </p:sp>
+      <p:sp>
+        <p:nvSpPr>
+          <p:cNvPr id="22" name="Text 20"/>
+          <p:cNvSpPr/>
+          <p:nvPr/>
+        </p:nvSpPr>
+        <p:spPr>
+          <a:xfrm>
+            <a:off x="923544" y="6007608"/>
+            <a:ext cx="10405872" cy="219456"/>
+          </a:xfrm>
+          <a:prstGeom prst="rect">
+            <a:avLst/>
+          </a:prstGeom>
+          <a:noFill/>
+          <a:ln/>
+        </p:spPr>
+        <p:txBody>
+          <a:bodyPr wrap="square" lIns="0" tIns="0" rIns="0" bIns="0" rtlCol="0" anchor="ctr"/>
+          <a:lstStyle/>
+          <a:p>
+            <a:pPr indent="0" marL="0">
+              <a:buNone/>
+            </a:pPr>
+            <a:r>
+              <a:rPr lang="en-US" sz="1400" b="1" dirty="0">
+                <a:solidFill>
+                  <a:srgbClr val="102032"/>
+                </a:solidFill>
+                <a:latin typeface="Aptos Display" pitchFamily="34" charset="0"/>
+                <a:ea typeface="Aptos Display" pitchFamily="34" charset="-122"/>
+                <a:cs typeface="Aptos Display" pitchFamily="34" charset="-120"/>
+              </a:rPr>
+              <a:t>Why this matters</a:t>
+            </a:r>
+            <a:endParaRPr lang="en-US" sz="1400" dirty="0"/>
+          </a:p>
+        </p:txBody>
+      </p:sp>
+      <p:sp>
+        <p:nvSpPr>
+          <p:cNvPr id="23" name="Text 21"/>
+          <p:cNvSpPr/>
+          <p:nvPr/>
+        </p:nvSpPr>
+        <p:spPr>
+          <a:xfrm>
+            <a:off x="923544" y="6281928"/>
+            <a:ext cx="10405872" cy="36576"/>
+          </a:xfrm>
+          <a:prstGeom prst="rect">
+            <a:avLst/>
+          </a:prstGeom>
+          <a:noFill/>
+          <a:ln/>
+        </p:spPr>
+        <p:txBody>
+          <a:bodyPr wrap="square" lIns="0" tIns="0" rIns="0" bIns="0" rtlCol="0" anchor="t"/>
+          <a:lstStyle/>
+          <a:p>
+            <a:pPr indent="0" marL="0">
+              <a:buNone/>
+            </a:pPr>
+            <a:r>
+              <a:rPr lang="en-US" sz="1080" dirty="0">
+                <a:solidFill>
+                  <a:srgbClr val="102032"/>
+                </a:solidFill>
+                <a:latin typeface="Aptos" pitchFamily="34" charset="0"/>
+                <a:ea typeface="Aptos" pitchFamily="34" charset="-122"/>
+                <a:cs typeface="Aptos" pitchFamily="34" charset="-120"/>
+              </a:rPr>
+              <a:t>This process turns each accepted goal into an auditable repo state instead of a one-model opinion.</a:t>
+            </a:r>
+            <a:endParaRPr lang="en-US" sz="1080" dirty="0"/>
+          </a:p>
+        </p:txBody>
+      </p:sp>
+      <p:sp>
+        <p:nvSpPr>
+          <p:cNvPr id="24" name="Text 22"/>
+          <p:cNvSpPr/>
+          <p:nvPr/>
+        </p:nvSpPr>
+        <p:spPr>
+          <a:xfrm>
+            <a:off x="10058400" y="6565392"/>
+            <a:ext cx="1645920" cy="128016"/>
+          </a:xfrm>
+          <a:prstGeom prst="rect">
+            <a:avLst/>
+          </a:prstGeom>
+          <a:noFill/>
+          <a:ln/>
+        </p:spPr>
+        <p:txBody>
+          <a:bodyPr wrap="square" lIns="0" tIns="0" rIns="0" bIns="0" rtlCol="0" anchor="ctr"/>
+          <a:lstStyle/>
+          <a:p>
+            <a:pPr algn="r" indent="0" marL="0">
+              <a:buNone/>
+            </a:pPr>
+            <a:r>
+              <a:rPr lang="en-US" sz="850" dirty="0">
+                <a:solidFill>
+                  <a:srgbClr val="D7E0E6"/>
+                </a:solidFill>
+                <a:latin typeface="Aptos" pitchFamily="34" charset="0"/>
+                <a:ea typeface="Aptos" pitchFamily="34" charset="-122"/>
+                <a:cs typeface="Aptos" pitchFamily="34" charset="-120"/>
+              </a:rPr>
+              <a:t>RTDL summary · 13/14</a:t>
+            </a:r>
+            <a:endParaRPr lang="en-US" sz="850" dirty="0"/>
+          </a:p>
+        </p:txBody>
+      </p:sp>
+    </p:spTree>
+  </p:cSld>
+  <p:clrMapOvr>
+    <a:masterClrMapping/>
+  </p:clrMapOvr>
+</p:sld>
+</file>
+
+<file path=ppt/slides/slide14.xml><?xml version="1.0" encoding="utf-8"?>
+<p:sld xmlns:a="http://schemas.openxmlformats.org/drawingml/2006/main" xmlns:r="http://schemas.openxmlformats.org/officeDocument/2006/relationships" xmlns:p="http://schemas.openxmlformats.org/presentationml/2006/main">
+  <p:cSld name="Slide 14">
+    <p:bg>
+      <p:bgPr>
+        <a:solidFill>
+          <a:srgbClr val="F7F4EE"/>
+        </a:solidFill>
+      </p:bgPr>
+    </p:bg>
+    <p:spTree>
+      <p:nvGrpSpPr>
+        <p:cNvPr id="1" name=""/>
+        <p:cNvGrpSpPr/>
+        <p:nvPr/>
+      </p:nvGrpSpPr>
+      <p:grpSpPr>
+        <a:xfrm>
+          <a:off x="0" y="0"/>
+          <a:ext cx="0" cy="0"/>
+          <a:chOff x="0" y="0"/>
+          <a:chExt cx="0" cy="0"/>
+        </a:xfrm>
+      </p:grpSpPr>
+      <p:sp>
+        <p:nvSpPr>
+          <p:cNvPr id="2" name="Shape 0"/>
+          <p:cNvSpPr/>
+          <p:nvPr/>
+        </p:nvSpPr>
+        <p:spPr>
+          <a:xfrm>
+            <a:off x="0" y="0"/>
+            <a:ext cx="12191695" cy="310896"/>
+          </a:xfrm>
+          <a:prstGeom prst="rect">
+            <a:avLst/>
+          </a:prstGeom>
+          <a:solidFill>
+            <a:srgbClr val="1E5A7A"/>
+          </a:solidFill>
+          <a:ln w="12700">
+            <a:solidFill>
+              <a:srgbClr val="1E5A7A">
+                <a:alpha val="0"/>
+              </a:srgbClr>
+            </a:solidFill>
+            <a:prstDash val="solid"/>
+          </a:ln>
+        </p:spPr>
+      </p:sp>
+      <p:sp>
+        <p:nvSpPr>
+          <p:cNvPr id="3" name="Shape 1"/>
+          <p:cNvSpPr/>
+          <p:nvPr/>
+        </p:nvSpPr>
+        <p:spPr>
+          <a:xfrm>
+            <a:off x="0" y="6528816"/>
+            <a:ext cx="12191695" cy="329184"/>
+          </a:xfrm>
+          <a:prstGeom prst="rect">
+            <a:avLst/>
+          </a:prstGeom>
+          <a:solidFill>
+            <a:srgbClr val="0D1720"/>
+          </a:solidFill>
+          <a:ln w="12700">
+            <a:solidFill>
+              <a:srgbClr val="0D1720">
+                <a:alpha val="0"/>
+              </a:srgbClr>
+            </a:solidFill>
+            <a:prstDash val="solid"/>
+          </a:ln>
+        </p:spPr>
+      </p:sp>
+      <p:sp>
+        <p:nvSpPr>
+          <p:cNvPr id="4" name="Text 2"/>
+          <p:cNvSpPr/>
+          <p:nvPr/>
+        </p:nvSpPr>
+        <p:spPr>
+          <a:xfrm>
+            <a:off x="640080" y="457200"/>
+            <a:ext cx="8595360" cy="420624"/>
+          </a:xfrm>
+          <a:prstGeom prst="rect">
+            <a:avLst/>
+          </a:prstGeom>
+          <a:noFill/>
+          <a:ln/>
+        </p:spPr>
+        <p:txBody>
+          <a:bodyPr wrap="square" lIns="0" tIns="0" rIns="0" bIns="0" rtlCol="0" anchor="ctr"/>
+          <a:lstStyle/>
+          <a:p>
+            <a:pPr indent="0" marL="0">
+              <a:buNone/>
+            </a:pPr>
+            <a:r>
+              <a:rPr lang="en-US" sz="2400" b="1" dirty="0">
+                <a:solidFill>
+                  <a:srgbClr val="102032"/>
+                </a:solidFill>
+                <a:latin typeface="Aptos Display" pitchFamily="34" charset="0"/>
+                <a:ea typeface="Aptos Display" pitchFamily="34" charset="-122"/>
+                <a:cs typeface="Aptos Display" pitchFamily="34" charset="-120"/>
+              </a:rPr>
+              <a:t>Agent Roles and Closure Rules</a:t>
+            </a:r>
+            <a:endParaRPr lang="en-US" sz="2400" dirty="0"/>
+          </a:p>
+        </p:txBody>
+      </p:sp>
+      <p:sp>
+        <p:nvSpPr>
+          <p:cNvPr id="5" name="Text 3"/>
+          <p:cNvSpPr/>
+          <p:nvPr/>
+        </p:nvSpPr>
+        <p:spPr>
+          <a:xfrm>
+            <a:off x="658368" y="932688"/>
+            <a:ext cx="9875520" cy="274320"/>
+          </a:xfrm>
+          <a:prstGeom prst="rect">
+            <a:avLst/>
+          </a:prstGeom>
+          <a:noFill/>
+          <a:ln/>
+        </p:spPr>
+        <p:txBody>
+          <a:bodyPr wrap="square" lIns="0" tIns="0" rIns="0" bIns="0" rtlCol="0" anchor="ctr"/>
+          <a:lstStyle/>
+          <a:p>
+            <a:pPr indent="0" marL="0">
+              <a:buNone/>
+            </a:pPr>
+            <a:r>
+              <a:rPr lang="en-US" sz="1050" dirty="0">
+                <a:solidFill>
+                  <a:srgbClr val="5C6B77"/>
+                </a:solidFill>
+                <a:latin typeface="Aptos" pitchFamily="34" charset="0"/>
+                <a:ea typeface="Aptos" pitchFamily="34" charset="-122"/>
+                <a:cs typeface="Aptos" pitchFamily="34" charset="-120"/>
+              </a:rPr>
+              <a:t>Different models play different roles so the project gets structured disagreement before publication.</a:t>
+            </a:r>
+            <a:endParaRPr lang="en-US" sz="1050" dirty="0"/>
+          </a:p>
+        </p:txBody>
+      </p:sp>
+      <p:sp>
+        <p:nvSpPr>
+          <p:cNvPr id="6" name="Shape 4"/>
+          <p:cNvSpPr/>
+          <p:nvPr/>
+        </p:nvSpPr>
+        <p:spPr>
+          <a:xfrm>
+            <a:off x="731520" y="1417320"/>
+            <a:ext cx="3429000" cy="2560320"/>
+          </a:xfrm>
+          <a:prstGeom prst="roundRect">
+            <a:avLst>
+              <a:gd name="adj" fmla="val 1786"/>
+            </a:avLst>
+          </a:prstGeom>
+          <a:solidFill>
+            <a:srgbClr val="FFFFFF"/>
+          </a:solidFill>
+          <a:ln w="12700">
+            <a:solidFill>
+              <a:srgbClr val="FFFFFF">
+                <a:alpha val="0"/>
+              </a:srgbClr>
+            </a:solidFill>
+            <a:prstDash val="solid"/>
+          </a:ln>
+        </p:spPr>
+      </p:sp>
+      <p:sp>
+        <p:nvSpPr>
+          <p:cNvPr id="7" name="Text 5"/>
+          <p:cNvSpPr/>
+          <p:nvPr/>
+        </p:nvSpPr>
+        <p:spPr>
+          <a:xfrm>
+            <a:off x="877824" y="1527048"/>
+            <a:ext cx="3136392" cy="219456"/>
+          </a:xfrm>
+          <a:prstGeom prst="rect">
+            <a:avLst/>
+          </a:prstGeom>
+          <a:noFill/>
+          <a:ln/>
+        </p:spPr>
+        <p:txBody>
+          <a:bodyPr wrap="square" lIns="0" tIns="0" rIns="0" bIns="0" rtlCol="0" anchor="ctr"/>
+          <a:lstStyle/>
+          <a:p>
+            <a:pPr indent="0" marL="0">
+              <a:buNone/>
+            </a:pPr>
+            <a:r>
+              <a:rPr lang="en-US" sz="1400" b="1" dirty="0">
+                <a:solidFill>
+                  <a:srgbClr val="102032"/>
+                </a:solidFill>
+                <a:latin typeface="Aptos Display" pitchFamily="34" charset="0"/>
+                <a:ea typeface="Aptos Display" pitchFamily="34" charset="-122"/>
+                <a:cs typeface="Aptos Display" pitchFamily="34" charset="-120"/>
+              </a:rPr>
+              <a:t>Codex</a:t>
+            </a:r>
+            <a:endParaRPr lang="en-US" sz="1400" dirty="0"/>
+          </a:p>
+        </p:txBody>
+      </p:sp>
+      <p:sp>
+        <p:nvSpPr>
+          <p:cNvPr id="8" name="Text 6"/>
+          <p:cNvSpPr/>
+          <p:nvPr/>
+        </p:nvSpPr>
+        <p:spPr>
+          <a:xfrm>
+            <a:off x="877824" y="1801368"/>
+            <a:ext cx="3136392" cy="2066544"/>
+          </a:xfrm>
+          <a:prstGeom prst="rect">
+            <a:avLst/>
+          </a:prstGeom>
+          <a:noFill/>
+          <a:ln/>
+        </p:spPr>
+        <p:txBody>
+          <a:bodyPr wrap="square" lIns="0" tIns="0" rIns="0" bIns="0" rtlCol="0" anchor="t"/>
+          <a:lstStyle/>
+          <a:p>
+            <a:pPr indent="0" marL="0">
+              <a:buNone/>
+            </a:pPr>
+            <a:r>
+              <a:rPr lang="en-US" sz="1080" dirty="0">
+                <a:solidFill>
+                  <a:srgbClr val="102032"/>
+                </a:solidFill>
+                <a:latin typeface="Aptos" pitchFamily="34" charset="0"/>
+                <a:ea typeface="Aptos" pitchFamily="34" charset="-122"/>
+                <a:cs typeface="Aptos" pitchFamily="34" charset="-120"/>
+              </a:rPr>
+              <a:t>Primary implementation driver.</a:t>
+            </a:r>
+            <a:endParaRPr lang="en-US" sz="1080" dirty="0"/>
+          </a:p>
+          <a:p>
+            <a:pPr indent="0" marL="0">
+              <a:buNone/>
+            </a:pPr>
+            <a:endParaRPr lang="en-US" sz="1080" dirty="0"/>
+          </a:p>
+          <a:p>
+            <a:pPr indent="0" marL="0">
+              <a:buNone/>
+            </a:pPr>
+            <a:r>
+              <a:rPr lang="en-US" sz="1080" dirty="0">
+                <a:solidFill>
+                  <a:srgbClr val="102032"/>
+                </a:solidFill>
+                <a:latin typeface="Aptos" pitchFamily="34" charset="0"/>
+                <a:ea typeface="Aptos" pitchFamily="34" charset="-122"/>
+                <a:cs typeface="Aptos" pitchFamily="34" charset="-120"/>
+              </a:rPr>
+              <a:t>Owns code changes, validation runs, doc updates, rebuttals, and final repo coherence.</a:t>
+            </a:r>
+            <a:endParaRPr lang="en-US" sz="1080" dirty="0"/>
+          </a:p>
+        </p:txBody>
+      </p:sp>
+      <p:sp>
+        <p:nvSpPr>
+          <p:cNvPr id="9" name="Shape 7"/>
+          <p:cNvSpPr/>
+          <p:nvPr/>
+        </p:nvSpPr>
+        <p:spPr>
+          <a:xfrm>
+            <a:off x="4389120" y="1417320"/>
+            <a:ext cx="3429000" cy="2560320"/>
+          </a:xfrm>
+          <a:prstGeom prst="roundRect">
+            <a:avLst>
+              <a:gd name="adj" fmla="val 1786"/>
+            </a:avLst>
+          </a:prstGeom>
+          <a:solidFill>
+            <a:srgbClr val="E9F1F4"/>
+          </a:solidFill>
+          <a:ln w="12700">
+            <a:solidFill>
+              <a:srgbClr val="E9F1F4">
+                <a:alpha val="0"/>
+              </a:srgbClr>
+            </a:solidFill>
+            <a:prstDash val="solid"/>
+          </a:ln>
+        </p:spPr>
+      </p:sp>
+      <p:sp>
+        <p:nvSpPr>
+          <p:cNvPr id="10" name="Text 8"/>
+          <p:cNvSpPr/>
+          <p:nvPr/>
+        </p:nvSpPr>
+        <p:spPr>
+          <a:xfrm>
+            <a:off x="4535424" y="1527048"/>
+            <a:ext cx="3136392" cy="219456"/>
+          </a:xfrm>
+          <a:prstGeom prst="rect">
+            <a:avLst/>
+          </a:prstGeom>
+          <a:noFill/>
+          <a:ln/>
+        </p:spPr>
+        <p:txBody>
+          <a:bodyPr wrap="square" lIns="0" tIns="0" rIns="0" bIns="0" rtlCol="0" anchor="ctr"/>
+          <a:lstStyle/>
+          <a:p>
+            <a:pPr indent="0" marL="0">
+              <a:buNone/>
+            </a:pPr>
+            <a:r>
+              <a:rPr lang="en-US" sz="1400" b="1" dirty="0">
+                <a:solidFill>
+                  <a:srgbClr val="102032"/>
+                </a:solidFill>
+                <a:latin typeface="Aptos Display" pitchFamily="34" charset="0"/>
+                <a:ea typeface="Aptos Display" pitchFamily="34" charset="-122"/>
+                <a:cs typeface="Aptos Display" pitchFamily="34" charset="-120"/>
+              </a:rPr>
+              <a:t>Gemini</a:t>
+            </a:r>
+            <a:endParaRPr lang="en-US" sz="1400" dirty="0"/>
+          </a:p>
+        </p:txBody>
+      </p:sp>
+      <p:sp>
+        <p:nvSpPr>
+          <p:cNvPr id="11" name="Text 9"/>
+          <p:cNvSpPr/>
+          <p:nvPr/>
+        </p:nvSpPr>
+        <p:spPr>
+          <a:xfrm>
+            <a:off x="4535424" y="1801368"/>
+            <a:ext cx="3136392" cy="2066544"/>
+          </a:xfrm>
+          <a:prstGeom prst="rect">
+            <a:avLst/>
+          </a:prstGeom>
+          <a:noFill/>
+          <a:ln/>
+        </p:spPr>
+        <p:txBody>
+          <a:bodyPr wrap="square" lIns="0" tIns="0" rIns="0" bIns="0" rtlCol="0" anchor="t"/>
+          <a:lstStyle/>
+          <a:p>
+            <a:pPr indent="0" marL="0">
+              <a:buNone/>
+            </a:pPr>
+            <a:r>
+              <a:rPr lang="en-US" sz="1080" dirty="0">
+                <a:solidFill>
+                  <a:srgbClr val="102032"/>
+                </a:solidFill>
+                <a:latin typeface="Aptos" pitchFamily="34" charset="0"/>
+                <a:ea typeface="Aptos" pitchFamily="34" charset="-122"/>
+                <a:cs typeface="Aptos" pitchFamily="34" charset="-120"/>
+              </a:rPr>
+              <a:t>Fast secondary reviewer.</a:t>
+            </a:r>
+            <a:endParaRPr lang="en-US" sz="1080" dirty="0"/>
+          </a:p>
+          <a:p>
+            <a:pPr indent="0" marL="0">
+              <a:buNone/>
+            </a:pPr>
+            <a:endParaRPr lang="en-US" sz="1080" dirty="0"/>
+          </a:p>
+          <a:p>
+            <a:pPr indent="0" marL="0">
+              <a:buNone/>
+            </a:pPr>
+            <a:r>
+              <a:rPr lang="en-US" sz="1080" dirty="0">
+                <a:solidFill>
+                  <a:srgbClr val="102032"/>
+                </a:solidFill>
+                <a:latin typeface="Aptos" pitchFamily="34" charset="0"/>
+                <a:ea typeface="Aptos" pitchFamily="34" charset="-122"/>
+                <a:cs typeface="Aptos" pitchFamily="34" charset="-120"/>
+              </a:rPr>
+              <a:t>Usually checks scope, evidence, semantic honesty, and whether a round is really ready to close.</a:t>
+            </a:r>
+            <a:endParaRPr lang="en-US" sz="1080" dirty="0"/>
+          </a:p>
+        </p:txBody>
+      </p:sp>
+      <p:sp>
+        <p:nvSpPr>
+          <p:cNvPr id="12" name="Shape 10"/>
+          <p:cNvSpPr/>
+          <p:nvPr/>
+        </p:nvSpPr>
+        <p:spPr>
+          <a:xfrm>
+            <a:off x="8046720" y="1417320"/>
+            <a:ext cx="3429000" cy="2560320"/>
+          </a:xfrm>
+          <a:prstGeom prst="roundRect">
+            <a:avLst>
+              <a:gd name="adj" fmla="val 1786"/>
+            </a:avLst>
+          </a:prstGeom>
+          <a:solidFill>
+            <a:srgbClr val="FFFFFF"/>
+          </a:solidFill>
+          <a:ln w="12700">
+            <a:solidFill>
+              <a:srgbClr val="FFFFFF">
+                <a:alpha val="0"/>
+              </a:srgbClr>
+            </a:solidFill>
+            <a:prstDash val="solid"/>
+          </a:ln>
+        </p:spPr>
+      </p:sp>
+      <p:sp>
+        <p:nvSpPr>
+          <p:cNvPr id="13" name="Text 11"/>
+          <p:cNvSpPr/>
+          <p:nvPr/>
+        </p:nvSpPr>
+        <p:spPr>
+          <a:xfrm>
+            <a:off x="8193024" y="1527048"/>
+            <a:ext cx="3136392" cy="219456"/>
+          </a:xfrm>
+          <a:prstGeom prst="rect">
+            <a:avLst/>
+          </a:prstGeom>
+          <a:noFill/>
+          <a:ln/>
+        </p:spPr>
+        <p:txBody>
+          <a:bodyPr wrap="square" lIns="0" tIns="0" rIns="0" bIns="0" rtlCol="0" anchor="ctr"/>
+          <a:lstStyle/>
+          <a:p>
+            <a:pPr indent="0" marL="0">
+              <a:buNone/>
+            </a:pPr>
+            <a:r>
+              <a:rPr lang="en-US" sz="1400" b="1" dirty="0">
+                <a:solidFill>
+                  <a:srgbClr val="102032"/>
+                </a:solidFill>
+                <a:latin typeface="Aptos Display" pitchFamily="34" charset="0"/>
+                <a:ea typeface="Aptos Display" pitchFamily="34" charset="-122"/>
+                <a:cs typeface="Aptos Display" pitchFamily="34" charset="-120"/>
+              </a:rPr>
+              <a:t>Claude</a:t>
+            </a:r>
+            <a:endParaRPr lang="en-US" sz="1400" dirty="0"/>
+          </a:p>
+        </p:txBody>
+      </p:sp>
+      <p:sp>
+        <p:nvSpPr>
+          <p:cNvPr id="14" name="Text 12"/>
+          <p:cNvSpPr/>
+          <p:nvPr/>
+        </p:nvSpPr>
+        <p:spPr>
+          <a:xfrm>
+            <a:off x="8193024" y="1801368"/>
+            <a:ext cx="3136392" cy="2066544"/>
+          </a:xfrm>
+          <a:prstGeom prst="rect">
+            <a:avLst/>
+          </a:prstGeom>
+          <a:noFill/>
+          <a:ln/>
+        </p:spPr>
+        <p:txBody>
+          <a:bodyPr wrap="square" lIns="0" tIns="0" rIns="0" bIns="0" rtlCol="0" anchor="t"/>
+          <a:lstStyle/>
+          <a:p>
+            <a:pPr indent="0" marL="0">
+              <a:buNone/>
+            </a:pPr>
+            <a:r>
+              <a:rPr lang="en-US" sz="1080" dirty="0">
+                <a:solidFill>
+                  <a:srgbClr val="102032"/>
+                </a:solidFill>
+                <a:latin typeface="Aptos" pitchFamily="34" charset="0"/>
+                <a:ea typeface="Aptos" pitchFamily="34" charset="-122"/>
+                <a:cs typeface="Aptos" pitchFamily="34" charset="-120"/>
+              </a:rPr>
+              <a:t>Audit and critique pressure.</a:t>
+            </a:r>
+            <a:endParaRPr lang="en-US" sz="1080" dirty="0"/>
+          </a:p>
+          <a:p>
+            <a:pPr indent="0" marL="0">
+              <a:buNone/>
+            </a:pPr>
+            <a:endParaRPr lang="en-US" sz="1080" dirty="0"/>
+          </a:p>
+          <a:p>
+            <a:pPr indent="0" marL="0">
+              <a:buNone/>
+            </a:pPr>
+            <a:r>
+              <a:rPr lang="en-US" sz="1080" dirty="0">
+                <a:solidFill>
+                  <a:srgbClr val="102032"/>
+                </a:solidFill>
+                <a:latin typeface="Aptos" pitchFamily="34" charset="0"/>
+                <a:ea typeface="Aptos" pitchFamily="34" charset="-122"/>
+                <a:cs typeface="Aptos" pitchFamily="34" charset="-120"/>
+              </a:rPr>
+              <a:t>Often used for deeper plan criticism, trust audits, and narrower comparison goals.</a:t>
+            </a:r>
+            <a:endParaRPr lang="en-US" sz="1080" dirty="0"/>
+          </a:p>
+        </p:txBody>
+      </p:sp>
+      <p:sp>
+        <p:nvSpPr>
+          <p:cNvPr id="15" name="Text 13"/>
+          <p:cNvSpPr/>
+          <p:nvPr/>
+        </p:nvSpPr>
+        <p:spPr>
+          <a:xfrm>
+            <a:off x="868680" y="4160520"/>
+            <a:ext cx="10515600" cy="1828800"/>
+          </a:xfrm>
+          <a:prstGeom prst="rect">
+            <a:avLst/>
+          </a:prstGeom>
+          <a:noFill/>
+          <a:ln/>
+        </p:spPr>
+        <p:txBody>
+          <a:bodyPr wrap="square" lIns="508" tIns="508" rIns="508" bIns="508" rtlCol="0" anchor="t"/>
+          <a:lstStyle/>
+          <a:p>
+            <a:pPr marL="177800" indent="-177800">
+              <a:buSzPct val="100000"/>
+              <a:buChar char="•"/>
+            </a:pPr>
+            <a:r>
+              <a:rPr lang="en-US" sz="1310" dirty="0">
+                <a:solidFill>
+                  <a:srgbClr val="102032"/>
+                </a:solidFill>
+                <a:latin typeface="Aptos" pitchFamily="34" charset="0"/>
+                <a:ea typeface="Aptos" pitchFamily="34" charset="-122"/>
+                <a:cs typeface="Aptos" pitchFamily="34" charset="-120"/>
+              </a:rPr>
+              <a:t>Consensus means the agents agree on the final goal state, not that they produce identical reports.</a:t>
+            </a:r>
+            <a:pPr indent="0" marL="0">
+              <a:buNone/>
+            </a:pPr>
+            <a:endParaRPr lang="en-US" sz="1310" dirty="0"/>
+          </a:p>
+          <a:p>
+            <a:pPr marL="177800" indent="-177800">
+              <a:buSzPct val="100000"/>
+              <a:buChar char="•"/>
+            </a:pPr>
+            <a:r>
+              <a:rPr lang="en-US" sz="1310" dirty="0">
+                <a:solidFill>
+                  <a:srgbClr val="102032"/>
+                </a:solidFill>
+                <a:latin typeface="Aptos" pitchFamily="34" charset="0"/>
+                <a:ea typeface="Aptos" pitchFamily="34" charset="-122"/>
+                <a:cs typeface="Aptos" pitchFamily="34" charset="-120"/>
+              </a:rPr>
+              <a:t>A goal can close as complete, complete-for-slice, canceled-superseded, or blocked, as long as the wording matches the evidence.</a:t>
+            </a:r>
+            <a:pPr indent="0" marL="0">
+              <a:buNone/>
+            </a:pPr>
+            <a:endParaRPr lang="en-US" sz="1310" dirty="0"/>
+          </a:p>
+          <a:p>
+            <a:pPr marL="177800" indent="-177800">
+              <a:buSzPct val="100000"/>
+              <a:buChar char="•"/>
+            </a:pPr>
+            <a:r>
+              <a:rPr lang="en-US" sz="1310" dirty="0">
+                <a:solidFill>
+                  <a:srgbClr val="102032"/>
+                </a:solidFill>
+                <a:latin typeface="Aptos" pitchFamily="34" charset="0"/>
+                <a:ea typeface="Aptos" pitchFamily="34" charset="-122"/>
+                <a:cs typeface="Aptos" pitchFamily="34" charset="-120"/>
+              </a:rPr>
+              <a:t>The archive keeps prompts, reviews, responses, and final closure notes so future contributors can inspect why a decision was made.</a:t>
+            </a:r>
+            <a:pPr indent="0" marL="0">
+              <a:buNone/>
+            </a:pPr>
+            <a:endParaRPr lang="en-US" sz="1310" dirty="0"/>
+          </a:p>
+          <a:p>
+            <a:pPr marL="177800" indent="-177800">
+              <a:buSzPct val="100000"/>
+              <a:buChar char="•"/>
+            </a:pPr>
+            <a:r>
+              <a:rPr lang="en-US" sz="1310" dirty="0">
+                <a:solidFill>
+                  <a:srgbClr val="102032"/>
+                </a:solidFill>
+                <a:latin typeface="Aptos" pitchFamily="34" charset="0"/>
+                <a:ea typeface="Aptos" pitchFamily="34" charset="-122"/>
+                <a:cs typeface="Aptos" pitchFamily="34" charset="-120"/>
+              </a:rPr>
+              <a:t>This is now a core part of RTDL’s engineering method, not an ad hoc side process.</a:t>
+            </a:r>
+            <a:endParaRPr lang="en-US" sz="1310" dirty="0"/>
+          </a:p>
+        </p:txBody>
+      </p:sp>
+      <p:sp>
+        <p:nvSpPr>
+          <p:cNvPr id="16" name="Text 14"/>
+          <p:cNvSpPr/>
+          <p:nvPr/>
+        </p:nvSpPr>
+        <p:spPr>
+          <a:xfrm>
+            <a:off x="10058400" y="6565392"/>
+            <a:ext cx="1645920" cy="128016"/>
+          </a:xfrm>
+          <a:prstGeom prst="rect">
+            <a:avLst/>
+          </a:prstGeom>
+          <a:noFill/>
+          <a:ln/>
+        </p:spPr>
+        <p:txBody>
+          <a:bodyPr wrap="square" lIns="0" tIns="0" rIns="0" bIns="0" rtlCol="0" anchor="ctr"/>
+          <a:lstStyle/>
+          <a:p>
+            <a:pPr algn="r" indent="0" marL="0">
+              <a:buNone/>
+            </a:pPr>
+            <a:r>
+              <a:rPr lang="en-US" sz="850" dirty="0">
+                <a:solidFill>
+                  <a:srgbClr val="D7E0E6"/>
+                </a:solidFill>
+                <a:latin typeface="Aptos" pitchFamily="34" charset="0"/>
+                <a:ea typeface="Aptos" pitchFamily="34" charset="-122"/>
+                <a:cs typeface="Aptos" pitchFamily="34" charset="-120"/>
+              </a:rPr>
+              <a:t>RTDL summary · 14/14</a:t>
             </a:r>
             <a:endParaRPr lang="en-US" sz="850" dirty="0"/>
           </a:p>
@@ -5398,7 +7117,7 @@
                 <a:ea typeface="Aptos" pitchFamily="34" charset="-122"/>
                 <a:cs typeface="Aptos" pitchFamily="34" charset="-120"/>
               </a:rPr>
-              <a:t>RTDL summary · 2/12</a:t>
+              <a:t>RTDL summary · 2/14</a:t>
             </a:r>
             <a:endParaRPr lang="en-US" sz="850" dirty="0"/>
           </a:p>
@@ -6274,7 +7993,7 @@
                 <a:ea typeface="Aptos" pitchFamily="34" charset="-122"/>
                 <a:cs typeface="Aptos" pitchFamily="34" charset="-120"/>
               </a:rPr>
-              <a:t>RTDL summary · 3/12</a:t>
+              <a:t>RTDL summary · 3/14</a:t>
             </a:r>
             <a:endParaRPr lang="en-US" sz="850" dirty="0"/>
           </a:p>
@@ -7075,7 +8794,7 @@
                 <a:ea typeface="Aptos" pitchFamily="34" charset="-122"/>
                 <a:cs typeface="Aptos" pitchFamily="34" charset="-120"/>
               </a:rPr>
-              <a:t>RTDL summary · 4/12</a:t>
+              <a:t>RTDL summary · 4/14</a:t>
             </a:r>
             <a:endParaRPr lang="en-US" sz="850" dirty="0"/>
           </a:p>
@@ -8403,7 +10122,7 @@
                 <a:ea typeface="Aptos" pitchFamily="34" charset="-122"/>
                 <a:cs typeface="Aptos" pitchFamily="34" charset="-120"/>
               </a:rPr>
-              <a:t>RTDL summary · 5/12</a:t>
+              <a:t>RTDL summary · 5/14</a:t>
             </a:r>
             <a:endParaRPr lang="en-US" sz="850" dirty="0"/>
           </a:p>
@@ -9708,7 +11427,7 @@
                 <a:ea typeface="Aptos" pitchFamily="34" charset="-122"/>
                 <a:cs typeface="Aptos" pitchFamily="34" charset="-120"/>
               </a:rPr>
-              <a:t>RTDL summary · 6/12</a:t>
+              <a:t>RTDL summary · 6/14</a:t>
             </a:r>
             <a:endParaRPr lang="en-US" sz="850" dirty="0"/>
           </a:p>
@@ -10564,7 +12283,7 @@
                 <a:ea typeface="Aptos" pitchFamily="34" charset="-122"/>
                 <a:cs typeface="Aptos" pitchFamily="34" charset="-120"/>
               </a:rPr>
-              <a:t>RTDL summary · 7/12</a:t>
+              <a:t>RTDL summary · 7/14</a:t>
             </a:r>
             <a:endParaRPr lang="en-US" sz="850" dirty="0"/>
           </a:p>
@@ -10728,7 +12447,7 @@
                 <a:ea typeface="Aptos" pitchFamily="34" charset="-122"/>
                 <a:cs typeface="Aptos" pitchFamily="34" charset="-120"/>
               </a:rPr>
-              <a:t>The project has been advanced through explicit multi-round Codex + Gemini review loops.</a:t>
+              <a:t>The project has been advanced through explicit multi-round Codex, Gemini, and Claude review loops.</a:t>
             </a:r>
             <a:endParaRPr lang="en-US" sz="1050" dirty="0"/>
           </a:p>
@@ -11619,7 +13338,7 @@
                 <a:ea typeface="Aptos" pitchFamily="34" charset="-122"/>
                 <a:cs typeface="Aptos" pitchFamily="34" charset="-120"/>
               </a:rPr>
-              <a:t>RTDL summary · 8/12</a:t>
+              <a:t>RTDL summary · 8/14</a:t>
             </a:r>
             <a:endParaRPr lang="en-US" sz="850" dirty="0"/>
           </a:p>
@@ -12445,7 +14164,7 @@
                 <a:ea typeface="Aptos" pitchFamily="34" charset="-122"/>
                 <a:cs typeface="Aptos" pitchFamily="34" charset="-120"/>
               </a:rPr>
-              <a:t>RTDL summary · 9/12</a:t>
+              <a:t>RTDL summary · 9/14</a:t>
             </a:r>
             <a:endParaRPr lang="en-US" sz="850" dirty="0"/>
           </a:p>

</xml_diff>

<commit_message>
Complete Goal 17 low-overhead runtime slice
</commit_message>
<xml_diff>
--- a/rtdl_status_summary.pptx
+++ b/rtdl_status_summary.pptx
@@ -19,9 +19,10 @@
     <p:sldId id="267" r:id="rId13"/>
     <p:sldId id="268" r:id="rId14"/>
     <p:sldId id="269" r:id="rId15"/>
+    <p:sldId id="270" r:id="rId16"/>
   </p:sldIdLst>
   <p:notesMasterIdLst>
-    <p:notesMasterId r:id="rId16"/>
+    <p:notesMasterId r:id="rId17"/>
   </p:notesMasterIdLst>
   <p:sldSz cx="12192000" cy="6858000"/>
   <p:notesSz cx="6858000" cy="12192000"/>
@@ -979,6 +980,94 @@
             <a:fld id="{F7021451-1387-4CA6-816F-3879F97B5CBC}" type="slidenum">
               <a:rPr lang="en-US"/>
               <a:t>14</a:t>
+            </a:fld>
+            <a:endParaRPr lang="en-US"/>
+          </a:p>
+        </p:txBody>
+      </p:sp>
+    </p:spTree>
+    <p:extLst>
+      <p:ext uri="{BB962C8B-B14F-4D97-AF65-F5344CB8AC3E}">
+        <p14:creationId xmlns:p14="http://schemas.microsoft.com/office/powerpoint/2010/main" val="1024086991"/>
+      </p:ext>
+    </p:extLst>
+  </p:cSld>
+  <p:clrMapOvr>
+    <a:masterClrMapping/>
+  </p:clrMapOvr>
+</p:notes>
+</file>
+
+<file path=ppt/notesSlides/notesSlide15.xml><?xml version="1.0" encoding="utf-8"?>
+<p:notes xmlns:a="http://schemas.openxmlformats.org/drawingml/2006/main" xmlns:r="http://schemas.openxmlformats.org/officeDocument/2006/relationships" xmlns:p="http://schemas.openxmlformats.org/presentationml/2006/main">
+  <p:cSld>
+    <p:spTree>
+      <p:nvGrpSpPr>
+        <p:cNvPr id="1" name=""/>
+        <p:cNvGrpSpPr/>
+        <p:nvPr/>
+      </p:nvGrpSpPr>
+      <p:grpSpPr>
+        <a:xfrm>
+          <a:off x="0" y="0"/>
+          <a:ext cx="0" cy="0"/>
+          <a:chOff x="0" y="0"/>
+          <a:chExt cx="0" cy="0"/>
+        </a:xfrm>
+      </p:grpSpPr>
+      <p:sp>
+        <p:nvSpPr>
+          <p:cNvPr id="2" name="Slide Image Placeholder 1"/>
+          <p:cNvSpPr>
+            <a:spLocks noGrp="1" noRot="1" noChangeAspect="1"/>
+          </p:cNvSpPr>
+          <p:nvPr>
+            <p:ph type="sldImg"/>
+          </p:nvPr>
+        </p:nvSpPr>
+        <p:spPr/>
+      </p:sp>
+      <p:sp>
+        <p:nvSpPr>
+          <p:cNvPr id="3" name="Notes Placeholder 2"/>
+          <p:cNvSpPr>
+            <a:spLocks noGrp="1"/>
+          </p:cNvSpPr>
+          <p:nvPr>
+            <p:ph type="body" idx="1"/>
+          </p:nvPr>
+        </p:nvSpPr>
+        <p:spPr/>
+        <p:txBody>
+          <a:bodyPr/>
+          <a:lstStyle/>
+          <a:p>
+            <a:r>
+              <a:rPr lang="en-US" dirty="0"/>
+              <a:t/>
+            </a:r>
+            <a:endParaRPr lang="en-US" dirty="0"/>
+          </a:p>
+        </p:txBody>
+      </p:sp>
+      <p:sp>
+        <p:nvSpPr>
+          <p:cNvPr id="4" name="Slide Number Placeholder 3"/>
+          <p:cNvSpPr>
+            <a:spLocks noGrp="1"/>
+          </p:cNvSpPr>
+          <p:nvPr>
+            <p:ph type="sldNum" sz="quarter" idx="10"/>
+          </p:nvPr>
+        </p:nvSpPr>
+        <p:spPr/>
+        <p:txBody>
+          <a:bodyPr/>
+          <a:lstStyle/>
+          <a:p>
+            <a:fld id="{F7021451-1387-4CA6-816F-3879F97B5CBC}" type="slidenum">
+              <a:rPr lang="en-US"/>
+              <a:t>15</a:t>
             </a:fld>
             <a:endParaRPr lang="en-US"/>
           </a:p>
@@ -2226,7 +2315,7 @@
                 <a:ea typeface="Aptos" pitchFamily="34" charset="-122"/>
                 <a:cs typeface="Aptos" pitchFamily="34" charset="-120"/>
               </a:rPr>
-              <a:t>Research status as of March 29, 2026</a:t>
+              <a:t>Research status as of March 31, 2026</a:t>
             </a:r>
             <a:endParaRPr lang="en-US" sz="1400" dirty="0"/>
           </a:p>
@@ -2930,7 +3019,7 @@
                 <a:ea typeface="Aptos" pitchFamily="34" charset="-122"/>
                 <a:cs typeface="Aptos" pitchFamily="34" charset="-120"/>
               </a:rPr>
-              <a:t>RTDL summary · 1/14</a:t>
+              <a:t>RTDL summary · 1/15</a:t>
             </a:r>
             <a:endParaRPr lang="en-US" sz="850" dirty="0"/>
           </a:p>
@@ -3485,7 +3574,7 @@
                 <a:ea typeface="Aptos" pitchFamily="34" charset="-122"/>
                 <a:cs typeface="Aptos" pitchFamily="34" charset="-120"/>
               </a:rPr>
-              <a:t>RTDL summary · 10/14</a:t>
+              <a:t>RTDL summary · 10/15</a:t>
             </a:r>
             <a:endParaRPr lang="en-US" sz="850" dirty="0"/>
           </a:p>
@@ -4291,7 +4380,7 @@
                 <a:ea typeface="Aptos" pitchFamily="34" charset="-122"/>
                 <a:cs typeface="Aptos" pitchFamily="34" charset="-120"/>
               </a:rPr>
-              <a:t>RTDL summary · 11/14</a:t>
+              <a:t>RTDL summary · 11/15</a:t>
             </a:r>
             <a:endParaRPr lang="en-US" sz="850" dirty="0"/>
           </a:p>
@@ -4562,7 +4651,7 @@
                 <a:ea typeface="Aptos" pitchFamily="34" charset="-122"/>
                 <a:cs typeface="Aptos" pitchFamily="34" charset="-120"/>
               </a:rPr>
-              <a:t>GitHub and local repo are in sync through Goal 15, including the native C++ + Embree comparison slice and refreshed history dashboard.</a:t>
+              <a:t>GitHub and local repo are in sync through Goal 17 first-slice closure, including the low-overhead Embree runtime path and refreshed history dashboard.</a:t>
             </a:r>
             <a:endParaRPr lang="en-US" sz="1080" dirty="0"/>
           </a:p>
@@ -4933,7 +5022,7 @@
                 <a:ea typeface="Courier New" pitchFamily="34" charset="-122"/>
                 <a:cs typeface="Courier New" pitchFamily="34" charset="-120"/>
               </a:rPr>
-              <a:t>- 57 passing tests</a:t>
+              <a:t>- 74 passing tests</a:t>
             </a:r>
             <a:endParaRPr lang="en-US" sz="980" dirty="0"/>
           </a:p>
@@ -5006,7 +5095,7 @@
                 <a:ea typeface="Aptos" pitchFamily="34" charset="-122"/>
                 <a:cs typeface="Aptos" pitchFamily="34" charset="-120"/>
               </a:rPr>
-              <a:t>RTDL summary · 12/14</a:t>
+              <a:t>RTDL summary · 12/15</a:t>
             </a:r>
             <a:endParaRPr lang="en-US" sz="850" dirty="0"/>
           </a:p>
@@ -5851,7 +5940,7 @@
                 <a:ea typeface="Aptos" pitchFamily="34" charset="-122"/>
                 <a:cs typeface="Aptos" pitchFamily="34" charset="-120"/>
               </a:rPr>
-              <a:t>RTDL summary · 13/14</a:t>
+              <a:t>RTDL summary · 13/15</a:t>
             </a:r>
             <a:endParaRPr lang="en-US" sz="850" dirty="0"/>
           </a:p>
@@ -6547,7 +6636,764 @@
                 <a:ea typeface="Aptos" pitchFamily="34" charset="-122"/>
                 <a:cs typeface="Aptos" pitchFamily="34" charset="-120"/>
               </a:rPr>
-              <a:t>RTDL summary · 14/14</a:t>
+              <a:t>RTDL summary · 14/15</a:t>
+            </a:r>
+            <a:endParaRPr lang="en-US" sz="850" dirty="0"/>
+          </a:p>
+        </p:txBody>
+      </p:sp>
+    </p:spTree>
+  </p:cSld>
+  <p:clrMapOvr>
+    <a:masterClrMapping/>
+  </p:clrMapOvr>
+</p:sld>
+</file>
+
+<file path=ppt/slides/slide15.xml><?xml version="1.0" encoding="utf-8"?>
+<p:sld xmlns:a="http://schemas.openxmlformats.org/drawingml/2006/main" xmlns:r="http://schemas.openxmlformats.org/officeDocument/2006/relationships" xmlns:p="http://schemas.openxmlformats.org/presentationml/2006/main">
+  <p:cSld name="Slide 15">
+    <p:bg>
+      <p:bgPr>
+        <a:solidFill>
+          <a:srgbClr val="F7F4EE"/>
+        </a:solidFill>
+      </p:bgPr>
+    </p:bg>
+    <p:spTree>
+      <p:nvGrpSpPr>
+        <p:cNvPr id="1" name=""/>
+        <p:cNvGrpSpPr/>
+        <p:nvPr/>
+      </p:nvGrpSpPr>
+      <p:grpSpPr>
+        <a:xfrm>
+          <a:off x="0" y="0"/>
+          <a:ext cx="0" cy="0"/>
+          <a:chOff x="0" y="0"/>
+          <a:chExt cx="0" cy="0"/>
+        </a:xfrm>
+      </p:grpSpPr>
+      <p:sp>
+        <p:nvSpPr>
+          <p:cNvPr id="2" name="Shape 0"/>
+          <p:cNvSpPr/>
+          <p:nvPr/>
+        </p:nvSpPr>
+        <p:spPr>
+          <a:xfrm>
+            <a:off x="0" y="0"/>
+            <a:ext cx="12191695" cy="310896"/>
+          </a:xfrm>
+          <a:prstGeom prst="rect">
+            <a:avLst/>
+          </a:prstGeom>
+          <a:solidFill>
+            <a:srgbClr val="B85C38"/>
+          </a:solidFill>
+          <a:ln w="12700">
+            <a:solidFill>
+              <a:srgbClr val="B85C38">
+                <a:alpha val="0"/>
+              </a:srgbClr>
+            </a:solidFill>
+            <a:prstDash val="solid"/>
+          </a:ln>
+        </p:spPr>
+      </p:sp>
+      <p:sp>
+        <p:nvSpPr>
+          <p:cNvPr id="3" name="Shape 1"/>
+          <p:cNvSpPr/>
+          <p:nvPr/>
+        </p:nvSpPr>
+        <p:spPr>
+          <a:xfrm>
+            <a:off x="0" y="6528816"/>
+            <a:ext cx="12191695" cy="329184"/>
+          </a:xfrm>
+          <a:prstGeom prst="rect">
+            <a:avLst/>
+          </a:prstGeom>
+          <a:solidFill>
+            <a:srgbClr val="0D1720"/>
+          </a:solidFill>
+          <a:ln w="12700">
+            <a:solidFill>
+              <a:srgbClr val="0D1720">
+                <a:alpha val="0"/>
+              </a:srgbClr>
+            </a:solidFill>
+            <a:prstDash val="solid"/>
+          </a:ln>
+        </p:spPr>
+      </p:sp>
+      <p:sp>
+        <p:nvSpPr>
+          <p:cNvPr id="4" name="Text 2"/>
+          <p:cNvSpPr/>
+          <p:nvPr/>
+        </p:nvSpPr>
+        <p:spPr>
+          <a:xfrm>
+            <a:off x="640080" y="457200"/>
+            <a:ext cx="8595360" cy="420624"/>
+          </a:xfrm>
+          <a:prstGeom prst="rect">
+            <a:avLst/>
+          </a:prstGeom>
+          <a:noFill/>
+          <a:ln/>
+        </p:spPr>
+        <p:txBody>
+          <a:bodyPr wrap="square" lIns="0" tIns="0" rIns="0" bIns="0" rtlCol="0" anchor="ctr"/>
+          <a:lstStyle/>
+          <a:p>
+            <a:pPr indent="0" marL="0">
+              <a:buNone/>
+            </a:pPr>
+            <a:r>
+              <a:rPr lang="en-US" sz="2400" b="1" dirty="0">
+                <a:solidFill>
+                  <a:srgbClr val="102032"/>
+                </a:solidFill>
+                <a:latin typeface="Aptos Display" pitchFamily="34" charset="0"/>
+                <a:ea typeface="Aptos Display" pitchFamily="34" charset="-122"/>
+                <a:cs typeface="Aptos Display" pitchFamily="34" charset="-120"/>
+              </a:rPr>
+              <a:t>RTDL vs Native Runtime Path</a:t>
+            </a:r>
+            <a:endParaRPr lang="en-US" sz="2400" dirty="0"/>
+          </a:p>
+        </p:txBody>
+      </p:sp>
+      <p:sp>
+        <p:nvSpPr>
+          <p:cNvPr id="5" name="Text 3"/>
+          <p:cNvSpPr/>
+          <p:nvPr/>
+        </p:nvSpPr>
+        <p:spPr>
+          <a:xfrm>
+            <a:off x="658368" y="932688"/>
+            <a:ext cx="9875520" cy="274320"/>
+          </a:xfrm>
+          <a:prstGeom prst="rect">
+            <a:avLst/>
+          </a:prstGeom>
+          <a:noFill/>
+          <a:ln/>
+        </p:spPr>
+        <p:txBody>
+          <a:bodyPr wrap="square" lIns="0" tIns="0" rIns="0" bIns="0" rtlCol="0" anchor="ctr"/>
+          <a:lstStyle/>
+          <a:p>
+            <a:pPr indent="0" marL="0">
+              <a:buNone/>
+            </a:pPr>
+            <a:r>
+              <a:rPr lang="en-US" sz="1050" dirty="0">
+                <a:solidFill>
+                  <a:srgbClr val="5C6B77"/>
+                </a:solidFill>
+                <a:latin typeface="Aptos" pitchFamily="34" charset="0"/>
+                <a:ea typeface="Aptos" pitchFamily="34" charset="-122"/>
+                <a:cs typeface="Aptos" pitchFamily="34" charset="-120"/>
+              </a:rPr>
+              <a:t>The Python-like DSL is preserved, but the current runtime path is still too heavy compared with a thin native wrapper.</a:t>
+            </a:r>
+            <a:endParaRPr lang="en-US" sz="1050" dirty="0"/>
+          </a:p>
+        </p:txBody>
+      </p:sp>
+      <p:sp>
+        <p:nvSpPr>
+          <p:cNvPr id="6" name="Shape 4"/>
+          <p:cNvSpPr/>
+          <p:nvPr/>
+        </p:nvSpPr>
+        <p:spPr>
+          <a:xfrm>
+            <a:off x="731520" y="1417320"/>
+            <a:ext cx="5257800" cy="3977640"/>
+          </a:xfrm>
+          <a:prstGeom prst="roundRect">
+            <a:avLst>
+              <a:gd name="adj" fmla="val 1149"/>
+            </a:avLst>
+          </a:prstGeom>
+          <a:solidFill>
+            <a:srgbClr val="FFFFFF"/>
+          </a:solidFill>
+          <a:ln w="12700">
+            <a:solidFill>
+              <a:srgbClr val="FFFFFF">
+                <a:alpha val="0"/>
+              </a:srgbClr>
+            </a:solidFill>
+            <a:prstDash val="solid"/>
+          </a:ln>
+        </p:spPr>
+      </p:sp>
+      <p:sp>
+        <p:nvSpPr>
+          <p:cNvPr id="7" name="Text 5"/>
+          <p:cNvSpPr/>
+          <p:nvPr/>
+        </p:nvSpPr>
+        <p:spPr>
+          <a:xfrm>
+            <a:off x="877824" y="1527048"/>
+            <a:ext cx="4965192" cy="219456"/>
+          </a:xfrm>
+          <a:prstGeom prst="rect">
+            <a:avLst/>
+          </a:prstGeom>
+          <a:noFill/>
+          <a:ln/>
+        </p:spPr>
+        <p:txBody>
+          <a:bodyPr wrap="square" lIns="0" tIns="0" rIns="0" bIns="0" rtlCol="0" anchor="ctr"/>
+          <a:lstStyle/>
+          <a:p>
+            <a:pPr indent="0" marL="0">
+              <a:buNone/>
+            </a:pPr>
+            <a:r>
+              <a:rPr lang="en-US" sz="1400" b="1" dirty="0">
+                <a:solidFill>
+                  <a:srgbClr val="102032"/>
+                </a:solidFill>
+                <a:latin typeface="Aptos Display" pitchFamily="34" charset="0"/>
+                <a:ea typeface="Aptos Display" pitchFamily="34" charset="-122"/>
+                <a:cs typeface="Aptos Display" pitchFamily="34" charset="-120"/>
+              </a:rPr>
+              <a:t>Current RTDL + Embree path</a:t>
+            </a:r>
+            <a:endParaRPr lang="en-US" sz="1400" dirty="0"/>
+          </a:p>
+        </p:txBody>
+      </p:sp>
+      <p:sp>
+        <p:nvSpPr>
+          <p:cNvPr id="8" name="Text 6"/>
+          <p:cNvSpPr/>
+          <p:nvPr/>
+        </p:nvSpPr>
+        <p:spPr>
+          <a:xfrm>
+            <a:off x="877824" y="1801368"/>
+            <a:ext cx="4965192" cy="3483864"/>
+          </a:xfrm>
+          <a:prstGeom prst="rect">
+            <a:avLst/>
+          </a:prstGeom>
+          <a:noFill/>
+          <a:ln/>
+        </p:spPr>
+        <p:txBody>
+          <a:bodyPr wrap="square" lIns="0" tIns="0" rIns="0" bIns="0" rtlCol="0" anchor="t"/>
+          <a:lstStyle/>
+          <a:p>
+            <a:pPr indent="0" marL="0">
+              <a:buNone/>
+            </a:pPr>
+            <a:r>
+              <a:rPr lang="en-US" sz="1080" dirty="0">
+                <a:solidFill>
+                  <a:srgbClr val="102032"/>
+                </a:solidFill>
+                <a:latin typeface="Aptos" pitchFamily="34" charset="0"/>
+                <a:ea typeface="Aptos" pitchFamily="34" charset="-122"/>
+                <a:cs typeface="Aptos" pitchFamily="34" charset="-120"/>
+              </a:rPr>
+              <a:t>1. Python DSL kernel</a:t>
+            </a:r>
+            <a:endParaRPr lang="en-US" sz="1080" dirty="0"/>
+          </a:p>
+          <a:p>
+            <a:pPr indent="0" marL="0">
+              <a:buNone/>
+            </a:pPr>
+            <a:r>
+              <a:rPr lang="en-US" sz="1080" dirty="0">
+                <a:solidFill>
+                  <a:srgbClr val="102032"/>
+                </a:solidFill>
+                <a:latin typeface="Aptos" pitchFamily="34" charset="0"/>
+                <a:ea typeface="Aptos" pitchFamily="34" charset="-122"/>
+                <a:cs typeface="Aptos" pitchFamily="34" charset="-120"/>
+              </a:rPr>
+              <a:t>2. compile / validate / lower</a:t>
+            </a:r>
+            <a:endParaRPr lang="en-US" sz="1080" dirty="0"/>
+          </a:p>
+          <a:p>
+            <a:pPr indent="0" marL="0">
+              <a:buNone/>
+            </a:pPr>
+            <a:r>
+              <a:rPr lang="en-US" sz="1080" dirty="0">
+                <a:solidFill>
+                  <a:srgbClr val="102032"/>
+                </a:solidFill>
+                <a:latin typeface="Aptos" pitchFamily="34" charset="0"/>
+                <a:ea typeface="Aptos" pitchFamily="34" charset="-122"/>
+                <a:cs typeface="Aptos" pitchFamily="34" charset="-120"/>
+              </a:rPr>
+              <a:t>3. Python input normalization</a:t>
+            </a:r>
+            <a:endParaRPr lang="en-US" sz="1080" dirty="0"/>
+          </a:p>
+          <a:p>
+            <a:pPr indent="0" marL="0">
+              <a:buNone/>
+            </a:pPr>
+            <a:r>
+              <a:rPr lang="en-US" sz="1080" dirty="0">
+                <a:solidFill>
+                  <a:srgbClr val="102032"/>
+                </a:solidFill>
+                <a:latin typeface="Aptos" pitchFamily="34" charset="0"/>
+                <a:ea typeface="Aptos" pitchFamily="34" charset="-122"/>
+                <a:cs typeface="Aptos" pitchFamily="34" charset="-120"/>
+              </a:rPr>
+              <a:t>4. ctypes marshaling</a:t>
+            </a:r>
+            <a:endParaRPr lang="en-US" sz="1080" dirty="0"/>
+          </a:p>
+          <a:p>
+            <a:pPr indent="0" marL="0">
+              <a:buNone/>
+            </a:pPr>
+            <a:r>
+              <a:rPr lang="en-US" sz="1080" dirty="0">
+                <a:solidFill>
+                  <a:srgbClr val="102032"/>
+                </a:solidFill>
+                <a:latin typeface="Aptos" pitchFamily="34" charset="0"/>
+                <a:ea typeface="Aptos" pitchFamily="34" charset="-122"/>
+                <a:cs typeface="Aptos" pitchFamily="34" charset="-120"/>
+              </a:rPr>
+              <a:t>5. native Embree backend</a:t>
+            </a:r>
+            <a:endParaRPr lang="en-US" sz="1080" dirty="0"/>
+          </a:p>
+          <a:p>
+            <a:pPr indent="0" marL="0">
+              <a:buNone/>
+            </a:pPr>
+            <a:r>
+              <a:rPr lang="en-US" sz="1080" dirty="0">
+                <a:solidFill>
+                  <a:srgbClr val="102032"/>
+                </a:solidFill>
+                <a:latin typeface="Aptos" pitchFamily="34" charset="0"/>
+                <a:ea typeface="Aptos" pitchFamily="34" charset="-122"/>
+                <a:cs typeface="Aptos" pitchFamily="34" charset="-120"/>
+              </a:rPr>
+              <a:t>6. native rows</a:t>
+            </a:r>
+            <a:endParaRPr lang="en-US" sz="1080" dirty="0"/>
+          </a:p>
+          <a:p>
+            <a:pPr indent="0" marL="0">
+              <a:buNone/>
+            </a:pPr>
+            <a:r>
+              <a:rPr lang="en-US" sz="1080" dirty="0">
+                <a:solidFill>
+                  <a:srgbClr val="102032"/>
+                </a:solidFill>
+                <a:latin typeface="Aptos" pitchFamily="34" charset="0"/>
+                <a:ea typeface="Aptos" pitchFamily="34" charset="-122"/>
+                <a:cs typeface="Aptos" pitchFamily="34" charset="-120"/>
+              </a:rPr>
+              <a:t>7. Python dict rows</a:t>
+            </a:r>
+            <a:endParaRPr lang="en-US" sz="1080" dirty="0"/>
+          </a:p>
+          <a:p>
+            <a:pPr indent="0" marL="0">
+              <a:buNone/>
+            </a:pPr>
+            <a:endParaRPr lang="en-US" sz="1080" dirty="0"/>
+          </a:p>
+          <a:p>
+            <a:pPr indent="0" marL="0">
+              <a:buNone/>
+            </a:pPr>
+            <a:r>
+              <a:rPr lang="en-US" sz="1080" dirty="0">
+                <a:solidFill>
+                  <a:srgbClr val="102032"/>
+                </a:solidFill>
+                <a:latin typeface="Aptos" pitchFamily="34" charset="0"/>
+                <a:ea typeface="Aptos" pitchFamily="34" charset="-122"/>
+                <a:cs typeface="Aptos" pitchFamily="34" charset="-120"/>
+              </a:rPr>
+              <a:t>Measured Goal 15 gap:</a:t>
+            </a:r>
+            <a:endParaRPr lang="en-US" sz="1080" dirty="0"/>
+          </a:p>
+          <a:p>
+            <a:pPr indent="0" marL="0">
+              <a:buNone/>
+            </a:pPr>
+            <a:r>
+              <a:rPr lang="en-US" sz="1080" dirty="0">
+                <a:solidFill>
+                  <a:srgbClr val="102032"/>
+                </a:solidFill>
+                <a:latin typeface="Aptos" pitchFamily="34" charset="0"/>
+                <a:ea typeface="Aptos" pitchFamily="34" charset="-122"/>
+                <a:cs typeface="Aptos" pitchFamily="34" charset="-120"/>
+              </a:rPr>
+              <a:t>- lsi: about 7.6x slower than native</a:t>
+            </a:r>
+            <a:endParaRPr lang="en-US" sz="1080" dirty="0"/>
+          </a:p>
+          <a:p>
+            <a:pPr indent="0" marL="0">
+              <a:buNone/>
+            </a:pPr>
+            <a:r>
+              <a:rPr lang="en-US" sz="1080" dirty="0">
+                <a:solidFill>
+                  <a:srgbClr val="102032"/>
+                </a:solidFill>
+                <a:latin typeface="Aptos" pitchFamily="34" charset="0"/>
+                <a:ea typeface="Aptos" pitchFamily="34" charset="-122"/>
+                <a:cs typeface="Aptos" pitchFamily="34" charset="-120"/>
+              </a:rPr>
+              <a:t>- pip: about 37x slower than native</a:t>
+            </a:r>
+            <a:endParaRPr lang="en-US" sz="1080" dirty="0"/>
+          </a:p>
+        </p:txBody>
+      </p:sp>
+      <p:sp>
+        <p:nvSpPr>
+          <p:cNvPr id="9" name="Shape 7"/>
+          <p:cNvSpPr/>
+          <p:nvPr/>
+        </p:nvSpPr>
+        <p:spPr>
+          <a:xfrm>
+            <a:off x="6217920" y="1417320"/>
+            <a:ext cx="5257800" cy="3977640"/>
+          </a:xfrm>
+          <a:prstGeom prst="roundRect">
+            <a:avLst>
+              <a:gd name="adj" fmla="val 1149"/>
+            </a:avLst>
+          </a:prstGeom>
+          <a:solidFill>
+            <a:srgbClr val="E9F1F4"/>
+          </a:solidFill>
+          <a:ln w="12700">
+            <a:solidFill>
+              <a:srgbClr val="E9F1F4">
+                <a:alpha val="0"/>
+              </a:srgbClr>
+            </a:solidFill>
+            <a:prstDash val="solid"/>
+          </a:ln>
+        </p:spPr>
+      </p:sp>
+      <p:sp>
+        <p:nvSpPr>
+          <p:cNvPr id="10" name="Text 8"/>
+          <p:cNvSpPr/>
+          <p:nvPr/>
+        </p:nvSpPr>
+        <p:spPr>
+          <a:xfrm>
+            <a:off x="6364224" y="1527048"/>
+            <a:ext cx="4965192" cy="219456"/>
+          </a:xfrm>
+          <a:prstGeom prst="rect">
+            <a:avLst/>
+          </a:prstGeom>
+          <a:noFill/>
+          <a:ln/>
+        </p:spPr>
+        <p:txBody>
+          <a:bodyPr wrap="square" lIns="0" tIns="0" rIns="0" bIns="0" rtlCol="0" anchor="ctr"/>
+          <a:lstStyle/>
+          <a:p>
+            <a:pPr indent="0" marL="0">
+              <a:buNone/>
+            </a:pPr>
+            <a:r>
+              <a:rPr lang="en-US" sz="1400" b="1" dirty="0">
+                <a:solidFill>
+                  <a:srgbClr val="102032"/>
+                </a:solidFill>
+                <a:latin typeface="Aptos Display" pitchFamily="34" charset="0"/>
+                <a:ea typeface="Aptos Display" pitchFamily="34" charset="-122"/>
+                <a:cs typeface="Aptos Display" pitchFamily="34" charset="-120"/>
+              </a:rPr>
+              <a:t>Pure C++ + Embree path</a:t>
+            </a:r>
+            <a:endParaRPr lang="en-US" sz="1400" dirty="0"/>
+          </a:p>
+        </p:txBody>
+      </p:sp>
+      <p:sp>
+        <p:nvSpPr>
+          <p:cNvPr id="11" name="Text 9"/>
+          <p:cNvSpPr/>
+          <p:nvPr/>
+        </p:nvSpPr>
+        <p:spPr>
+          <a:xfrm>
+            <a:off x="6364224" y="1801368"/>
+            <a:ext cx="4965192" cy="3483864"/>
+          </a:xfrm>
+          <a:prstGeom prst="rect">
+            <a:avLst/>
+          </a:prstGeom>
+          <a:noFill/>
+          <a:ln/>
+        </p:spPr>
+        <p:txBody>
+          <a:bodyPr wrap="square" lIns="0" tIns="0" rIns="0" bIns="0" rtlCol="0" anchor="t"/>
+          <a:lstStyle/>
+          <a:p>
+            <a:pPr indent="0" marL="0">
+              <a:buNone/>
+            </a:pPr>
+            <a:r>
+              <a:rPr lang="en-US" sz="1080" dirty="0">
+                <a:solidFill>
+                  <a:srgbClr val="102032"/>
+                </a:solidFill>
+                <a:latin typeface="Aptos" pitchFamily="34" charset="0"/>
+                <a:ea typeface="Aptos" pitchFamily="34" charset="-122"/>
+                <a:cs typeface="Aptos" pitchFamily="34" charset="-120"/>
+              </a:rPr>
+              <a:t>1. native input arrays</a:t>
+            </a:r>
+            <a:endParaRPr lang="en-US" sz="1080" dirty="0"/>
+          </a:p>
+          <a:p>
+            <a:pPr indent="0" marL="0">
+              <a:buNone/>
+            </a:pPr>
+            <a:r>
+              <a:rPr lang="en-US" sz="1080" dirty="0">
+                <a:solidFill>
+                  <a:srgbClr val="102032"/>
+                </a:solidFill>
+                <a:latin typeface="Aptos" pitchFamily="34" charset="0"/>
+                <a:ea typeface="Aptos" pitchFamily="34" charset="-122"/>
+                <a:cs typeface="Aptos" pitchFamily="34" charset="-120"/>
+              </a:rPr>
+              <a:t>2. direct native call</a:t>
+            </a:r>
+            <a:endParaRPr lang="en-US" sz="1080" dirty="0"/>
+          </a:p>
+          <a:p>
+            <a:pPr indent="0" marL="0">
+              <a:buNone/>
+            </a:pPr>
+            <a:r>
+              <a:rPr lang="en-US" sz="1080" dirty="0">
+                <a:solidFill>
+                  <a:srgbClr val="102032"/>
+                </a:solidFill>
+                <a:latin typeface="Aptos" pitchFamily="34" charset="0"/>
+                <a:ea typeface="Aptos" pitchFamily="34" charset="-122"/>
+                <a:cs typeface="Aptos" pitchFamily="34" charset="-120"/>
+              </a:rPr>
+              <a:t>3. native rows</a:t>
+            </a:r>
+            <a:endParaRPr lang="en-US" sz="1080" dirty="0"/>
+          </a:p>
+          <a:p>
+            <a:pPr indent="0" marL="0">
+              <a:buNone/>
+            </a:pPr>
+            <a:r>
+              <a:rPr lang="en-US" sz="1080" dirty="0">
+                <a:solidFill>
+                  <a:srgbClr val="102032"/>
+                </a:solidFill>
+                <a:latin typeface="Aptos" pitchFamily="34" charset="0"/>
+                <a:ea typeface="Aptos" pitchFamily="34" charset="-122"/>
+                <a:cs typeface="Aptos" pitchFamily="34" charset="-120"/>
+              </a:rPr>
+              <a:t>4. output serialization</a:t>
+            </a:r>
+            <a:endParaRPr lang="en-US" sz="1080" dirty="0"/>
+          </a:p>
+          <a:p>
+            <a:pPr indent="0" marL="0">
+              <a:buNone/>
+            </a:pPr>
+            <a:endParaRPr lang="en-US" sz="1080" dirty="0"/>
+          </a:p>
+          <a:p>
+            <a:pPr indent="0" marL="0">
+              <a:buNone/>
+            </a:pPr>
+            <a:r>
+              <a:rPr lang="en-US" sz="1080" dirty="0">
+                <a:solidFill>
+                  <a:srgbClr val="102032"/>
+                </a:solidFill>
+                <a:latin typeface="Aptos" pitchFamily="34" charset="0"/>
+                <a:ea typeface="Aptos" pitchFamily="34" charset="-122"/>
+                <a:cs typeface="Aptos" pitchFamily="34" charset="-120"/>
+              </a:rPr>
+              <a:t>The current comparison uses the same Embree-native core, so the gap mainly comes from RTDL host/runtime overhead rather than a different traversal engine.</a:t>
+            </a:r>
+            <a:endParaRPr lang="en-US" sz="1080" dirty="0"/>
+          </a:p>
+        </p:txBody>
+      </p:sp>
+      <p:sp>
+        <p:nvSpPr>
+          <p:cNvPr id="12" name="Shape 10"/>
+          <p:cNvSpPr/>
+          <p:nvPr/>
+        </p:nvSpPr>
+        <p:spPr>
+          <a:xfrm>
+            <a:off x="777240" y="5577840"/>
+            <a:ext cx="10698480" cy="621792"/>
+          </a:xfrm>
+          <a:prstGeom prst="roundRect">
+            <a:avLst>
+              <a:gd name="adj" fmla="val 7353"/>
+            </a:avLst>
+          </a:prstGeom>
+          <a:solidFill>
+            <a:srgbClr val="F5EAD7"/>
+          </a:solidFill>
+          <a:ln w="12700">
+            <a:solidFill>
+              <a:srgbClr val="F5EAD7">
+                <a:alpha val="0"/>
+              </a:srgbClr>
+            </a:solidFill>
+            <a:prstDash val="solid"/>
+          </a:ln>
+        </p:spPr>
+      </p:sp>
+      <p:sp>
+        <p:nvSpPr>
+          <p:cNvPr id="13" name="Text 11"/>
+          <p:cNvSpPr/>
+          <p:nvPr/>
+        </p:nvSpPr>
+        <p:spPr>
+          <a:xfrm>
+            <a:off x="923544" y="5687568"/>
+            <a:ext cx="10405872" cy="219456"/>
+          </a:xfrm>
+          <a:prstGeom prst="rect">
+            <a:avLst/>
+          </a:prstGeom>
+          <a:noFill/>
+          <a:ln/>
+        </p:spPr>
+        <p:txBody>
+          <a:bodyPr wrap="square" lIns="0" tIns="0" rIns="0" bIns="0" rtlCol="0" anchor="ctr"/>
+          <a:lstStyle/>
+          <a:p>
+            <a:pPr indent="0" marL="0">
+              <a:buNone/>
+            </a:pPr>
+            <a:r>
+              <a:rPr lang="en-US" sz="1400" b="1" dirty="0">
+                <a:solidFill>
+                  <a:srgbClr val="102032"/>
+                </a:solidFill>
+                <a:latin typeface="Aptos Display" pitchFamily="34" charset="0"/>
+                <a:ea typeface="Aptos Display" pitchFamily="34" charset="-122"/>
+                <a:cs typeface="Aptos Display" pitchFamily="34" charset="-120"/>
+              </a:rPr>
+              <a:t>Design implication</a:t>
+            </a:r>
+            <a:endParaRPr lang="en-US" sz="1400" dirty="0"/>
+          </a:p>
+        </p:txBody>
+      </p:sp>
+      <p:sp>
+        <p:nvSpPr>
+          <p:cNvPr id="14" name="Text 12"/>
+          <p:cNvSpPr/>
+          <p:nvPr/>
+        </p:nvSpPr>
+        <p:spPr>
+          <a:xfrm>
+            <a:off x="923544" y="5961888"/>
+            <a:ext cx="10405872" cy="128016"/>
+          </a:xfrm>
+          <a:prstGeom prst="rect">
+            <a:avLst/>
+          </a:prstGeom>
+          <a:noFill/>
+          <a:ln/>
+        </p:spPr>
+        <p:txBody>
+          <a:bodyPr wrap="square" lIns="0" tIns="0" rIns="0" bIns="0" rtlCol="0" anchor="t"/>
+          <a:lstStyle/>
+          <a:p>
+            <a:pPr indent="0" marL="0">
+              <a:buNone/>
+            </a:pPr>
+            <a:r>
+              <a:rPr lang="en-US" sz="1080" dirty="0">
+                <a:solidFill>
+                  <a:srgbClr val="102032"/>
+                </a:solidFill>
+                <a:latin typeface="Aptos" pitchFamily="34" charset="0"/>
+                <a:ea typeface="Aptos" pitchFamily="34" charset="-122"/>
+                <a:cs typeface="Aptos" pitchFamily="34" charset="-120"/>
+              </a:rPr>
+              <a:t>Keep the Python-like DSL, but move execution toward compiled plans plus flat native-ready buffers. Python should remain the control plane, not the main data plane.</a:t>
+            </a:r>
+            <a:endParaRPr lang="en-US" sz="1080" dirty="0"/>
+          </a:p>
+        </p:txBody>
+      </p:sp>
+      <p:sp>
+        <p:nvSpPr>
+          <p:cNvPr id="15" name="Text 13"/>
+          <p:cNvSpPr/>
+          <p:nvPr/>
+        </p:nvSpPr>
+        <p:spPr>
+          <a:xfrm>
+            <a:off x="10058400" y="6565392"/>
+            <a:ext cx="1645920" cy="128016"/>
+          </a:xfrm>
+          <a:prstGeom prst="rect">
+            <a:avLst/>
+          </a:prstGeom>
+          <a:noFill/>
+          <a:ln/>
+        </p:spPr>
+        <p:txBody>
+          <a:bodyPr wrap="square" lIns="0" tIns="0" rIns="0" bIns="0" rtlCol="0" anchor="ctr"/>
+          <a:lstStyle/>
+          <a:p>
+            <a:pPr algn="r" indent="0" marL="0">
+              <a:buNone/>
+            </a:pPr>
+            <a:r>
+              <a:rPr lang="en-US" sz="850" dirty="0">
+                <a:solidFill>
+                  <a:srgbClr val="D7E0E6"/>
+                </a:solidFill>
+                <a:latin typeface="Aptos" pitchFamily="34" charset="0"/>
+                <a:ea typeface="Aptos" pitchFamily="34" charset="-122"/>
+                <a:cs typeface="Aptos" pitchFamily="34" charset="-120"/>
+              </a:rPr>
+              <a:t>RTDL summary · 15/15</a:t>
             </a:r>
             <a:endParaRPr lang="en-US" sz="850" dirty="0"/>
           </a:p>
@@ -7117,7 +7963,7 @@
                 <a:ea typeface="Aptos" pitchFamily="34" charset="-122"/>
                 <a:cs typeface="Aptos" pitchFamily="34" charset="-120"/>
               </a:rPr>
-              <a:t>RTDL summary · 2/14</a:t>
+              <a:t>RTDL summary · 2/15</a:t>
             </a:r>
             <a:endParaRPr lang="en-US" sz="850" dirty="0"/>
           </a:p>
@@ -7993,7 +8839,7 @@
                 <a:ea typeface="Aptos" pitchFamily="34" charset="-122"/>
                 <a:cs typeface="Aptos" pitchFamily="34" charset="-120"/>
               </a:rPr>
-              <a:t>RTDL summary · 3/14</a:t>
+              <a:t>RTDL summary · 3/15</a:t>
             </a:r>
             <a:endParaRPr lang="en-US" sz="850" dirty="0"/>
           </a:p>
@@ -8794,7 +9640,7 @@
                 <a:ea typeface="Aptos" pitchFamily="34" charset="-122"/>
                 <a:cs typeface="Aptos" pitchFamily="34" charset="-120"/>
               </a:rPr>
-              <a:t>RTDL summary · 4/14</a:t>
+              <a:t>RTDL summary · 4/15</a:t>
             </a:r>
             <a:endParaRPr lang="en-US" sz="850" dirty="0"/>
           </a:p>
@@ -10122,7 +10968,7 @@
                 <a:ea typeface="Aptos" pitchFamily="34" charset="-122"/>
                 <a:cs typeface="Aptos" pitchFamily="34" charset="-120"/>
               </a:rPr>
-              <a:t>RTDL summary · 5/14</a:t>
+              <a:t>RTDL summary · 5/15</a:t>
             </a:r>
             <a:endParaRPr lang="en-US" sz="850" dirty="0"/>
           </a:p>
@@ -11427,7 +12273,7 @@
                 <a:ea typeface="Aptos" pitchFamily="34" charset="-122"/>
                 <a:cs typeface="Aptos" pitchFamily="34" charset="-120"/>
               </a:rPr>
-              <a:t>RTDL summary · 6/14</a:t>
+              <a:t>RTDL summary · 6/15</a:t>
             </a:r>
             <a:endParaRPr lang="en-US" sz="850" dirty="0"/>
           </a:p>
@@ -12283,7 +13129,7 @@
                 <a:ea typeface="Aptos" pitchFamily="34" charset="-122"/>
                 <a:cs typeface="Aptos" pitchFamily="34" charset="-120"/>
               </a:rPr>
-              <a:t>RTDL summary · 7/14</a:t>
+              <a:t>RTDL summary · 7/15</a:t>
             </a:r>
             <a:endParaRPr lang="en-US" sz="850" dirty="0"/>
           </a:p>
@@ -13265,7 +14111,7 @@
                 <a:ea typeface="Aptos" pitchFamily="34" charset="-122"/>
                 <a:cs typeface="Aptos" pitchFamily="34" charset="-120"/>
               </a:rPr>
-              <a:t>16 rounds</a:t>
+              <a:t>19 rounds</a:t>
             </a:r>
             <a:endParaRPr lang="en-US" sz="1020" dirty="0"/>
           </a:p>
@@ -13282,7 +14128,7 @@
                 <a:ea typeface="Aptos" pitchFamily="34" charset="-122"/>
                 <a:cs typeface="Aptos" pitchFamily="34" charset="-120"/>
               </a:rPr>
-              <a:t>44 external reports</a:t>
+              <a:t>56 external reports</a:t>
             </a:r>
             <a:endParaRPr lang="en-US" sz="1020" dirty="0"/>
           </a:p>
@@ -13299,7 +14145,7 @@
                 <a:ea typeface="Aptos" pitchFamily="34" charset="-122"/>
                 <a:cs typeface="Aptos" pitchFamily="34" charset="-120"/>
               </a:rPr>
-              <a:t>251 archived project snapshots</a:t>
+              <a:t>281 archived project snapshots</a:t>
             </a:r>
             <a:endParaRPr lang="en-US" sz="1020" dirty="0"/>
           </a:p>
@@ -13338,7 +14184,7 @@
                 <a:ea typeface="Aptos" pitchFamily="34" charset="-122"/>
                 <a:cs typeface="Aptos" pitchFamily="34" charset="-120"/>
               </a:rPr>
-              <a:t>RTDL summary · 8/14</a:t>
+              <a:t>RTDL summary · 8/15</a:t>
             </a:r>
             <a:endParaRPr lang="en-US" sz="850" dirty="0"/>
           </a:p>
@@ -14164,7 +15010,7 @@
                 <a:ea typeface="Aptos" pitchFamily="34" charset="-122"/>
                 <a:cs typeface="Aptos" pitchFamily="34" charset="-120"/>
               </a:rPr>
-              <a:t>RTDL summary · 9/14</a:t>
+              <a:t>RTDL summary · 9/15</a:t>
             </a:r>
             <a:endParaRPr lang="en-US" sz="850" dirty="0"/>
           </a:p>

</xml_diff>

<commit_message>
Refresh runtime docs and status deck for Goal 19
</commit_message>
<xml_diff>
--- a/rtdl_status_summary.pptx
+++ b/rtdl_status_summary.pptx
@@ -4651,7 +4651,7 @@
                 <a:ea typeface="Aptos" pitchFamily="34" charset="-122"/>
                 <a:cs typeface="Aptos" pitchFamily="34" charset="-120"/>
               </a:rPr>
-              <a:t>GitHub and local repo are in sync through Goal 17 first-slice closure, including the low-overhead Embree runtime path and refreshed history dashboard.</a:t>
+              <a:t>GitHub and local repo are in sync through Goal 19 closure, including the first-class raw Embree runtime path, the native-vs-RTDL performance comparison, and the refreshed history dashboard.</a:t>
             </a:r>
             <a:endParaRPr lang="en-US" sz="1080" dirty="0"/>
           </a:p>
@@ -4988,7 +4988,7 @@
                 <a:ea typeface="Courier New" pitchFamily="34" charset="-122"/>
                 <a:cs typeface="Courier New" pitchFamily="34" charset="-120"/>
               </a:rPr>
-              <a:t>- CPU + Embree runtimes plus native C++ comparison slice</a:t>
+              <a:t>- CPU + Embree runtimes plus native C++ comparison slices</a:t>
             </a:r>
             <a:endParaRPr lang="en-US" sz="980" dirty="0"/>
           </a:p>
@@ -5022,7 +5022,7 @@
                 <a:ea typeface="Courier New" pitchFamily="34" charset="-122"/>
                 <a:cs typeface="Courier New" pitchFamily="34" charset="-120"/>
               </a:rPr>
-              <a:t>- 74 passing tests</a:t>
+              <a:t>- 80 passing tests</a:t>
             </a:r>
             <a:endParaRPr lang="en-US" sz="980" dirty="0"/>
           </a:p>
@@ -5039,7 +5039,24 @@
                 <a:ea typeface="Courier New" pitchFamily="34" charset="-122"/>
                 <a:cs typeface="Courier New" pitchFamily="34" charset="-120"/>
               </a:rPr>
-              <a:t>- 16 archived review/revision rounds</a:t>
+              <a:t>- 21 archived review/revision rounds</a:t>
+            </a:r>
+            <a:endParaRPr lang="en-US" sz="980" dirty="0"/>
+          </a:p>
+          <a:p>
+            <a:pPr indent="0" marL="0">
+              <a:buNone/>
+            </a:pPr>
+            <a:r>
+              <a:rPr lang="en-US" sz="980" dirty="0">
+                <a:solidFill>
+                  <a:srgbClr val="102032"/>
+                </a:solidFill>
+                <a:latin typeface="Courier New" pitchFamily="34" charset="0"/>
+                <a:ea typeface="Courier New" pitchFamily="34" charset="-122"/>
+                <a:cs typeface="Courier New" pitchFamily="34" charset="-120"/>
+              </a:rPr>
+              <a:t>- First-class raw + prepared raw runtime modes</a:t>
             </a:r>
             <a:endParaRPr lang="en-US" sz="980" dirty="0"/>
           </a:p>
@@ -6800,7 +6817,7 @@
                 <a:ea typeface="Aptos" pitchFamily="34" charset="-122"/>
                 <a:cs typeface="Aptos" pitchFamily="34" charset="-120"/>
               </a:rPr>
-              <a:t>The Python-like DSL is preserved, but the current runtime path is still too heavy compared with a thin native wrapper.</a:t>
+              <a:t>Goal 19 sharpened the conclusion: the DSL is viable, but only the low-overhead runtime modes are close to native.</a:t>
             </a:r>
             <a:endParaRPr lang="en-US" sz="1050" dirty="0"/>
           </a:p>
@@ -7032,7 +7049,7 @@
                 <a:ea typeface="Aptos" pitchFamily="34" charset="-122"/>
                 <a:cs typeface="Aptos" pitchFamily="34" charset="-120"/>
               </a:rPr>
-              <a:t>Measured Goal 15 gap:</a:t>
+              <a:t>Goal 19 larger-profile gap:</a:t>
             </a:r>
             <a:endParaRPr lang="en-US" sz="1080" dirty="0"/>
           </a:p>
@@ -7049,7 +7066,7 @@
                 <a:ea typeface="Aptos" pitchFamily="34" charset="-122"/>
                 <a:cs typeface="Aptos" pitchFamily="34" charset="-120"/>
               </a:rPr>
-              <a:t>- lsi: about 7.6x slower than native</a:t>
+              <a:t>- lsi dict path: about 101.6x slower than native</a:t>
             </a:r>
             <a:endParaRPr lang="en-US" sz="1080" dirty="0"/>
           </a:p>
@@ -7066,7 +7083,7 @@
                 <a:ea typeface="Aptos" pitchFamily="34" charset="-122"/>
                 <a:cs typeface="Aptos" pitchFamily="34" charset="-120"/>
               </a:rPr>
-              <a:t>- pip: about 37x slower than native</a:t>
+              <a:t>- pip dict path: about 225.3x slower than native</a:t>
             </a:r>
             <a:endParaRPr lang="en-US" sz="1080" dirty="0"/>
           </a:p>
@@ -7247,7 +7264,41 @@
                 <a:ea typeface="Aptos" pitchFamily="34" charset="-122"/>
                 <a:cs typeface="Aptos" pitchFamily="34" charset="-120"/>
               </a:rPr>
-              <a:t>The current comparison uses the same Embree-native core, so the gap mainly comes from RTDL host/runtime overhead rather than a different traversal engine.</a:t>
+              <a:t>Goal 19 larger-profile result:</a:t>
+            </a:r>
+            <a:endParaRPr lang="en-US" sz="1080" dirty="0"/>
+          </a:p>
+          <a:p>
+            <a:pPr indent="0" marL="0">
+              <a:buNone/>
+            </a:pPr>
+            <a:r>
+              <a:rPr lang="en-US" sz="1080" dirty="0">
+                <a:solidFill>
+                  <a:srgbClr val="102032"/>
+                </a:solidFill>
+                <a:latin typeface="Aptos" pitchFamily="34" charset="0"/>
+                <a:ea typeface="Aptos" pitchFamily="34" charset="-122"/>
+                <a:cs typeface="Aptos" pitchFamily="34" charset="-120"/>
+              </a:rPr>
+              <a:t>- lsi raw/prepared-raw: about 0.98x / 0.89x of native</a:t>
+            </a:r>
+            <a:endParaRPr lang="en-US" sz="1080" dirty="0"/>
+          </a:p>
+          <a:p>
+            <a:pPr indent="0" marL="0">
+              <a:buNone/>
+            </a:pPr>
+            <a:r>
+              <a:rPr lang="en-US" sz="1080" dirty="0">
+                <a:solidFill>
+                  <a:srgbClr val="102032"/>
+                </a:solidFill>
+                <a:latin typeface="Aptos" pitchFamily="34" charset="0"/>
+                <a:ea typeface="Aptos" pitchFamily="34" charset="-122"/>
+                <a:cs typeface="Aptos" pitchFamily="34" charset="-120"/>
+              </a:rPr>
+              <a:t>- pip raw/prepared-raw: about 0.87x / 0.83x of native</a:t>
             </a:r>
             <a:endParaRPr lang="en-US" sz="1080" dirty="0"/>
           </a:p>
@@ -7354,7 +7405,7 @@
                 <a:ea typeface="Aptos" pitchFamily="34" charset="-122"/>
                 <a:cs typeface="Aptos" pitchFamily="34" charset="-120"/>
               </a:rPr>
-              <a:t>Keep the Python-like DSL, but move execution toward compiled plans plus flat native-ready buffers. Python should remain the control plane, not the main data plane.</a:t>
+              <a:t>Keep the Python-like DSL. Treat dict-return execution as a convenience mode, and treat raw / prepared-raw execution as the serious performance path. Python should remain the control plane, not the main data plane.</a:t>
             </a:r>
             <a:endParaRPr lang="en-US" sz="1080" dirty="0"/>
           </a:p>

</xml_diff>

<commit_message>
Reset project vision and v0.1 framing
</commit_message>
<xml_diff>
--- a/rtdl_status_summary.pptx
+++ b/rtdl_status_summary.pptx
@@ -2315,7 +2315,7 @@
                 <a:ea typeface="Aptos" pitchFamily="34" charset="-122"/>
                 <a:cs typeface="Aptos" pitchFamily="34" charset="-120"/>
               </a:rPr>
-              <a:t>Research status as of March 31, 2026</a:t>
+              <a:t>Research status as of April 1, 2026</a:t>
             </a:r>
             <a:endParaRPr lang="en-US" sz="1400" dirty="0"/>
           </a:p>
@@ -2422,7 +2422,7 @@
                 <a:ea typeface="Aptos" pitchFamily="34" charset="-122"/>
                 <a:cs typeface="Aptos" pitchFamily="34" charset="-120"/>
               </a:rPr>
-              <a:t>Lower the difficulty of non-graphics ray tracing programming by about 10x.</a:t>
+              <a:t>Whole-project goal: a DSL for non-graphical, re-purposed RT-based applications across multiple backends and ecosystems.</a:t>
             </a:r>
             <a:endParaRPr lang="en-US" sz="1080" dirty="0"/>
           </a:p>
@@ -2445,7 +2445,7 @@
                 <a:ea typeface="Aptos" pitchFamily="34" charset="-122"/>
                 <a:cs typeface="Aptos" pitchFamily="34" charset="-120"/>
               </a:rPr>
-              <a:t>Initial focus: RayJoin-style workloads. Users stay in Python; RTDL handles geometry contracts, traversal, refinement, launch planning, and backend wiring.</a:t>
+              <a:t>Current v0.1 slice: RayJoin-style workloads on the local Embree path first, with future NVIDIA bring-up when hardware is available.</a:t>
             </a:r>
             <a:endParaRPr lang="en-US" sz="1080" dirty="0"/>
           </a:p>
@@ -7608,7 +7608,7 @@
                 <a:ea typeface="Aptos" pitchFamily="34" charset="-122"/>
                 <a:cs typeface="Aptos" pitchFamily="34" charset="-120"/>
               </a:rPr>
-              <a:t>Why this project exists and why RayJoin is the right first target.</a:t>
+              <a:t>Broad multi-backend project vision, with RayJoin as the current v0.1 vertical slice.</a:t>
             </a:r>
             <a:endParaRPr lang="en-US" sz="1050" dirty="0"/>
           </a:p>

</xml_diff>

<commit_message>
Refresh live docs and checkpoint Goal 50 PostGIS work
</commit_message>
<xml_diff>
--- a/rtdl_status_summary.pptx
+++ b/rtdl_status_summary.pptx
@@ -2315,7 +2315,7 @@
                 <a:ea typeface="Aptos" pitchFamily="34" charset="-122"/>
                 <a:cs typeface="Aptos" pitchFamily="34" charset="-120"/>
               </a:rPr>
-              <a:t>Research status as of April 1, 2026</a:t>
+              <a:t>Research status as of April 3, 2026</a:t>
             </a:r>
             <a:endParaRPr lang="en-US" sz="1400" dirty="0"/>
           </a:p>
@@ -2445,7 +2445,7 @@
                 <a:ea typeface="Aptos" pitchFamily="34" charset="-122"/>
                 <a:cs typeface="Aptos" pitchFamily="34" charset="-120"/>
               </a:rPr>
-              <a:t>Current v0.1 slice: RayJoin-style workloads on the local Embree path first, with future NVIDIA bring-up when hardware is available.</a:t>
+              <a:t>Current v0.1 slice: RayJoin-style workloads validated through a native oracle plus Embree and OptiX, with PostGIS ground-truth comparison in progress.</a:t>
             </a:r>
             <a:endParaRPr lang="en-US" sz="1080" dirty="0"/>
           </a:p>
@@ -2552,7 +2552,7 @@
                 <a:ea typeface="Aptos Display" pitchFamily="34" charset="-122"/>
                 <a:cs typeface="Aptos Display" pitchFamily="34" charset="-120"/>
               </a:rPr>
-              <a:t>4</a:t>
+              <a:t>6</a:t>
             </a:r>
             <a:endParaRPr lang="en-US" sz="1800" dirty="0"/>
           </a:p>
@@ -2659,7 +2659,7 @@
                 <a:ea typeface="Aptos Display" pitchFamily="34" charset="-122"/>
                 <a:cs typeface="Aptos Display" pitchFamily="34" charset="-120"/>
               </a:rPr>
-              <a:t>32</a:t>
+              <a:t>160</a:t>
             </a:r>
             <a:endParaRPr lang="en-US" sz="1800" dirty="0"/>
           </a:p>
@@ -2727,7 +2727,7 @@
                 <a:ea typeface="Aptos" pitchFamily="34" charset="-122"/>
                 <a:cs typeface="Aptos" pitchFamily="34" charset="-120"/>
               </a:rPr>
-              <a:t>Review Rounds</a:t>
+              <a:t>Review</a:t>
             </a:r>
             <a:endParaRPr lang="en-US" sz="900" dirty="0"/>
           </a:p>
@@ -2766,7 +2766,7 @@
                 <a:ea typeface="Aptos Display" pitchFamily="34" charset="-122"/>
                 <a:cs typeface="Aptos Display" pitchFamily="34" charset="-120"/>
               </a:rPr>
-              <a:t>8</a:t>
+              <a:t>50+</a:t>
             </a:r>
             <a:endParaRPr lang="en-US" sz="1800" dirty="0"/>
           </a:p>
@@ -2834,7 +2834,7 @@
                 <a:ea typeface="Aptos" pitchFamily="34" charset="-122"/>
                 <a:cs typeface="Aptos" pitchFamily="34" charset="-120"/>
               </a:rPr>
-              <a:t>Local Runtime</a:t>
+              <a:t>Validated RT</a:t>
             </a:r>
             <a:endParaRPr lang="en-US" sz="900" dirty="0"/>
           </a:p>
@@ -2873,7 +2873,7 @@
                 <a:ea typeface="Aptos Display" pitchFamily="34" charset="-122"/>
                 <a:cs typeface="Aptos Display" pitchFamily="34" charset="-120"/>
               </a:rPr>
-              <a:t>Embree</a:t>
+              <a:t>CPU + GPU</a:t>
             </a:r>
             <a:endParaRPr lang="en-US" sz="1800" dirty="0"/>
           </a:p>
@@ -2941,7 +2941,7 @@
                 <a:ea typeface="Aptos" pitchFamily="34" charset="-122"/>
                 <a:cs typeface="Aptos" pitchFamily="34" charset="-120"/>
               </a:rPr>
-              <a:t>Execution Modes</a:t>
+              <a:t>Backends</a:t>
             </a:r>
             <a:endParaRPr lang="en-US" sz="900" dirty="0"/>
           </a:p>
@@ -2980,7 +2980,7 @@
                 <a:ea typeface="Aptos Display" pitchFamily="34" charset="-122"/>
                 <a:cs typeface="Aptos Display" pitchFamily="34" charset="-120"/>
               </a:rPr>
-              <a:t>3</a:t>
+              <a:t>3 core</a:t>
             </a:r>
             <a:endParaRPr lang="en-US" sz="1800" dirty="0"/>
           </a:p>
@@ -3313,7 +3313,7 @@
                 <a:ea typeface="Aptos" pitchFamily="34" charset="-122"/>
                 <a:cs typeface="Aptos" pitchFamily="34" charset="-120"/>
               </a:rPr>
-              <a:t>The same kernels can compile to IR, lower to backend plans, execute on CPU, and execute on Embree.</a:t>
+              <a:t>The same kernels can compile to IR and execute through the native oracle, Embree, and accepted bounded OptiX paths.</a:t>
             </a:r>
             <a:endParaRPr lang="en-US" sz="1080" dirty="0"/>
           </a:p>
@@ -3336,7 +3336,7 @@
                 <a:ea typeface="Aptos" pitchFamily="34" charset="-122"/>
                 <a:cs typeface="Aptos" pitchFamily="34" charset="-120"/>
               </a:rPr>
-              <a:t>A separate audited native C++ + Embree comparison slice now cross-checks deterministic lsi and pip fixtures.</a:t>
+              <a:t>Three-backend checks exist on the Linux host for accepted real-data packages.</a:t>
             </a:r>
             <a:endParaRPr lang="en-US" sz="1080" dirty="0"/>
           </a:p>
@@ -3489,7 +3489,7 @@
                 <a:ea typeface="Aptos" pitchFamily="34" charset="-122"/>
                 <a:cs typeface="Aptos" pitchFamily="34" charset="-120"/>
               </a:rPr>
-              <a:t>No real OptiX runtime integration yet.</a:t>
+              <a:t>No closed PostGIS ground-truth comparison result yet.</a:t>
             </a:r>
             <a:endParaRPr lang="en-US" sz="1080" dirty="0"/>
           </a:p>
@@ -3512,7 +3512,7 @@
                 <a:ea typeface="Aptos" pitchFamily="34" charset="-122"/>
                 <a:cs typeface="Aptos" pitchFamily="34" charset="-120"/>
               </a:rPr>
-              <a:t>No performance evaluation against RayJoin.</a:t>
+              <a:t>No final bounded full RayJoin-style reproduction package across all current targets yet.</a:t>
             </a:r>
             <a:endParaRPr lang="en-US" sz="1080" dirty="0"/>
           </a:p>
@@ -3535,7 +3535,7 @@
                 <a:ea typeface="Aptos" pitchFamily="34" charset="-122"/>
                 <a:cs typeface="Aptos" pitchFamily="34" charset="-120"/>
               </a:rPr>
-              <a:t>No support yet for the full range of general-purpose RT workloads beyond the current small surface.</a:t>
+              <a:t>Vulkan is not yet validated to the same level as Embree or OptiX.</a:t>
             </a:r>
             <a:endParaRPr lang="en-US" sz="1080" dirty="0"/>
           </a:p>
@@ -3738,7 +3738,7 @@
                 <a:ea typeface="Aptos" pitchFamily="34" charset="-122"/>
                 <a:cs typeface="Aptos" pitchFamily="34" charset="-120"/>
               </a:rPr>
-              <a:t>The next steps after the current Mac-local milestone.</a:t>
+              <a:t>The next steps after the current multi-backend bring-up milestone.</a:t>
             </a:r>
             <a:endParaRPr lang="en-US" sz="1050" dirty="0"/>
           </a:p>
@@ -4071,7 +4071,7 @@
                 <a:ea typeface="Aptos Display" pitchFamily="34" charset="-122"/>
                 <a:cs typeface="Aptos Display" pitchFamily="34" charset="-120"/>
               </a:rPr>
-              <a:t>Bring up real OptiX runtime</a:t>
+              <a:t>Close external truth and matrix</a:t>
             </a:r>
             <a:endParaRPr lang="en-US" sz="1400" dirty="0"/>
           </a:p>
@@ -4110,7 +4110,7 @@
                 <a:ea typeface="Aptos" pitchFamily="34" charset="-122"/>
                 <a:cs typeface="Aptos" pitchFamily="34" charset="-120"/>
               </a:rPr>
-              <a:t>Connect the cloud NVIDIA environment and make generated backend artifacts execute end to end.</a:t>
+              <a:t>Finish PostGIS ground-truth comparison and close the bounded RayJoin-style experiment matrix across the current accepted backends.</a:t>
             </a:r>
             <a:endParaRPr lang="en-US" sz="1080" dirty="0"/>
           </a:p>
@@ -4234,7 +4234,7 @@
                 <a:ea typeface="Aptos" pitchFamily="34" charset="-122"/>
                 <a:cs typeface="Aptos" pitchFamily="34" charset="-120"/>
               </a:rPr>
-              <a:t>Add robust arithmetic strategy, benchmark against RayJoin, and refine backend specialization.</a:t>
+              <a:t>Add robust arithmetic strategy, continue apples-to-apples backend comparisons, and refine backend specialization.</a:t>
             </a:r>
             <a:endParaRPr lang="en-US" sz="1080" dirty="0"/>
           </a:p>
@@ -4651,7 +4651,30 @@
                 <a:ea typeface="Aptos" pitchFamily="34" charset="-122"/>
                 <a:cs typeface="Aptos" pitchFamily="34" charset="-120"/>
               </a:rPr>
-              <a:t>GitHub and local repo are in sync through Goal 19 closure, including the first-class raw Embree runtime path, the native-vs-RTDL performance comparison, and the refreshed history dashboard.</a:t>
+              <a:t>GitHub and local repo are in sync through the current audited multi-backend state.</a:t>
+            </a:r>
+            <a:endParaRPr lang="en-US" sz="1080" dirty="0"/>
+          </a:p>
+          <a:p>
+            <a:pPr indent="0" marL="0">
+              <a:buNone/>
+            </a:pPr>
+            <a:endParaRPr lang="en-US" sz="1080" dirty="0"/>
+          </a:p>
+          <a:p>
+            <a:pPr indent="0" marL="0">
+              <a:buNone/>
+            </a:pPr>
+            <a:r>
+              <a:rPr lang="en-US" sz="1080" dirty="0">
+                <a:solidFill>
+                  <a:srgbClr val="102032"/>
+                </a:solidFill>
+                <a:latin typeface="Aptos" pitchFamily="34" charset="0"/>
+                <a:ea typeface="Aptos" pitchFamily="34" charset="-122"/>
+                <a:cs typeface="Aptos" pitchFamily="34" charset="-120"/>
+              </a:rPr>
+              <a:t>Embree and OptiX are real; Vulkan is provisional; the PostGIS truth track is active.</a:t>
             </a:r>
             <a:endParaRPr lang="en-US" sz="1080" dirty="0"/>
           </a:p>
@@ -4781,7 +4804,7 @@
                 <a:ea typeface="Aptos" pitchFamily="34" charset="-122"/>
                 <a:cs typeface="Aptos" pitchFamily="34" charset="-120"/>
               </a:rPr>
-              <a:t>Read docs/rtdl/*, run make test, make run-rtdsl-sim, and make run-rtdsl-embree, then author new kernels against the current contracts.</a:t>
+              <a:t>Read docs/rtdl/*, run make test, validate kernels against the oracle, and compare them against Embree and OptiX on accepted targets.</a:t>
             </a:r>
             <a:endParaRPr lang="en-US" sz="1080" dirty="0"/>
           </a:p>
@@ -4888,7 +4911,7 @@
                 <a:ea typeface="Aptos" pitchFamily="34" charset="-122"/>
                 <a:cs typeface="Aptos" pitchFamily="34" charset="-120"/>
               </a:rPr>
-              <a:t>Real OptiX runtime integration, generated backend validation, and progress toward replacing narrow slices of handwritten RayJoin code.</a:t>
+              <a:t>Bounded real-data GPU validation, apples-to-apples backend comparison, and progress toward a bounded RayJoin-style reproduction package.</a:t>
             </a:r>
             <a:endParaRPr lang="en-US" sz="1080" dirty="0"/>
           </a:p>
@@ -4988,7 +5011,7 @@
                 <a:ea typeface="Courier New" pitchFamily="34" charset="-122"/>
                 <a:cs typeface="Courier New" pitchFamily="34" charset="-120"/>
               </a:rPr>
-              <a:t>- CPU + Embree runtimes plus native C++ comparison slices</a:t>
+              <a:t>- Native oracle + Embree + OptiX</a:t>
             </a:r>
             <a:endParaRPr lang="en-US" sz="980" dirty="0"/>
           </a:p>
@@ -5005,7 +5028,7 @@
                 <a:ea typeface="Courier New" pitchFamily="34" charset="-122"/>
                 <a:cs typeface="Courier New" pitchFamily="34" charset="-120"/>
               </a:rPr>
-              <a:t>- Embree 4.4.0 runtime on this Mac</a:t>
+              <a:t>- PostGIS ground-truth track in progress</a:t>
             </a:r>
             <a:endParaRPr lang="en-US" sz="980" dirty="0"/>
           </a:p>
@@ -5022,7 +5045,7 @@
                 <a:ea typeface="Courier New" pitchFamily="34" charset="-122"/>
                 <a:cs typeface="Courier New" pitchFamily="34" charset="-120"/>
               </a:rPr>
-              <a:t>- 80 passing tests</a:t>
+              <a:t>- Vulkan retained as provisional backend code</a:t>
             </a:r>
             <a:endParaRPr lang="en-US" sz="980" dirty="0"/>
           </a:p>
@@ -5039,7 +5062,24 @@
                 <a:ea typeface="Courier New" pitchFamily="34" charset="-122"/>
                 <a:cs typeface="Courier New" pitchFamily="34" charset="-120"/>
               </a:rPr>
-              <a:t>- 21 archived review/revision rounds</a:t>
+              <a:t>- 160 passing tests</a:t>
+            </a:r>
+            <a:endParaRPr lang="en-US" sz="980" dirty="0"/>
+          </a:p>
+          <a:p>
+            <a:pPr indent="0" marL="0">
+              <a:buNone/>
+            </a:pPr>
+            <a:r>
+              <a:rPr lang="en-US" sz="980" dirty="0">
+                <a:solidFill>
+                  <a:srgbClr val="102032"/>
+                </a:solidFill>
+                <a:latin typeface="Courier New" pitchFamily="34" charset="0"/>
+                <a:ea typeface="Courier New" pitchFamily="34" charset="-122"/>
+                <a:cs typeface="Courier New" pitchFamily="34" charset="-120"/>
+              </a:rPr>
+              <a:t>- 50+ reviewed goal rounds</a:t>
             </a:r>
             <a:endParaRPr lang="en-US" sz="980" dirty="0"/>
           </a:p>
@@ -8470,6 +8510,40 @@
             </a:r>
             <a:endParaRPr lang="en-US" sz="1080" dirty="0"/>
           </a:p>
+          <a:p>
+            <a:pPr indent="0" marL="0">
+              <a:buNone/>
+            </a:pPr>
+            <a:r>
+              <a:rPr lang="en-US" sz="1080" dirty="0">
+                <a:solidFill>
+                  <a:srgbClr val="102032"/>
+                </a:solidFill>
+                <a:latin typeface="Aptos" pitchFamily="34" charset="0"/>
+                <a:ea typeface="Aptos" pitchFamily="34" charset="-122"/>
+                <a:cs typeface="Aptos" pitchFamily="34" charset="-120"/>
+              </a:rPr>
+              <a:t>segment_polygon_hitcount</a:t>
+            </a:r>
+            <a:endParaRPr lang="en-US" sz="1080" dirty="0"/>
+          </a:p>
+          <a:p>
+            <a:pPr indent="0" marL="0">
+              <a:buNone/>
+            </a:pPr>
+            <a:r>
+              <a:rPr lang="en-US" sz="1080" dirty="0">
+                <a:solidFill>
+                  <a:srgbClr val="102032"/>
+                </a:solidFill>
+                <a:latin typeface="Aptos" pitchFamily="34" charset="0"/>
+                <a:ea typeface="Aptos" pitchFamily="34" charset="-122"/>
+                <a:cs typeface="Aptos" pitchFamily="34" charset="-120"/>
+              </a:rPr>
+              <a:t>point_nearest_segment</a:t>
+            </a:r>
+            <a:endParaRPr lang="en-US" sz="1080" dirty="0"/>
+          </a:p>
         </p:txBody>
       </p:sp>
       <p:sp>
@@ -8573,7 +8647,7 @@
                 <a:ea typeface="Aptos" pitchFamily="34" charset="-122"/>
                 <a:cs typeface="Aptos" pitchFamily="34" charset="-120"/>
               </a:rPr>
-              <a:t>Compiler-only planning</a:t>
+              <a:t>Native C++ oracle</a:t>
             </a:r>
             <a:endParaRPr lang="en-US" sz="1080" dirty="0"/>
           </a:p>
@@ -8590,7 +8664,7 @@
                 <a:ea typeface="Aptos" pitchFamily="34" charset="-122"/>
                 <a:cs typeface="Aptos" pitchFamily="34" charset="-120"/>
               </a:rPr>
-              <a:t>Python CPU simulator</a:t>
+              <a:t>Embree runtime</a:t>
             </a:r>
             <a:endParaRPr lang="en-US" sz="1080" dirty="0"/>
           </a:p>
@@ -8607,7 +8681,24 @@
                 <a:ea typeface="Aptos" pitchFamily="34" charset="-122"/>
                 <a:cs typeface="Aptos" pitchFamily="34" charset="-120"/>
               </a:rPr>
-              <a:t>Native Embree runtime</a:t>
+              <a:t>OptiX runtime</a:t>
+            </a:r>
+            <a:endParaRPr lang="en-US" sz="1080" dirty="0"/>
+          </a:p>
+          <a:p>
+            <a:pPr indent="0" marL="0">
+              <a:buNone/>
+            </a:pPr>
+            <a:r>
+              <a:rPr lang="en-US" sz="1080" dirty="0">
+                <a:solidFill>
+                  <a:srgbClr val="102032"/>
+                </a:solidFill>
+                <a:latin typeface="Aptos" pitchFamily="34" charset="0"/>
+                <a:ea typeface="Aptos" pitchFamily="34" charset="-122"/>
+                <a:cs typeface="Aptos" pitchFamily="34" charset="-120"/>
+              </a:rPr>
+              <a:t>Vulkan (provisional)</a:t>
             </a:r>
             <a:endParaRPr lang="en-US" sz="1080" dirty="0"/>
           </a:p>
@@ -8748,7 +8839,24 @@
                 <a:ea typeface="Aptos" pitchFamily="34" charset="-122"/>
                 <a:cs typeface="Aptos" pitchFamily="34" charset="-120"/>
               </a:rPr>
-              <a:t>OptiX/CUDA skeleton artifacts</a:t>
+              <a:t>PostGIS comparison</a:t>
+            </a:r>
+            <a:endParaRPr lang="en-US" sz="1080" dirty="0"/>
+          </a:p>
+          <a:p>
+            <a:pPr indent="0" marL="0">
+              <a:buNone/>
+            </a:pPr>
+            <a:r>
+              <a:rPr lang="en-US" sz="1080" dirty="0">
+                <a:solidFill>
+                  <a:srgbClr val="102032"/>
+                </a:solidFill>
+                <a:latin typeface="Aptos" pitchFamily="34" charset="0"/>
+                <a:ea typeface="Aptos" pitchFamily="34" charset="-122"/>
+                <a:cs typeface="Aptos" pitchFamily="34" charset="-120"/>
+              </a:rPr>
+              <a:t>GPU backend plumbing</a:t>
             </a:r>
             <a:endParaRPr lang="en-US" sz="1080" dirty="0"/>
           </a:p>
@@ -8830,7 +8938,28 @@
                 <a:ea typeface="Aptos" pitchFamily="34" charset="-122"/>
                 <a:cs typeface="Aptos" pitchFamily="34" charset="-120"/>
               </a:rPr>
-              <a:t>The OptiX path is still a planning and code-generation backend, not a finished runtime.</a:t>
+              <a:t>The OptiX path is a real controlled runtime on 192.168.1.20, with bounded accepted real-data validation.</a:t>
+            </a:r>
+            <a:pPr indent="0" marL="0">
+              <a:buNone/>
+            </a:pPr>
+            <a:endParaRPr lang="en-US" sz="1350" dirty="0"/>
+          </a:p>
+          <a:p>
+            <a:pPr marL="177800" indent="-177800">
+              <a:buSzPct val="100000"/>
+              <a:buChar char="•"/>
+            </a:pPr>
+            <a:r>
+              <a:rPr lang="en-US" sz="1350" dirty="0">
+                <a:solidFill>
+                  <a:srgbClr val="102032"/>
+                </a:solidFill>
+                <a:latin typeface="Aptos" pitchFamily="34" charset="0"/>
+                <a:ea typeface="Aptos" pitchFamily="34" charset="-122"/>
+                <a:cs typeface="Aptos" pitchFamily="34" charset="-120"/>
+              </a:rPr>
+              <a:t>The Vulkan path is present in-repo but still provisional.</a:t>
             </a:r>
             <a:pPr indent="0" marL="0">
               <a:buNone/>
@@ -10466,7 +10595,7 @@
                 <a:ea typeface="Aptos" pitchFamily="34" charset="-122"/>
                 <a:cs typeface="Aptos" pitchFamily="34" charset="-120"/>
               </a:rPr>
-              <a:t>CPU runtime</a:t>
+              <a:t>Oracle runtime</a:t>
             </a:r>
             <a:endParaRPr lang="en-US" sz="1080" dirty="0"/>
           </a:p>
@@ -10500,7 +10629,24 @@
                 <a:ea typeface="Aptos" pitchFamily="34" charset="-122"/>
                 <a:cs typeface="Aptos" pitchFamily="34" charset="-120"/>
               </a:rPr>
-              <a:t>OptiX skeleton codegen</a:t>
+              <a:t>OptiX runtime</a:t>
+            </a:r>
+            <a:endParaRPr lang="en-US" sz="1080" dirty="0"/>
+          </a:p>
+          <a:p>
+            <a:pPr indent="0" marL="0">
+              <a:buNone/>
+            </a:pPr>
+            <a:r>
+              <a:rPr lang="en-US" sz="1080" dirty="0">
+                <a:solidFill>
+                  <a:srgbClr val="102032"/>
+                </a:solidFill>
+                <a:latin typeface="Aptos" pitchFamily="34" charset="0"/>
+                <a:ea typeface="Aptos" pitchFamily="34" charset="-122"/>
+                <a:cs typeface="Aptos" pitchFamily="34" charset="-120"/>
+              </a:rPr>
+              <a:t>Vulkan runtime (provisional)</a:t>
             </a:r>
             <a:endParaRPr lang="en-US" sz="1080" dirty="0"/>
           </a:p>
@@ -10918,7 +11064,7 @@
                 <a:ea typeface="Aptos Display" pitchFamily="34" charset="-122"/>
                 <a:cs typeface="Aptos Display" pitchFamily="34" charset="-120"/>
               </a:rPr>
-              <a:t>Native Mac runtime</a:t>
+              <a:t>Validated runtime surface</a:t>
             </a:r>
             <a:endParaRPr lang="en-US" sz="1400" dirty="0"/>
           </a:p>
@@ -10957,7 +11103,7 @@
                 <a:ea typeface="Aptos" pitchFamily="34" charset="-122"/>
                 <a:cs typeface="Aptos" pitchFamily="34" charset="-120"/>
               </a:rPr>
-              <a:t>Embree 4.4.0 on this Mac via src/native/rtdl_embree.cpp.</a:t>
+              <a:t>Embree-backed local validation on this Mac, plus larger Linux validation and OptiX execution on 192.168.1.20.</a:t>
             </a:r>
             <a:endParaRPr lang="en-US" sz="1080" dirty="0"/>
           </a:p>
@@ -10980,7 +11126,7 @@
                 <a:ea typeface="Aptos" pitchFamily="34" charset="-122"/>
                 <a:cs typeface="Aptos" pitchFamily="34" charset="-120"/>
               </a:rPr>
-              <a:t>Public API: rt.run_embree(...)</a:t>
+              <a:t>Public APIs: rt.run_embree(...), rt.run_optix(...)</a:t>
             </a:r>
             <a:endParaRPr lang="en-US" sz="1080" dirty="0"/>
           </a:p>
@@ -12178,7 +12324,7 @@
                 <a:ea typeface="Aptos" pitchFamily="34" charset="-122"/>
                 <a:cs typeface="Aptos" pitchFamily="34" charset="-120"/>
               </a:rPr>
-              <a:t>datasets.py parses RayJoin-style CDB chains and derives segment, polygon, and point-probe views for non-GPU validation.</a:t>
+              <a:t>datasets.py parses RayJoin-style CDB chains and derives segment, polygon, and point-probe views for oracle, Embree, OptiX, and PostGIS comparison.</a:t>
             </a:r>
             <a:endParaRPr lang="en-US" sz="1080" dirty="0"/>
           </a:p>
@@ -12285,7 +12431,7 @@
                 <a:ea typeface="Aptos" pitchFamily="34" charset="-122"/>
                 <a:cs typeface="Aptos" pitchFamily="34" charset="-120"/>
               </a:rPr>
-              <a:t>tests/fixtures/rayjoin/ plus authored synthetic examples, Section 5.6 generators, and Embree demos.</a:t>
+              <a:t>tests/fixtures/rayjoin/, exact-source public datasets, bounded Linux validation slices, and synthetic generators.</a:t>
             </a:r>
             <a:endParaRPr lang="en-US" sz="1080" dirty="0"/>
           </a:p>
@@ -12686,7 +12832,7 @@
                 <a:ea typeface="Aptos Display" pitchFamily="34" charset="-122"/>
                 <a:cs typeface="Aptos Display" pitchFamily="34" charset="-120"/>
               </a:rPr>
-              <a:t>2. Python simulator</a:t>
+              <a:t>2. Native oracle</a:t>
             </a:r>
             <a:endParaRPr lang="en-US" sz="1400" dirty="0"/>
           </a:p>
@@ -12725,7 +12871,7 @@
                 <a:ea typeface="Aptos" pitchFamily="34" charset="-122"/>
                 <a:cs typeface="Aptos" pitchFamily="34" charset="-120"/>
               </a:rPr>
-              <a:t>make run-rtdsl-sim</a:t>
+              <a:t>Use rt.run_cpu(...)</a:t>
             </a:r>
             <a:endParaRPr lang="en-US" sz="1080" dirty="0"/>
           </a:p>
@@ -12748,7 +12894,7 @@
                 <a:ea typeface="Aptos" pitchFamily="34" charset="-122"/>
                 <a:cs typeface="Aptos" pitchFamily="34" charset="-120"/>
               </a:rPr>
-              <a:t>Runs the current workload surface through the CPU reference runtime.</a:t>
+              <a:t>Runs the current workload surface through the native C/C++ ground-truth path.</a:t>
             </a:r>
             <a:endParaRPr lang="en-US" sz="1080" dirty="0"/>
           </a:p>
@@ -12855,7 +13001,7 @@
                 <a:ea typeface="Aptos" pitchFamily="34" charset="-122"/>
                 <a:cs typeface="Aptos" pitchFamily="34" charset="-120"/>
               </a:rPr>
-              <a:t>make run-rtdsl-embree</a:t>
+              <a:t>Use rt.run_embree(...)</a:t>
             </a:r>
             <a:endParaRPr lang="en-US" sz="1080" dirty="0"/>
           </a:p>
@@ -12878,7 +13024,7 @@
                 <a:ea typeface="Aptos" pitchFamily="34" charset="-122"/>
                 <a:cs typeface="Aptos" pitchFamily="34" charset="-120"/>
               </a:rPr>
-              <a:t>Runs the same workloads through the local Embree backend on this Mac.</a:t>
+              <a:t>Runs the same workloads through the controlled Embree backend; OptiX runs on the Linux GPU host.</a:t>
             </a:r>
             <a:endParaRPr lang="en-US" sz="1080" dirty="0"/>
           </a:p>
@@ -14016,7 +14162,7 @@
                 <a:ea typeface="Aptos Display" pitchFamily="34" charset="-122"/>
                 <a:cs typeface="Aptos Display" pitchFamily="34" charset="-120"/>
               </a:rPr>
-              <a:t>Goals 6-15</a:t>
+              <a:t>Goals 6-50</a:t>
             </a:r>
             <a:endParaRPr lang="en-US" sz="1400" dirty="0"/>
           </a:p>
@@ -14055,7 +14201,7 @@
                 <a:ea typeface="Aptos" pitchFamily="34" charset="-122"/>
                 <a:cs typeface="Aptos" pitchFamily="34" charset="-120"/>
               </a:rPr>
-              <a:t>CPU simulator, Embree backend, evaluation/reporting, trust audit, paper-analogue work, and native C++ comparison.</a:t>
+              <a:t>Native oracle, Embree maturity, OptiX bring-up, three-backend checks, docs rewrite, full audit, and PostGIS ground-truth work.</a:t>
             </a:r>
             <a:endParaRPr lang="en-US" sz="1080" dirty="0"/>
           </a:p>
@@ -14162,7 +14308,7 @@
                 <a:ea typeface="Aptos" pitchFamily="34" charset="-122"/>
                 <a:cs typeface="Aptos" pitchFamily="34" charset="-120"/>
               </a:rPr>
-              <a:t>19 rounds</a:t>
+              <a:t>50+ goals</a:t>
             </a:r>
             <a:endParaRPr lang="en-US" sz="1020" dirty="0"/>
           </a:p>
@@ -14179,7 +14325,7 @@
                 <a:ea typeface="Aptos" pitchFamily="34" charset="-122"/>
                 <a:cs typeface="Aptos" pitchFamily="34" charset="-120"/>
               </a:rPr>
-              <a:t>56 external reports</a:t>
+              <a:t>2-3 AI review</a:t>
             </a:r>
             <a:endParaRPr lang="en-US" sz="1020" dirty="0"/>
           </a:p>
@@ -14196,7 +14342,7 @@
                 <a:ea typeface="Aptos" pitchFamily="34" charset="-122"/>
                 <a:cs typeface="Aptos" pitchFamily="34" charset="-120"/>
               </a:rPr>
-              <a:t>281 archived project snapshots</a:t>
+              <a:t>clean audited repo</a:t>
             </a:r>
             <a:endParaRPr lang="en-US" sz="1020" dirty="0"/>
           </a:p>
@@ -14636,7 +14782,7 @@
                 <a:ea typeface="Aptos" pitchFamily="34" charset="-122"/>
                 <a:cs typeface="Aptos" pitchFamily="34" charset="-120"/>
               </a:rPr>
-              <a:t>Purpose: real local native runtime on this Mac.</a:t>
+              <a:t>Purpose: controlled CPU backend for validated real-data work.</a:t>
             </a:r>
             <a:endParaRPr lang="en-US" sz="1080" dirty="0"/>
           </a:p>
@@ -14766,7 +14912,7 @@
                 <a:ea typeface="Aptos" pitchFamily="34" charset="-122"/>
                 <a:cs typeface="Aptos" pitchFamily="34" charset="-120"/>
               </a:rPr>
-              <a:t>Purpose: original target backend and future RT-core execution path.</a:t>
+              <a:t>Purpose: NVIDIA GPU backend for the RayJoin-style target slice.</a:t>
             </a:r>
             <a:endParaRPr lang="en-US" sz="1080" dirty="0"/>
           </a:p>
@@ -14789,7 +14935,7 @@
                 <a:ea typeface="Aptos" pitchFamily="34" charset="-122"/>
                 <a:cs typeface="Aptos" pitchFamily="34" charset="-120"/>
               </a:rPr>
-              <a:t>Status: lowering + skeleton codegen only.</a:t>
+              <a:t>Status: implemented and validated on bounded accepted workloads.</a:t>
             </a:r>
             <a:endParaRPr lang="en-US" sz="1080" dirty="0"/>
           </a:p>
@@ -14896,7 +15042,7 @@
                 <a:ea typeface="Aptos" pitchFamily="34" charset="-122"/>
                 <a:cs typeface="Aptos" pitchFamily="34" charset="-120"/>
               </a:rPr>
-              <a:t>Most plausible future option: Metal ray tracing.</a:t>
+              <a:t>Vulkan KHR path is in-repo but provisional.</a:t>
             </a:r>
             <a:endParaRPr lang="en-US" sz="1080" dirty="0"/>
           </a:p>
@@ -14919,7 +15065,7 @@
                 <a:ea typeface="Aptos" pitchFamily="34" charset="-122"/>
                 <a:cs typeface="Aptos" pitchFamily="34" charset="-120"/>
               </a:rPr>
-              <a:t>Not started.</a:t>
+              <a:t>Apple/Metal work is still future.</a:t>
             </a:r>
             <a:endParaRPr lang="en-US" sz="1080" dirty="0"/>
           </a:p>
@@ -14980,7 +15126,7 @@
                 <a:ea typeface="Aptos" pitchFamily="34" charset="-122"/>
                 <a:cs typeface="Aptos" pitchFamily="34" charset="-120"/>
               </a:rPr>
-              <a:t>Embree de-risks runtime semantics before the NVIDIA GPU environment is connected.</a:t>
+              <a:t>Embree is the strongest validated backend today.</a:t>
             </a:r>
             <a:pPr indent="0" marL="0">
               <a:buNone/>
@@ -15001,7 +15147,7 @@
                 <a:ea typeface="Aptos" pitchFamily="34" charset="-122"/>
                 <a:cs typeface="Aptos" pitchFamily="34" charset="-120"/>
               </a:rPr>
-              <a:t>OptiX remains the research-critical backend for matching the original RayJoin direction.</a:t>
+              <a:t>OptiX is real and correctness-checked on bounded real-data workloads.</a:t>
             </a:r>
             <a:pPr indent="0" marL="0">
               <a:buNone/>
@@ -15022,7 +15168,28 @@
                 <a:ea typeface="Aptos" pitchFamily="34" charset="-122"/>
                 <a:cs typeface="Aptos" pitchFamily="34" charset="-120"/>
               </a:rPr>
-              <a:t>A broader future architecture can support CPU, Mac GPU, and NVIDIA RT hardware under one language.</a:t>
+              <a:t>Vulkan is retained as provisional backend code, not as an equally accepted backend.</a:t>
+            </a:r>
+            <a:pPr indent="0" marL="0">
+              <a:buNone/>
+            </a:pPr>
+            <a:endParaRPr lang="en-US" sz="1340" dirty="0"/>
+          </a:p>
+          <a:p>
+            <a:pPr marL="177800" indent="-177800">
+              <a:buSzPct val="100000"/>
+              <a:buChar char="•"/>
+            </a:pPr>
+            <a:r>
+              <a:rPr lang="en-US" sz="1340" dirty="0">
+                <a:solidFill>
+                  <a:srgbClr val="102032"/>
+                </a:solidFill>
+                <a:latin typeface="Aptos" pitchFamily="34" charset="0"/>
+                <a:ea typeface="Aptos" pitchFamily="34" charset="-122"/>
+                <a:cs typeface="Aptos" pitchFamily="34" charset="-120"/>
+              </a:rPr>
+              <a:t>A broader future architecture can still support CPU, NVIDIA, Vulkan-class, and future Apple/mobile RT targets.</a:t>
             </a:r>
             <a:endParaRPr lang="en-US" sz="1340" dirty="0"/>
           </a:p>

</xml_diff>

<commit_message>
Refresh status docs and harden Vulkan tests
</commit_message>
<xml_diff>
--- a/rtdl_status_summary.pptx
+++ b/rtdl_status_summary.pptx
@@ -2445,7 +2445,7 @@
                 <a:ea typeface="Aptos" pitchFamily="34" charset="-122"/>
                 <a:cs typeface="Aptos" pitchFamily="34" charset="-120"/>
               </a:rPr>
-              <a:t>Current v0.1 slice: RayJoin-style workloads validated through a native oracle plus Embree and OptiX, with PostGIS ground-truth comparison in progress.</a:t>
+              <a:t>Current v0.1 slice: RayJoin-style workloads validated through a native oracle plus Embree and OptiX, with bounded PostGIS-backed ground truth and a first bounded overlay-seed closure.</a:t>
             </a:r>
             <a:endParaRPr lang="en-US" sz="1080" dirty="0"/>
           </a:p>
@@ -2659,7 +2659,7 @@
                 <a:ea typeface="Aptos Display" pitchFamily="34" charset="-122"/>
                 <a:cs typeface="Aptos Display" pitchFamily="34" charset="-120"/>
               </a:rPr>
-              <a:t>160</a:t>
+              <a:t>273</a:t>
             </a:r>
             <a:endParaRPr lang="en-US" sz="1800" dirty="0"/>
           </a:p>
@@ -2766,7 +2766,7 @@
                 <a:ea typeface="Aptos Display" pitchFamily="34" charset="-122"/>
                 <a:cs typeface="Aptos Display" pitchFamily="34" charset="-120"/>
               </a:rPr>
-              <a:t>50+</a:t>
+              <a:t>57+</a:t>
             </a:r>
             <a:endParaRPr lang="en-US" sz="1800" dirty="0"/>
           </a:p>
@@ -3336,7 +3336,7 @@
                 <a:ea typeface="Aptos" pitchFamily="34" charset="-122"/>
                 <a:cs typeface="Aptos" pitchFamily="34" charset="-120"/>
               </a:rPr>
-              <a:t>Three-backend checks exist on the Linux host for accepted real-data packages.</a:t>
+              <a:t>Bounded four-system checks now exist across PostGIS, the oracle, Embree, and OptiX on accepted real-data packages.</a:t>
             </a:r>
             <a:endParaRPr lang="en-US" sz="1080" dirty="0"/>
           </a:p>
@@ -3489,7 +3489,7 @@
                 <a:ea typeface="Aptos" pitchFamily="34" charset="-122"/>
                 <a:cs typeface="Aptos" pitchFamily="34" charset="-120"/>
               </a:rPr>
-              <a:t>No closed PostGIS ground-truth comparison result yet.</a:t>
+              <a:t>No final bounded full RayJoin-style reproduction package across all current targets yet.</a:t>
             </a:r>
             <a:endParaRPr lang="en-US" sz="1080" dirty="0"/>
           </a:p>
@@ -3512,7 +3512,7 @@
                 <a:ea typeface="Aptos" pitchFamily="34" charset="-122"/>
                 <a:cs typeface="Aptos" pitchFamily="34" charset="-120"/>
               </a:rPr>
-              <a:t>No final bounded full RayJoin-style reproduction package across all current targets yet.</a:t>
+              <a:t>Overlay remains a seed analogue, not full polygon materialization.</a:t>
             </a:r>
             <a:endParaRPr lang="en-US" sz="1080" dirty="0"/>
           </a:p>
@@ -4110,7 +4110,7 @@
                 <a:ea typeface="Aptos" pitchFamily="34" charset="-122"/>
                 <a:cs typeface="Aptos" pitchFamily="34" charset="-120"/>
               </a:rPr>
-              <a:t>Finish PostGIS ground-truth comparison and close the bounded RayJoin-style experiment matrix across the current accepted backends.</a:t>
+              <a:t>Extend the PostGIS-backed bounded matrix and close more RayJoin-style families across the current accepted backends.</a:t>
             </a:r>
             <a:endParaRPr lang="en-US" sz="1080" dirty="0"/>
           </a:p>
@@ -4674,7 +4674,7 @@
                 <a:ea typeface="Aptos" pitchFamily="34" charset="-122"/>
                 <a:cs typeface="Aptos" pitchFamily="34" charset="-120"/>
               </a:rPr>
-              <a:t>Embree and OptiX are real; Vulkan is provisional; the PostGIS truth track is active.</a:t>
+              <a:t>Embree and OptiX are real; Vulkan is provisional; bounded PostGIS closure is established on accepted packages.</a:t>
             </a:r>
             <a:endParaRPr lang="en-US" sz="1080" dirty="0"/>
           </a:p>
@@ -5028,7 +5028,7 @@
                 <a:ea typeface="Courier New" pitchFamily="34" charset="-122"/>
                 <a:cs typeface="Courier New" pitchFamily="34" charset="-120"/>
               </a:rPr>
-              <a:t>- PostGIS ground-truth track in progress</a:t>
+              <a:t>- Bounded PostGIS ground-truth closure on accepted packages</a:t>
             </a:r>
             <a:endParaRPr lang="en-US" sz="980" dirty="0"/>
           </a:p>
@@ -5045,7 +5045,7 @@
                 <a:ea typeface="Courier New" pitchFamily="34" charset="-122"/>
                 <a:cs typeface="Courier New" pitchFamily="34" charset="-120"/>
               </a:rPr>
-              <a:t>- Vulkan retained as provisional backend code</a:t>
+              <a:t>- First bounded overlay-seed four-system closure</a:t>
             </a:r>
             <a:endParaRPr lang="en-US" sz="980" dirty="0"/>
           </a:p>
@@ -5062,7 +5062,7 @@
                 <a:ea typeface="Courier New" pitchFamily="34" charset="-122"/>
                 <a:cs typeface="Courier New" pitchFamily="34" charset="-120"/>
               </a:rPr>
-              <a:t>- 160 passing tests</a:t>
+              <a:t>- Vulkan retained as provisional backend code</a:t>
             </a:r>
             <a:endParaRPr lang="en-US" sz="980" dirty="0"/>
           </a:p>
@@ -5079,7 +5079,24 @@
                 <a:ea typeface="Courier New" pitchFamily="34" charset="-122"/>
                 <a:cs typeface="Courier New" pitchFamily="34" charset="-120"/>
               </a:rPr>
-              <a:t>- 50+ reviewed goal rounds</a:t>
+              <a:t>- 273 full-matrix tests</a:t>
+            </a:r>
+            <a:endParaRPr lang="en-US" sz="980" dirty="0"/>
+          </a:p>
+          <a:p>
+            <a:pPr indent="0" marL="0">
+              <a:buNone/>
+            </a:pPr>
+            <a:r>
+              <a:rPr lang="en-US" sz="980" dirty="0">
+                <a:solidFill>
+                  <a:srgbClr val="102032"/>
+                </a:solidFill>
+                <a:latin typeface="Courier New" pitchFamily="34" charset="0"/>
+                <a:ea typeface="Courier New" pitchFamily="34" charset="-122"/>
+                <a:cs typeface="Courier New" pitchFamily="34" charset="-120"/>
+              </a:rPr>
+              <a:t>- 57+ reviewed goal rounds</a:t>
             </a:r>
             <a:endParaRPr lang="en-US" sz="980" dirty="0"/>
           </a:p>
@@ -8959,6 +8976,27 @@
                 <a:ea typeface="Aptos" pitchFamily="34" charset="-122"/>
                 <a:cs typeface="Aptos" pitchFamily="34" charset="-120"/>
               </a:rPr>
+              <a:t>PostGIS is now a closed external checker on accepted bounded packages.</a:t>
+            </a:r>
+            <a:pPr indent="0" marL="0">
+              <a:buNone/>
+            </a:pPr>
+            <a:endParaRPr lang="en-US" sz="1350" dirty="0"/>
+          </a:p>
+          <a:p>
+            <a:pPr marL="177800" indent="-177800">
+              <a:buSzPct val="100000"/>
+              <a:buChar char="•"/>
+            </a:pPr>
+            <a:r>
+              <a:rPr lang="en-US" sz="1350" dirty="0">
+                <a:solidFill>
+                  <a:srgbClr val="102032"/>
+                </a:solidFill>
+                <a:latin typeface="Aptos" pitchFamily="34" charset="0"/>
+                <a:ea typeface="Aptos" pitchFamily="34" charset="-122"/>
+                <a:cs typeface="Aptos" pitchFamily="34" charset="-120"/>
+              </a:rPr>
               <a:t>The Vulkan path is present in-repo but still provisional.</a:t>
             </a:r>
             <a:pPr indent="0" marL="0">
@@ -14162,7 +14200,7 @@
                 <a:ea typeface="Aptos Display" pitchFamily="34" charset="-122"/>
                 <a:cs typeface="Aptos Display" pitchFamily="34" charset="-120"/>
               </a:rPr>
-              <a:t>Goals 6-50</a:t>
+              <a:t>Goals 6-57</a:t>
             </a:r>
             <a:endParaRPr lang="en-US" sz="1400" dirty="0"/>
           </a:p>
@@ -14201,7 +14239,7 @@
                 <a:ea typeface="Aptos" pitchFamily="34" charset="-122"/>
                 <a:cs typeface="Aptos" pitchFamily="34" charset="-120"/>
               </a:rPr>
-              <a:t>Native oracle, Embree maturity, OptiX bring-up, three-backend checks, docs rewrite, full audit, and PostGIS ground-truth work.</a:t>
+              <a:t>Native oracle, Embree maturity, OptiX bring-up, three-backend checks, docs rewrite, full audit, PostGIS closure, first bounded overlay-seed four-system result, and the status/test refresh package.</a:t>
             </a:r>
             <a:endParaRPr lang="en-US" sz="1080" dirty="0"/>
           </a:p>
@@ -14308,7 +14346,7 @@
                 <a:ea typeface="Aptos" pitchFamily="34" charset="-122"/>
                 <a:cs typeface="Aptos" pitchFamily="34" charset="-120"/>
               </a:rPr>
-              <a:t>50+ goals</a:t>
+              <a:t>57+ goals</a:t>
             </a:r>
             <a:endParaRPr lang="en-US" sz="1020" dirty="0"/>
           </a:p>

</xml_diff>

<commit_message>
Close full consistency audit
</commit_message>
<xml_diff>
--- a/rtdl_status_summary.pptx
+++ b/rtdl_status_summary.pptx
@@ -2445,7 +2445,7 @@
                 <a:ea typeface="Aptos" pitchFamily="34" charset="-122"/>
                 <a:cs typeface="Aptos" pitchFamily="34" charset="-120"/>
               </a:rPr>
-              <a:t>Current v0.1 slice: RayJoin-style workloads validated through a native oracle plus Embree and OptiX, with bounded PostGIS-backed ground truth and a first bounded overlay-seed closure.</a:t>
+              <a:t>Current v0.1 slice: a bounded accepted reproduction package across native oracle, Embree, OptiX, and PostGIS-backed checks, plus a first bounded overlay-seed closure.</a:t>
             </a:r>
             <a:endParaRPr lang="en-US" sz="1080" dirty="0"/>
           </a:p>
@@ -2766,7 +2766,7 @@
                 <a:ea typeface="Aptos Display" pitchFamily="34" charset="-122"/>
                 <a:cs typeface="Aptos Display" pitchFamily="34" charset="-120"/>
               </a:rPr>
-              <a:t>57+</a:t>
+              <a:t>59+</a:t>
             </a:r>
             <a:endParaRPr lang="en-US" sz="1800" dirty="0"/>
           </a:p>
@@ -5028,7 +5028,7 @@
                 <a:ea typeface="Courier New" pitchFamily="34" charset="-122"/>
                 <a:cs typeface="Courier New" pitchFamily="34" charset="-120"/>
               </a:rPr>
-              <a:t>- Bounded PostGIS ground-truth closure on accepted packages</a:t>
+              <a:t>- Bounded accepted reproduction package across trusted systems</a:t>
             </a:r>
             <a:endParaRPr lang="en-US" sz="980" dirty="0"/>
           </a:p>
@@ -5096,7 +5096,7 @@
                 <a:ea typeface="Courier New" pitchFamily="34" charset="-122"/>
                 <a:cs typeface="Courier New" pitchFamily="34" charset="-120"/>
               </a:rPr>
-              <a:t>- 57+ reviewed goal rounds</a:t>
+              <a:t>- 59+ reviewed goal rounds</a:t>
             </a:r>
             <a:endParaRPr lang="en-US" sz="980" dirty="0"/>
           </a:p>
@@ -14346,7 +14346,7 @@
                 <a:ea typeface="Aptos" pitchFamily="34" charset="-122"/>
                 <a:cs typeface="Aptos" pitchFamily="34" charset="-120"/>
               </a:rPr>
-              <a:t>57+ goals</a:t>
+              <a:t>59+ goals</a:t>
             </a:r>
             <a:endParaRPr lang="en-US" sz="1020" dirty="0"/>
           </a:p>

</xml_diff>

<commit_message>
Repair live docs and record blocked Vulkan scaling round
</commit_message>
<xml_diff>
--- a/rtdl_status_summary.pptx
+++ b/rtdl_status_summary.pptx
@@ -3489,7 +3489,7 @@
                 <a:ea typeface="Aptos" pitchFamily="34" charset="-122"/>
                 <a:cs typeface="Aptos" pitchFamily="34" charset="-120"/>
               </a:rPr>
-              <a:t>No final bounded full RayJoin-style reproduction package across all current targets yet.</a:t>
+              <a:t>The accepted package is still bounded rather than paper-identical or nationwide.</a:t>
             </a:r>
             <a:endParaRPr lang="en-US" sz="1080" dirty="0"/>
           </a:p>
@@ -3535,7 +3535,7 @@
                 <a:ea typeface="Aptos" pitchFamily="34" charset="-122"/>
                 <a:cs typeface="Aptos" pitchFamily="34" charset="-120"/>
               </a:rPr>
-              <a:t>Vulkan is not yet validated to the same level as Embree or OptiX.</a:t>
+              <a:t>Vulkan still has larger-package scaling limits and is not yet at Embree/OptiX maturity.</a:t>
             </a:r>
             <a:endParaRPr lang="en-US" sz="1080" dirty="0"/>
           </a:p>
@@ -4674,7 +4674,7 @@
                 <a:ea typeface="Aptos" pitchFamily="34" charset="-122"/>
                 <a:cs typeface="Aptos" pitchFamily="34" charset="-120"/>
               </a:rPr>
-              <a:t>Embree and OptiX are real; Vulkan is provisional; bounded PostGIS closure is established on accepted packages.</a:t>
+              <a:t>Embree and OptiX are real; Vulkan is parity-clean on the accepted bounded Linux surface but still provisional; bounded PostGIS closure is established on accepted packages.</a:t>
             </a:r>
             <a:endParaRPr lang="en-US" sz="1080" dirty="0"/>
           </a:p>
@@ -5062,7 +5062,7 @@
                 <a:ea typeface="Courier New" pitchFamily="34" charset="-122"/>
                 <a:cs typeface="Courier New" pitchFamily="34" charset="-120"/>
               </a:rPr>
-              <a:t>- Vulkan retained as provisional backend code</a:t>
+              <a:t>- Vulkan parity-clean on the accepted bounded Linux surface</a:t>
             </a:r>
             <a:endParaRPr lang="en-US" sz="980" dirty="0"/>
           </a:p>
@@ -8715,7 +8715,7 @@
                 <a:ea typeface="Aptos" pitchFamily="34" charset="-122"/>
                 <a:cs typeface="Aptos" pitchFamily="34" charset="-120"/>
               </a:rPr>
-              <a:t>Vulkan (provisional)</a:t>
+              <a:t>Vulkan runtime</a:t>
             </a:r>
             <a:endParaRPr lang="en-US" sz="1080" dirty="0"/>
           </a:p>
@@ -8997,7 +8997,7 @@
                 <a:ea typeface="Aptos" pitchFamily="34" charset="-122"/>
                 <a:cs typeface="Aptos" pitchFamily="34" charset="-120"/>
               </a:rPr>
-              <a:t>The Vulkan path is present in-repo but still provisional.</a:t>
+              <a:t>The Vulkan path is now parity-clean on the accepted bounded Linux surface, but still provisional for larger-scale use.</a:t>
             </a:r>
             <a:pPr indent="0" marL="0">
               <a:buNone/>
@@ -10684,7 +10684,7 @@
                 <a:ea typeface="Aptos" pitchFamily="34" charset="-122"/>
                 <a:cs typeface="Aptos" pitchFamily="34" charset="-120"/>
               </a:rPr>
-              <a:t>Vulkan runtime (provisional)</a:t>
+              <a:t>Vulkan runtime</a:t>
             </a:r>
             <a:endParaRPr lang="en-US" sz="1080" dirty="0"/>
           </a:p>
@@ -15080,7 +15080,7 @@
                 <a:ea typeface="Aptos" pitchFamily="34" charset="-122"/>
                 <a:cs typeface="Aptos" pitchFamily="34" charset="-120"/>
               </a:rPr>
-              <a:t>Vulkan KHR path is in-repo but provisional.</a:t>
+              <a:t>Vulkan KHR path is in-repo, parity-clean on the accepted bounded Linux surface, and still provisional beyond that.</a:t>
             </a:r>
             <a:endParaRPr lang="en-US" sz="1080" dirty="0"/>
           </a:p>
@@ -15206,7 +15206,7 @@
                 <a:ea typeface="Aptos" pitchFamily="34" charset="-122"/>
                 <a:cs typeface="Aptos" pitchFamily="34" charset="-120"/>
               </a:rPr>
-              <a:t>Vulkan is retained as provisional backend code, not as an equally accepted backend.</a:t>
+              <a:t>Vulkan is now correctness-closed on the accepted bounded Linux surface, but it is not yet an equally mature large-scale backend.</a:t>
             </a:r>
             <a:pPr indent="0" marL="0">
               <a:buNone/>

</xml_diff>

<commit_message>
Publish flat paper package, updated status deck, and Goal 104 report
</commit_message>
<xml_diff>
--- a/rtdl_status_summary.pptx
+++ b/rtdl_status_summary.pptx
@@ -2315,7 +2315,7 @@
                 <a:ea typeface="Aptos" pitchFamily="34" charset="-122"/>
                 <a:cs typeface="Aptos" pitchFamily="34" charset="-120"/>
               </a:rPr>
-              <a:t>Research status as of April 3, 2026</a:t>
+              <a:t>Research status as of April 5, 2026</a:t>
             </a:r>
             <a:endParaRPr lang="en-US" sz="1400" dirty="0"/>
           </a:p>
@@ -2445,7 +2445,7 @@
                 <a:ea typeface="Aptos" pitchFamily="34" charset="-122"/>
                 <a:cs typeface="Aptos" pitchFamily="34" charset="-120"/>
               </a:rPr>
-              <a:t>Current v0.1 slice: a bounded accepted reproduction package across native oracle, Embree, OptiX, and PostGIS-backed checks, plus a first bounded overlay-seed closure.</a:t>
+              <a:t>Current v0.1 slice: Goal 102 closes the full honest bounded RayJoin reproduction for Embree and OptiX, and Goal 103 closes the bounded Vulkan-only package.</a:t>
             </a:r>
             <a:endParaRPr lang="en-US" sz="1080" dirty="0"/>
           </a:p>
@@ -2659,7 +2659,7 @@
                 <a:ea typeface="Aptos Display" pitchFamily="34" charset="-122"/>
                 <a:cs typeface="Aptos Display" pitchFamily="34" charset="-120"/>
               </a:rPr>
-              <a:t>273</a:t>
+              <a:t>293</a:t>
             </a:r>
             <a:endParaRPr lang="en-US" sz="1800" dirty="0"/>
           </a:p>
@@ -2727,7 +2727,7 @@
                 <a:ea typeface="Aptos" pitchFamily="34" charset="-122"/>
                 <a:cs typeface="Aptos" pitchFamily="34" charset="-120"/>
               </a:rPr>
-              <a:t>Review</a:t>
+              <a:t>Goals</a:t>
             </a:r>
             <a:endParaRPr lang="en-US" sz="900" dirty="0"/>
           </a:p>
@@ -2766,7 +2766,7 @@
                 <a:ea typeface="Aptos Display" pitchFamily="34" charset="-122"/>
                 <a:cs typeface="Aptos Display" pitchFamily="34" charset="-120"/>
               </a:rPr>
-              <a:t>59+</a:t>
+              <a:t>103</a:t>
             </a:r>
             <a:endParaRPr lang="en-US" sz="1800" dirty="0"/>
           </a:p>
@@ -3313,7 +3313,7 @@
                 <a:ea typeface="Aptos" pitchFamily="34" charset="-122"/>
                 <a:cs typeface="Aptos" pitchFamily="34" charset="-120"/>
               </a:rPr>
-              <a:t>The same kernels can compile to IR and execute through the native oracle, Embree, and accepted bounded OptiX paths.</a:t>
+              <a:t>The same kernels can compile to IR and execute through the native oracle, Embree, OptiX, and Vulkan.</a:t>
             </a:r>
             <a:endParaRPr lang="en-US" sz="1080" dirty="0"/>
           </a:p>
@@ -3336,7 +3336,7 @@
                 <a:ea typeface="Aptos" pitchFamily="34" charset="-122"/>
                 <a:cs typeface="Aptos" pitchFamily="34" charset="-120"/>
               </a:rPr>
-              <a:t>Bounded four-system checks now exist across PostGIS, the oracle, Embree, and OptiX on accepted real-data packages.</a:t>
+              <a:t>Goal 102 closes the full honest bounded RayJoin reproduction package, and Goal 103 closes the matching bounded Vulkan-only package.</a:t>
             </a:r>
             <a:endParaRPr lang="en-US" sz="1080" dirty="0"/>
           </a:p>
@@ -3489,7 +3489,7 @@
                 <a:ea typeface="Aptos" pitchFamily="34" charset="-122"/>
                 <a:cs typeface="Aptos" pitchFamily="34" charset="-120"/>
               </a:rPr>
-              <a:t>The accepted package is still bounded rather than paper-identical or nationwide.</a:t>
+              <a:t>The accepted package is still bounded rather than paper-identical.</a:t>
             </a:r>
             <a:endParaRPr lang="en-US" sz="1080" dirty="0"/>
           </a:p>
@@ -3535,7 +3535,7 @@
                 <a:ea typeface="Aptos" pitchFamily="34" charset="-122"/>
                 <a:cs typeface="Aptos" pitchFamily="34" charset="-120"/>
               </a:rPr>
-              <a:t>Vulkan still has larger-package scaling limits and is not yet at Embree/OptiX maturity.</a:t>
+              <a:t>Most RayJoin paper rows remain unavailable for Vulkan and several other backend-specific slices.</a:t>
             </a:r>
             <a:endParaRPr lang="en-US" sz="1080" dirty="0"/>
           </a:p>
@@ -3699,7 +3699,7 @@
                 <a:ea typeface="Aptos Display" pitchFamily="34" charset="-122"/>
                 <a:cs typeface="Aptos Display" pitchFamily="34" charset="-120"/>
               </a:rPr>
-              <a:t>Roadmap to a Fully Functional DSL</a:t>
+              <a:t>Roadmap Beyond RayJoin</a:t>
             </a:r>
             <a:endParaRPr lang="en-US" sz="2400" dirty="0"/>
           </a:p>
@@ -3738,7 +3738,7 @@
                 <a:ea typeface="Aptos" pitchFamily="34" charset="-122"/>
                 <a:cs typeface="Aptos" pitchFamily="34" charset="-120"/>
               </a:rPr>
-              <a:t>The next steps after the current multi-backend bring-up milestone.</a:t>
+              <a:t>The next steps after the current honest reproduction closure.</a:t>
             </a:r>
             <a:endParaRPr lang="en-US" sz="1050" dirty="0"/>
           </a:p>
@@ -3862,7 +3862,7 @@
                 <a:ea typeface="Aptos" pitchFamily="34" charset="-122"/>
                 <a:cs typeface="Aptos" pitchFamily="34" charset="-120"/>
               </a:rPr>
-              <a:t>Keep improving docs, examples, negative validation, and authored-program testing.</a:t>
+              <a:t>Keep improving docs, examples, tutorials, and authored-program testing.</a:t>
             </a:r>
             <a:endParaRPr lang="en-US" sz="1080" dirty="0"/>
           </a:p>
@@ -4110,7 +4110,7 @@
                 <a:ea typeface="Aptos" pitchFamily="34" charset="-122"/>
                 <a:cs typeface="Aptos" pitchFamily="34" charset="-120"/>
               </a:rPr>
-              <a:t>Extend the PostGIS-backed bounded matrix and close more RayJoin-style families across the current accepted backends.</a:t>
+              <a:t>Close missing backend/workload cases only where they materially strengthen the system story.</a:t>
             </a:r>
             <a:endParaRPr lang="en-US" sz="1080" dirty="0"/>
           </a:p>
@@ -4234,7 +4234,7 @@
                 <a:ea typeface="Aptos" pitchFamily="34" charset="-122"/>
                 <a:cs typeface="Aptos" pitchFamily="34" charset="-120"/>
               </a:rPr>
-              <a:t>Add robust arithmetic strategy, continue apples-to-apples backend comparisons, and refine backend specialization.</a:t>
+              <a:t>Add robust arithmetic strategy, continue backend specialization, and widen non-RayJoin application examples.</a:t>
             </a:r>
             <a:endParaRPr lang="en-US" sz="1080" dirty="0"/>
           </a:p>
@@ -4341,7 +4341,7 @@
                 <a:ea typeface="Aptos" pitchFamily="34" charset="-122"/>
                 <a:cs typeface="Aptos" pitchFamily="34" charset="-120"/>
               </a:rPr>
-              <a:t>The project has moved from a language sketch to an executable system. The next phase is backend maturity, not basic feasibility.</a:t>
+              <a:t>The project has moved from a language sketch to an executable and published multi-backend system. The next phase is broader applications, not first feasibility.</a:t>
             </a:r>
             <a:endParaRPr lang="en-US" sz="1080" dirty="0"/>
           </a:p>
@@ -4544,7 +4544,7 @@
                 <a:ea typeface="Aptos" pitchFamily="34" charset="-122"/>
                 <a:cs typeface="Aptos" pitchFamily="34" charset="-120"/>
               </a:rPr>
-              <a:t>RTDL is ready for the next development phase.</a:t>
+              <a:t>RTDL is ready for post-RayJoin applications.</a:t>
             </a:r>
             <a:endParaRPr lang="en-US" sz="1050" dirty="0"/>
           </a:p>
@@ -4674,7 +4674,7 @@
                 <a:ea typeface="Aptos" pitchFamily="34" charset="-122"/>
                 <a:cs typeface="Aptos" pitchFamily="34" charset="-120"/>
               </a:rPr>
-              <a:t>Embree and OptiX are real; Vulkan is parity-clean on the accepted bounded Linux surface but still provisional; bounded PostGIS closure is established on accepted packages.</a:t>
+              <a:t>Goal 102 and Goal 103 are published. Embree and OptiX are the mature performance backends; Vulkan is the supported but slower backend.</a:t>
             </a:r>
             <a:endParaRPr lang="en-US" sz="1080" dirty="0"/>
           </a:p>
@@ -4804,7 +4804,7 @@
                 <a:ea typeface="Aptos" pitchFamily="34" charset="-122"/>
                 <a:cs typeface="Aptos" pitchFamily="34" charset="-120"/>
               </a:rPr>
-              <a:t>Read docs/rtdl/*, run make test, validate kernels against the oracle, and compare them against Embree and OptiX on accepted targets.</a:t>
+              <a:t>Read the quick tutorial, write RTDL programs, run tests, and validate kernels against the oracle and the supported backends.</a:t>
             </a:r>
             <a:endParaRPr lang="en-US" sz="1080" dirty="0"/>
           </a:p>
@@ -4911,7 +4911,7 @@
                 <a:ea typeface="Aptos" pitchFamily="34" charset="-122"/>
                 <a:cs typeface="Aptos" pitchFamily="34" charset="-120"/>
               </a:rPr>
-              <a:t>Bounded real-data GPU validation, apples-to-apples backend comparison, and progress toward a bounded RayJoin-style reproduction package.</a:t>
+              <a:t>Stable GPU execution, backend comparison, and a base for new non-RayJoin workloads.</a:t>
             </a:r>
             <a:endParaRPr lang="en-US" sz="1080" dirty="0"/>
           </a:p>
@@ -5011,7 +5011,7 @@
                 <a:ea typeface="Courier New" pitchFamily="34" charset="-122"/>
                 <a:cs typeface="Courier New" pitchFamily="34" charset="-120"/>
               </a:rPr>
-              <a:t>- Native oracle + Embree + OptiX</a:t>
+              <a:t>- Native oracle + Embree + OptiX + Vulkan</a:t>
             </a:r>
             <a:endParaRPr lang="en-US" sz="980" dirty="0"/>
           </a:p>
@@ -5028,7 +5028,7 @@
                 <a:ea typeface="Courier New" pitchFamily="34" charset="-122"/>
                 <a:cs typeface="Courier New" pitchFamily="34" charset="-120"/>
               </a:rPr>
-              <a:t>- Bounded accepted reproduction package across trusted systems</a:t>
+              <a:t>- Goal 102: full honest bounded RayJoin reproduction</a:t>
             </a:r>
             <a:endParaRPr lang="en-US" sz="980" dirty="0"/>
           </a:p>
@@ -5045,7 +5045,7 @@
                 <a:ea typeface="Courier New" pitchFamily="34" charset="-122"/>
                 <a:cs typeface="Courier New" pitchFamily="34" charset="-120"/>
               </a:rPr>
-              <a:t>- First bounded overlay-seed four-system closure</a:t>
+              <a:t>- Goal 103: full honest bounded Vulkan-only reproduction</a:t>
             </a:r>
             <a:endParaRPr lang="en-US" sz="980" dirty="0"/>
           </a:p>
@@ -5062,7 +5062,7 @@
                 <a:ea typeface="Courier New" pitchFamily="34" charset="-122"/>
                 <a:cs typeface="Courier New" pitchFamily="34" charset="-120"/>
               </a:rPr>
-              <a:t>- Vulkan parity-clean on the accepted bounded Linux surface</a:t>
+              <a:t>- Long flagship row: Embree and OptiX beat PostGIS; Vulkan is parity-clean but slower</a:t>
             </a:r>
             <a:endParaRPr lang="en-US" sz="980" dirty="0"/>
           </a:p>
@@ -5079,7 +5079,7 @@
                 <a:ea typeface="Courier New" pitchFamily="34" charset="-122"/>
                 <a:cs typeface="Courier New" pitchFamily="34" charset="-120"/>
               </a:rPr>
-              <a:t>- 273 full-matrix tests</a:t>
+              <a:t>- 293 full-matrix tests</a:t>
             </a:r>
             <a:endParaRPr lang="en-US" sz="980" dirty="0"/>
           </a:p>
@@ -5096,7 +5096,7 @@
                 <a:ea typeface="Courier New" pitchFamily="34" charset="-122"/>
                 <a:cs typeface="Courier New" pitchFamily="34" charset="-120"/>
               </a:rPr>
-              <a:t>- 59+ reviewed goal rounds</a:t>
+              <a:t>- 103 reviewed goal rounds</a:t>
             </a:r>
             <a:endParaRPr lang="en-US" sz="980" dirty="0"/>
           </a:p>
@@ -7462,7 +7462,7 @@
                 <a:ea typeface="Aptos" pitchFamily="34" charset="-122"/>
                 <a:cs typeface="Aptos" pitchFamily="34" charset="-120"/>
               </a:rPr>
-              <a:t>Keep the Python-like DSL. Treat dict-return execution as a convenience mode, and treat raw / prepared-raw execution as the serious performance path. Python should remain the control plane, not the main data plane.</a:t>
+              <a:t>Keep the Python-like DSL. Treat Python dict-return execution as the convenience path, and treat lower-overhead native-return modes as the serious performance path. Python should remain the control plane, not the main data plane.</a:t>
             </a:r>
             <a:endParaRPr lang="en-US" sz="1080" dirty="0"/>
           </a:p>
@@ -8955,7 +8955,7 @@
                 <a:ea typeface="Aptos" pitchFamily="34" charset="-122"/>
                 <a:cs typeface="Aptos" pitchFamily="34" charset="-120"/>
               </a:rPr>
-              <a:t>The OptiX path is a real controlled runtime on 192.168.1.20, with bounded accepted real-data validation.</a:t>
+              <a:t>The OptiX path is parity-clean and faster than PostGIS on the strongest accepted long `county_zipcode` PIP surface.</a:t>
             </a:r>
             <a:pPr indent="0" marL="0">
               <a:buNone/>
@@ -8976,7 +8976,7 @@
                 <a:ea typeface="Aptos" pitchFamily="34" charset="-122"/>
                 <a:cs typeface="Aptos" pitchFamily="34" charset="-120"/>
               </a:rPr>
-              <a:t>PostGIS is now a closed external checker on accepted bounded packages.</a:t>
+              <a:t>PostGIS is the external indexed baseline on the accepted package surfaces.</a:t>
             </a:r>
             <a:pPr indent="0" marL="0">
               <a:buNone/>
@@ -8997,7 +8997,7 @@
                 <a:ea typeface="Aptos" pitchFamily="34" charset="-122"/>
                 <a:cs typeface="Aptos" pitchFamily="34" charset="-120"/>
               </a:rPr>
-              <a:t>The Vulkan path is now parity-clean on the accepted bounded Linux surface, but still provisional for larger-scale use.</a:t>
+              <a:t>The Vulkan path is hardware-validated, parity-clean on the long flagship row, and slower than PostGIS there.</a:t>
             </a:r>
             <a:pPr indent="0" marL="0">
               <a:buNone/>
@@ -14200,7 +14200,7 @@
                 <a:ea typeface="Aptos Display" pitchFamily="34" charset="-122"/>
                 <a:cs typeface="Aptos Display" pitchFamily="34" charset="-120"/>
               </a:rPr>
-              <a:t>Goals 6-57</a:t>
+              <a:t>Goals 6-103</a:t>
             </a:r>
             <a:endParaRPr lang="en-US" sz="1400" dirty="0"/>
           </a:p>
@@ -14239,7 +14239,7 @@
                 <a:ea typeface="Aptos" pitchFamily="34" charset="-122"/>
                 <a:cs typeface="Aptos" pitchFamily="34" charset="-120"/>
               </a:rPr>
-              <a:t>Native oracle, Embree maturity, OptiX bring-up, three-backend checks, docs rewrite, full audit, PostGIS closure, first bounded overlay-seed four-system result, and the status/test refresh package.</a:t>
+              <a:t>Native oracle, Embree maturity, OptiX bring-up, Vulkan repair, release validation, hello-world/tutorial closure, and the honest RayJoin reproduction packages.</a:t>
             </a:r>
             <a:endParaRPr lang="en-US" sz="1080" dirty="0"/>
           </a:p>
@@ -14346,7 +14346,7 @@
                 <a:ea typeface="Aptos" pitchFamily="34" charset="-122"/>
                 <a:cs typeface="Aptos" pitchFamily="34" charset="-120"/>
               </a:rPr>
-              <a:t>59+ goals</a:t>
+              <a:t>103 goals</a:t>
             </a:r>
             <a:endParaRPr lang="en-US" sz="1020" dirty="0"/>
           </a:p>
@@ -14363,7 +14363,7 @@
                 <a:ea typeface="Aptos" pitchFamily="34" charset="-122"/>
                 <a:cs typeface="Aptos" pitchFamily="34" charset="-120"/>
               </a:rPr>
-              <a:t>2-3 AI review</a:t>
+              <a:t>2+ AI review</a:t>
             </a:r>
             <a:endParaRPr lang="en-US" sz="1020" dirty="0"/>
           </a:p>
@@ -14380,7 +14380,7 @@
                 <a:ea typeface="Aptos" pitchFamily="34" charset="-122"/>
                 <a:cs typeface="Aptos" pitchFamily="34" charset="-120"/>
               </a:rPr>
-              <a:t>clean audited repo</a:t>
+              <a:t>published closure</a:t>
             </a:r>
             <a:endParaRPr lang="en-US" sz="1020" dirty="0"/>
           </a:p>
@@ -14973,7 +14973,7 @@
                 <a:ea typeface="Aptos" pitchFamily="34" charset="-122"/>
                 <a:cs typeface="Aptos" pitchFamily="34" charset="-120"/>
               </a:rPr>
-              <a:t>Status: implemented and validated on bounded accepted workloads.</a:t>
+              <a:t>Status: mature performance backend on the accepted long `county_zipcode` PIP surface.</a:t>
             </a:r>
             <a:endParaRPr lang="en-US" sz="1080" dirty="0"/>
           </a:p>
@@ -15041,7 +15041,7 @@
                 <a:ea typeface="Aptos Display" pitchFamily="34" charset="-122"/>
                 <a:cs typeface="Aptos Display" pitchFamily="34" charset="-120"/>
               </a:rPr>
-              <a:t>Future Mac GPU</a:t>
+              <a:t>Vulkan</a:t>
             </a:r>
             <a:endParaRPr lang="en-US" sz="1400" dirty="0"/>
           </a:p>
@@ -15080,7 +15080,7 @@
                 <a:ea typeface="Aptos" pitchFamily="34" charset="-122"/>
                 <a:cs typeface="Aptos" pitchFamily="34" charset="-120"/>
               </a:rPr>
-              <a:t>Vulkan KHR path is in-repo, parity-clean on the accepted bounded Linux surface, and still provisional beyond that.</a:t>
+              <a:t>Portable GPU backend.</a:t>
             </a:r>
             <a:endParaRPr lang="en-US" sz="1080" dirty="0"/>
           </a:p>
@@ -15103,7 +15103,7 @@
                 <a:ea typeface="Aptos" pitchFamily="34" charset="-122"/>
                 <a:cs typeface="Aptos" pitchFamily="34" charset="-120"/>
               </a:rPr>
-              <a:t>Apple/Metal work is still future.</a:t>
+              <a:t>Status: hardware-validated, parity-clean on the flagship row, but slower than PostGIS.</a:t>
             </a:r>
             <a:endParaRPr lang="en-US" sz="1080" dirty="0"/>
           </a:p>
@@ -15164,7 +15164,7 @@
                 <a:ea typeface="Aptos" pitchFamily="34" charset="-122"/>
                 <a:cs typeface="Aptos" pitchFamily="34" charset="-120"/>
               </a:rPr>
-              <a:t>Embree is the strongest validated backend today.</a:t>
+              <a:t>Embree is the strongest validated CPU backend today.</a:t>
             </a:r>
             <a:pPr indent="0" marL="0">
               <a:buNone/>
@@ -15185,7 +15185,7 @@
                 <a:ea typeface="Aptos" pitchFamily="34" charset="-122"/>
                 <a:cs typeface="Aptos" pitchFamily="34" charset="-120"/>
               </a:rPr>
-              <a:t>OptiX is real and correctness-checked on bounded real-data workloads.</a:t>
+              <a:t>OptiX is a mature GPU backend on the accepted flagship row.</a:t>
             </a:r>
             <a:pPr indent="0" marL="0">
               <a:buNone/>
@@ -15206,7 +15206,7 @@
                 <a:ea typeface="Aptos" pitchFamily="34" charset="-122"/>
                 <a:cs typeface="Aptos" pitchFamily="34" charset="-120"/>
               </a:rPr>
-              <a:t>Vulkan is now correctness-closed on the accepted bounded Linux surface, but it is not yet an equally mature large-scale backend.</a:t>
+              <a:t>Vulkan is a supported but slower backend, not a provisional placeholder.</a:t>
             </a:r>
             <a:pPr indent="0" marL="0">
               <a:buNone/>

</xml_diff>